<commit_message>
feat: expand rnn slides to 9 with per-function/per-formula detail, add speaker script, fix knowledge doc errors
</commit_message>
<xml_diff>
--- a/asm06/slides/rnn.pptx
+++ b/asm06/slides/rnn.pptx
@@ -12,6 +12,8 @@
     <p:sldId id="260" r:id="rId12"/>
     <p:sldId id="261" r:id="rId13"/>
     <p:sldId id="262" r:id="rId14"/>
+    <p:sldId id="263" r:id="rId15"/>
+    <p:sldId id="264" r:id="rId16"/>
   </p:sldIdLst>
   <p:sldSz cx="12193200" cy="6858000" type="screen4x3"/>
   <p:notesSz cx="6858000" cy="9144000"/>
@@ -508,7 +510,7 @@
           <a:lstStyle/>
           <a:p>
             <a:r>
-              <a:t>Slide 1/7 — Dữ liệu chuỗi có thứ tự; mạng thường không nhớ → cần RNN. Code: cắt chuỗi thành cửa sổ 30 ngày</a:t>
+              <a:t>Slide 1/9 — Dữ liệu chuỗi có thứ tự; mạng thường không nhớ → cần RNN. Hàm make_windows cắt cửa sổ 30 ngày</a:t>
             </a:r>
           </a:p>
         </p:txBody>
@@ -578,7 +580,7 @@
           <a:lstStyle/>
           <a:p>
             <a:r>
-              <a:t>Slide 2/7 — h_t là trí nhớ; lặp cùng trọng số qua từng thời điểm. Code: rnn_cell + vòng lặp</a:t>
+              <a:t>Slide 2/9 — h_t là trí nhớ; lặp CÙNG trọng số qua từng thời điểm. Hàm rnn_cell = 1 bước, comment từng dòng</a:t>
             </a:r>
           </a:p>
         </p:txBody>
@@ -648,7 +650,7 @@
           <a:lstStyle/>
           <a:p>
             <a:r>
-              <a:t>Slide 3/7 — Công thức trung tâm + vai trò 3 ma trận. Code: định nghĩa model PyTorch/Keras</a:t>
+              <a:t>Slide 3/9 — Công thức trung tâm + vai trò 3 ma trận + tên gọi tương ứng trong PyTorch/Keras</a:t>
             </a:r>
           </a:p>
         </p:txBody>
@@ -718,7 +720,7 @@
           <a:lstStyle/>
           <a:p>
             <a:r>
-              <a:t>Slide 4/7 — Ví dụ số nhỏ chạy tay 1 bước — code numpy sinh đúng các số trong bảng</a:t>
+              <a:t>Slide 4/9 — Ví dụ số nhỏ chạy tay 1 bước — 4 dòng trong bảng = 4 phép tính, code sinh đúng số đó</a:t>
             </a:r>
           </a:p>
         </p:txBody>
@@ -788,7 +790,7 @@
           <a:lstStyle/>
           <a:p>
             <a:r>
-              <a:t>Slide 5/7 — BPTT điều chỉnh W/U/V ngược theo thời gian; gradient suy giảm khi chuỗi dài. Code: vòng lặp train</a:t>
+              <a:t>Slide 5/9 — 4 hàm tiền xử lý: load+sort → chia chrono → MinMax fit train → make_windows + guard ±3σ</a:t>
             </a:r>
           </a:p>
         </p:txBody>
@@ -858,7 +860,7 @@
           <a:lstStyle/>
           <a:p>
             <a:r>
-              <a:t>Slide 6/7 — Pipeline đầy đủ trên 2 tập dữ liệu thật + kết quả RMSE so với naive</a:t>
+              <a:t>Slide 6/9 — BPTT: gradient chảy ngược thời gian, mỗi bước nhân thêm U^T·diag(1−tanh²) → ‖U‖&lt;1 biến mất, &gt;1 bùng nổ</a:t>
             </a:r>
           </a:p>
         </p:txBody>
@@ -928,7 +930,147 @@
           <a:lstStyle/>
           <a:p>
             <a:r>
-              <a:t>Slide 7/7 — RNN quên dài hạn → LSTM thêm cổng, GRU bản gọn. Code: đổi 1 dòng</a:t>
+              <a:t>Slide 7/9 — Vòng lặp huấn luyện notebook 01 — từng lệnh đánh số ①→⑧; phải: bảng vai trò từng lệnh</a:t>
+            </a:r>
+          </a:p>
+        </p:txBody>
+      </p:sp>
+      <p:sp>
+        <p:nvSpPr>
+          <p:cNvPr id="4" name="Slide Number Placeholder 3"/>
+          <p:cNvSpPr>
+            <a:spLocks noGrp="1"/>
+          </p:cNvSpPr>
+          <p:nvPr>
+            <p:ph type="sldNum" idx="5" sz="quarter"/>
+          </p:nvPr>
+        </p:nvSpPr>
+        <p:spPr/>
+      </p:sp>
+    </p:spTree>
+  </p:cSld>
+  <p:clrMapOvr>
+    <a:masterClrMapping/>
+  </p:clrMapOvr>
+</p:notes>
+</file>
+
+<file path=ppt/notesSlides/notesSlide8.xml><?xml version="1.0" encoding="utf-8"?>
+<p:notes xmlns:a="http://schemas.openxmlformats.org/drawingml/2006/main" xmlns:p="http://schemas.openxmlformats.org/presentationml/2006/main" xmlns:r="http://schemas.openxmlformats.org/officeDocument/2006/relationships">
+  <p:cSld>
+    <p:spTree>
+      <p:nvGrpSpPr>
+        <p:cNvPr id="1" name=""/>
+        <p:cNvGrpSpPr/>
+        <p:nvPr/>
+      </p:nvGrpSpPr>
+      <p:grpSpPr>
+        <a:xfrm>
+          <a:off x="0" y="0"/>
+          <a:ext cx="0" cy="0"/>
+          <a:chOff x="0" y="0"/>
+          <a:chExt cx="0" cy="0"/>
+        </a:xfrm>
+      </p:grpSpPr>
+      <p:sp>
+        <p:nvSpPr>
+          <p:cNvPr id="2" name="Slide Image Placeholder 1"/>
+          <p:cNvSpPr>
+            <a:spLocks noGrp="1"/>
+          </p:cNvSpPr>
+          <p:nvPr>
+            <p:ph type="sldImg" idx="2"/>
+          </p:nvPr>
+        </p:nvSpPr>
+        <p:spPr/>
+      </p:sp>
+      <p:sp>
+        <p:nvSpPr>
+          <p:cNvPr id="3" name="Notes Placeholder 2"/>
+          <p:cNvSpPr>
+            <a:spLocks noGrp="1"/>
+          </p:cNvSpPr>
+          <p:nvPr>
+            <p:ph type="body" idx="3" sz="quarter"/>
+          </p:nvPr>
+        </p:nvSpPr>
+        <p:spPr/>
+        <p:txBody>
+          <a:bodyPr/>
+          <a:lstStyle/>
+          <a:p>
+            <a:r>
+              <a:t>Slide 8/9 — Dự báo Δ residual (giá mai = giá nay + Δ̂, guard ±3σ) thắng naive trên cả 2 tập</a:t>
+            </a:r>
+          </a:p>
+        </p:txBody>
+      </p:sp>
+      <p:sp>
+        <p:nvSpPr>
+          <p:cNvPr id="4" name="Slide Number Placeholder 3"/>
+          <p:cNvSpPr>
+            <a:spLocks noGrp="1"/>
+          </p:cNvSpPr>
+          <p:nvPr>
+            <p:ph type="sldNum" idx="5" sz="quarter"/>
+          </p:nvPr>
+        </p:nvSpPr>
+        <p:spPr/>
+      </p:sp>
+    </p:spTree>
+  </p:cSld>
+  <p:clrMapOvr>
+    <a:masterClrMapping/>
+  </p:clrMapOvr>
+</p:notes>
+</file>
+
+<file path=ppt/notesSlides/notesSlide9.xml><?xml version="1.0" encoding="utf-8"?>
+<p:notes xmlns:a="http://schemas.openxmlformats.org/drawingml/2006/main" xmlns:p="http://schemas.openxmlformats.org/presentationml/2006/main" xmlns:r="http://schemas.openxmlformats.org/officeDocument/2006/relationships">
+  <p:cSld>
+    <p:spTree>
+      <p:nvGrpSpPr>
+        <p:cNvPr id="1" name=""/>
+        <p:cNvGrpSpPr/>
+        <p:nvPr/>
+      </p:nvGrpSpPr>
+      <p:grpSpPr>
+        <a:xfrm>
+          <a:off x="0" y="0"/>
+          <a:ext cx="0" cy="0"/>
+          <a:chOff x="0" y="0"/>
+          <a:chExt cx="0" cy="0"/>
+        </a:xfrm>
+      </p:grpSpPr>
+      <p:sp>
+        <p:nvSpPr>
+          <p:cNvPr id="2" name="Slide Image Placeholder 1"/>
+          <p:cNvSpPr>
+            <a:spLocks noGrp="1"/>
+          </p:cNvSpPr>
+          <p:nvPr>
+            <p:ph type="sldImg" idx="2"/>
+          </p:nvPr>
+        </p:nvSpPr>
+        <p:spPr/>
+      </p:sp>
+      <p:sp>
+        <p:nvSpPr>
+          <p:cNvPr id="3" name="Notes Placeholder 2"/>
+          <p:cNvSpPr>
+            <a:spLocks noGrp="1"/>
+          </p:cNvSpPr>
+          <p:nvPr>
+            <p:ph type="body" idx="3" sz="quarter"/>
+          </p:nvPr>
+        </p:nvSpPr>
+        <p:spPr/>
+        <p:txBody>
+          <a:bodyPr/>
+          <a:lstStyle/>
+          <a:p>
+            <a:r>
+              <a:t>Slide 9/9 — LSTM 5 cổng + băng chuyền c_t (gradient qua phép CỘNG); GRU bản gọn 2 cổng; đổi 1 dòng code</a:t>
             </a:r>
           </a:p>
         </p:txBody>
@@ -4197,7 +4339,7 @@
         <p:spPr>
           <a:xfrm>
             <a:off x="7343999" y="1368000"/>
-            <a:ext cx="4428000" cy="2951999"/>
+            <a:ext cx="4428000" cy="3240000"/>
           </a:xfrm>
           <a:prstGeom prst="rect">
             <a:avLst/>
@@ -4236,7 +4378,7 @@
                 </a:solidFill>
                 <a:latin typeface="Consolas"/>
               </a:rPr>
-              <a:t># dữ liệu chuỗi → cắt thành cửa sổ</a:t>
+              <a:t># hàm 1 — cắt chuỗi thành cửa sổ</a:t>
             </a:r>
           </a:p>
           <a:p>
@@ -4247,7 +4389,7 @@
                 </a:solidFill>
                 <a:latin typeface="Consolas"/>
               </a:rPr>
-              <a:t># 30 ngày liên tiếp (notebook 03 thật)</a:t>
+              <a:t># (notebook 03, code thật)</a:t>
             </a:r>
           </a:p>
           <a:p>
@@ -4280,7 +4422,7 @@
                 </a:solidFill>
                 <a:latin typeface="Consolas"/>
               </a:rPr>
-              <a:t>        for i in range(len(arr)-L)])</a:t>
+              <a:t>      for i in range(len(arr)-L)])</a:t>
             </a:r>
           </a:p>
           <a:p>
@@ -4291,6 +4433,17 @@
                 </a:solidFill>
                 <a:latin typeface="Consolas"/>
               </a:rPr>
+              <a:t>    # mỗi mẫu = 30 ngày liên tiếp</a:t>
+            </a:r>
+          </a:p>
+          <a:p>
+            <a:r>
+              <a:rPr sz="1200">
+                <a:solidFill>
+                  <a:srgbClr val="222222"/>
+                </a:solidFill>
+                <a:latin typeface="Consolas"/>
+              </a:rPr>
               <a:t>    y = arr[L:, 0] - arr[L-1:-1, 0]</a:t>
             </a:r>
           </a:p>
@@ -4302,6 +4455,17 @@
                 </a:solidFill>
                 <a:latin typeface="Consolas"/>
               </a:rPr>
+              <a:t>    # nhãn = Δ giá của NGÀY KẾ</a:t>
+            </a:r>
+          </a:p>
+          <a:p>
+            <a:r>
+              <a:rPr sz="1200">
+                <a:solidFill>
+                  <a:srgbClr val="222222"/>
+                </a:solidFill>
+                <a:latin typeface="Consolas"/>
+              </a:rPr>
               <a:t>    return X, y</a:t>
             </a:r>
           </a:p>
@@ -4335,7 +4499,7 @@
                 </a:solidFill>
                 <a:latin typeface="Consolas"/>
               </a:rPr>
-              <a:t>y.shape  # (N,) — biến thiên giá ngày kế</a:t>
+              <a:t>y.shape  # (N,) — biết hôm nay, đoán biến thiên mai</a:t>
             </a:r>
           </a:p>
         </p:txBody>
@@ -4523,8 +4687,8 @@
         </p:blipFill>
         <p:spPr>
           <a:xfrm>
-            <a:off x="432000" y="2664000"/>
-            <a:ext cx="6263999" cy="2458336"/>
+            <a:off x="432000" y="2592000"/>
+            <a:ext cx="6120000" cy="2401822"/>
           </a:xfrm>
           <a:prstGeom prst="rect">
             <a:avLst/>
@@ -4539,8 +4703,8 @@
         </p:nvSpPr>
         <p:spPr>
           <a:xfrm>
-            <a:off x="7020000" y="2736000"/>
-            <a:ext cx="4752000" cy="2736000"/>
+            <a:off x="6803999" y="2592000"/>
+            <a:ext cx="4968000" cy="3096000"/>
           </a:xfrm>
           <a:prstGeom prst="rect">
             <a:avLst/>
@@ -4573,18 +4737,18 @@
           <a:p>
             <a:pPr algn="ctr"/>
             <a:r>
-              <a:rPr sz="1250">
-                <a:solidFill>
-                  <a:srgbClr val="222222"/>
-                </a:solidFill>
-                <a:latin typeface="Consolas"/>
-              </a:rPr>
-              <a:t># một bước RNN (notebook 00 — numpy thuần)</a:t>
-            </a:r>
-          </a:p>
-          <a:p>
-            <a:r>
-              <a:rPr sz="1250">
+              <a:rPr sz="1200">
+                <a:solidFill>
+                  <a:srgbClr val="222222"/>
+                </a:solidFill>
+                <a:latin typeface="Consolas"/>
+              </a:rPr>
+              <a:t># hàm 2 — MỘT bước RNN (numpy thuần, nb 00)</a:t>
+            </a:r>
+          </a:p>
+          <a:p>
+            <a:r>
+              <a:rPr sz="1200">
                 <a:solidFill>
                   <a:srgbClr val="222222"/>
                 </a:solidFill>
@@ -4595,7 +4759,7 @@
           </a:p>
           <a:p>
             <a:r>
-              <a:rPr sz="1250">
+              <a:rPr sz="1200">
                 <a:solidFill>
                   <a:srgbClr val="222222"/>
                 </a:solidFill>
@@ -4606,7 +4770,40 @@
           </a:p>
           <a:p>
             <a:r>
-              <a:rPr sz="1250">
+              <a:rPr sz="1200">
+                <a:solidFill>
+                  <a:srgbClr val="222222"/>
+                </a:solidFill>
+                <a:latin typeface="Consolas"/>
+              </a:rPr>
+              <a:t>    # W @ x_t   : đọc tín hiệu MỚI hôm nay</a:t>
+            </a:r>
+          </a:p>
+          <a:p>
+            <a:r>
+              <a:rPr sz="1200">
+                <a:solidFill>
+                  <a:srgbClr val="222222"/>
+                </a:solidFill>
+                <a:latin typeface="Consolas"/>
+              </a:rPr>
+              <a:t>    # U @ h_prev: mở TRÍ NHỚ hôm qua</a:t>
+            </a:r>
+          </a:p>
+          <a:p>
+            <a:r>
+              <a:rPr sz="1200">
+                <a:solidFill>
+                  <a:srgbClr val="222222"/>
+                </a:solidFill>
+                <a:latin typeface="Consolas"/>
+              </a:rPr>
+              <a:t>    # b_h       : thiên lệch</a:t>
+            </a:r>
+          </a:p>
+          <a:p>
+            <a:r>
+              <a:rPr sz="1200">
                 <a:solidFill>
                   <a:srgbClr val="222222"/>
                 </a:solidFill>
@@ -4617,7 +4814,18 @@
           </a:p>
           <a:p>
             <a:r>
-              <a:rPr sz="1250">
+              <a:rPr sz="1200">
+                <a:solidFill>
+                  <a:srgbClr val="222222"/>
+                </a:solidFill>
+                <a:latin typeface="Consolas"/>
+              </a:rPr>
+              <a:t>    # tanh nén về (−1, 1) — giữ số ổn định</a:t>
+            </a:r>
+          </a:p>
+          <a:p>
+            <a:r>
+              <a:rPr sz="1200">
                 <a:solidFill>
                   <a:srgbClr val="222222"/>
                 </a:solidFill>
@@ -4628,35 +4836,46 @@
           </a:p>
           <a:p>
             <a:r>
-              <a:rPr sz="1250">
-                <a:solidFill>
-                  <a:srgbClr val="222222"/>
-                </a:solidFill>
-                <a:latin typeface="Consolas"/>
-              </a:rPr>
-              <a:t>h = np.zeros(d_h)              # h_0 = 0</a:t>
-            </a:r>
-          </a:p>
-          <a:p>
-            <a:r>
-              <a:rPr sz="1250">
-                <a:solidFill>
-                  <a:srgbClr val="222222"/>
-                </a:solidFill>
-                <a:latin typeface="Consolas"/>
-              </a:rPr>
-              <a:t>for t in range(T):             # lặp từng ngày</a:t>
-            </a:r>
-          </a:p>
-          <a:p>
-            <a:r>
-              <a:rPr sz="1250">
+              <a:rPr sz="1200">
+                <a:solidFill>
+                  <a:srgbClr val="222222"/>
+                </a:solidFill>
+                <a:latin typeface="Consolas"/>
+              </a:rPr>
+              <a:t>h = np.zeros(d_h)          # h_0 = 0 — chưa biết gì</a:t>
+            </a:r>
+          </a:p>
+          <a:p>
+            <a:r>
+              <a:rPr sz="1200">
+                <a:solidFill>
+                  <a:srgbClr val="222222"/>
+                </a:solidFill>
+                <a:latin typeface="Consolas"/>
+              </a:rPr>
+              <a:t>for t in range(T):         # lặp CÙNG 1 cell</a:t>
+            </a:r>
+          </a:p>
+          <a:p>
+            <a:r>
+              <a:rPr sz="1200">
                 <a:solidFill>
                   <a:srgbClr val="222222"/>
                 </a:solidFill>
                 <a:latin typeface="Consolas"/>
               </a:rPr>
               <a:t>    h = rnn_cell(x[t], h, W, U, b_h)</a:t>
+            </a:r>
+          </a:p>
+          <a:p>
+            <a:r>
+              <a:rPr sz="1200">
+                <a:solidFill>
+                  <a:srgbClr val="222222"/>
+                </a:solidFill>
+                <a:latin typeface="Consolas"/>
+              </a:rPr>
+              <a:t>y = V @ h + b_y            # đọc trí nhớ cuối → dự đoán</a:t>
             </a:r>
           </a:p>
         </p:txBody>
@@ -5192,7 +5411,7 @@
         <p:spPr>
           <a:xfrm>
             <a:off x="7416000" y="2232000"/>
-            <a:ext cx="4356000" cy="3096000"/>
+            <a:ext cx="4356000" cy="3240000"/>
           </a:xfrm>
           <a:prstGeom prst="rect">
             <a:avLst/>
@@ -5225,18 +5444,18 @@
           <a:p>
             <a:pPr algn="ctr"/>
             <a:r>
-              <a:rPr sz="1200">
-                <a:solidFill>
-                  <a:srgbClr val="222222"/>
-                </a:solidFill>
-                <a:latin typeface="Consolas"/>
-              </a:rPr>
-              <a:t># PyTorch (notebook 01)</a:t>
-            </a:r>
-          </a:p>
-          <a:p>
-            <a:r>
-              <a:rPr sz="1200">
+              <a:rPr sz="1150">
+                <a:solidFill>
+                  <a:srgbClr val="222222"/>
+                </a:solidFill>
+                <a:latin typeface="Consolas"/>
+              </a:rPr>
+              <a:t># PyTorch (nb 01) — định nghĩa</a:t>
+            </a:r>
+          </a:p>
+          <a:p>
+            <a:r>
+              <a:rPr sz="1150">
                 <a:solidFill>
                   <a:srgbClr val="222222"/>
                 </a:solidFill>
@@ -5247,7 +5466,7 @@
           </a:p>
           <a:p>
             <a:r>
-              <a:rPr sz="1200">
+              <a:rPr sz="1150">
                 <a:solidFill>
                   <a:srgbClr val="222222"/>
                 </a:solidFill>
@@ -5258,40 +5477,40 @@
           </a:p>
           <a:p>
             <a:r>
-              <a:rPr sz="1200">
-                <a:solidFill>
-                  <a:srgbClr val="222222"/>
-                </a:solidFill>
-                <a:latin typeface="Consolas"/>
-              </a:rPr>
-              <a:t># weight_ih_l0 = W (64×2)</a:t>
-            </a:r>
-          </a:p>
-          <a:p>
-            <a:r>
-              <a:rPr sz="1200">
-                <a:solidFill>
-                  <a:srgbClr val="222222"/>
-                </a:solidFill>
-                <a:latin typeface="Consolas"/>
-              </a:rPr>
-              <a:t># weight_hh_l0 = U (64×64)</a:t>
-            </a:r>
-          </a:p>
-          <a:p>
-            <a:r>
-              <a:rPr sz="1200">
-                <a:solidFill>
-                  <a:srgbClr val="222222"/>
-                </a:solidFill>
-                <a:latin typeface="Consolas"/>
-              </a:rPr>
-              <a:t># fc.weight    = V (1×64)</a:t>
-            </a:r>
-          </a:p>
-          <a:p>
-            <a:r>
-              <a:rPr sz="1200">
+              <a:rPr sz="1150">
+                <a:solidFill>
+                  <a:srgbClr val="222222"/>
+                </a:solidFill>
+                <a:latin typeface="Consolas"/>
+              </a:rPr>
+              <a:t># weight_ih_l0 = W  (64×2)</a:t>
+            </a:r>
+          </a:p>
+          <a:p>
+            <a:r>
+              <a:rPr sz="1150">
+                <a:solidFill>
+                  <a:srgbClr val="222222"/>
+                </a:solidFill>
+                <a:latin typeface="Consolas"/>
+              </a:rPr>
+              <a:t># weight_hh_l0 = U  (64×64)</a:t>
+            </a:r>
+          </a:p>
+          <a:p>
+            <a:r>
+              <a:rPr sz="1150">
+                <a:solidFill>
+                  <a:srgbClr val="222222"/>
+                </a:solidFill>
+                <a:latin typeface="Consolas"/>
+              </a:rPr>
+              <a:t># fc.weight    = V  (1×64)</a:t>
+            </a:r>
+          </a:p>
+          <a:p>
+            <a:r>
+              <a:rPr sz="1150">
                 <a:solidFill>
                   <a:srgbClr val="222222"/>
                 </a:solidFill>
@@ -5302,18 +5521,51 @@
           </a:p>
           <a:p>
             <a:r>
-              <a:rPr sz="1200">
-                <a:solidFill>
-                  <a:srgbClr val="222222"/>
-                </a:solidFill>
-                <a:latin typeface="Consolas"/>
-              </a:rPr>
-              <a:t># Keras (notebook 02)</a:t>
-            </a:r>
-          </a:p>
-          <a:p>
-            <a:r>
-              <a:rPr sz="1200">
+              <a:rPr sz="1150">
+                <a:solidFill>
+                  <a:srgbClr val="222222"/>
+                </a:solidFill>
+                <a:latin typeface="Consolas"/>
+              </a:rPr>
+              <a:t>out, h_n = rnn(Xb)     # truyền TRỌN chuỗi</a:t>
+            </a:r>
+          </a:p>
+          <a:p>
+            <a:r>
+              <a:rPr sz="1150">
+                <a:solidFill>
+                  <a:srgbClr val="222222"/>
+                </a:solidFill>
+                <a:latin typeface="Consolas"/>
+              </a:rPr>
+              <a:t>y = fc(out[:, -1])     # chỉ đọc ngày CUỐI</a:t>
+            </a:r>
+          </a:p>
+          <a:p>
+            <a:r>
+              <a:rPr sz="1150">
+                <a:solidFill>
+                  <a:srgbClr val="222222"/>
+                </a:solidFill>
+                <a:latin typeface="Consolas"/>
+              </a:rPr>
+              <a:t/>
+            </a:r>
+          </a:p>
+          <a:p>
+            <a:r>
+              <a:rPr sz="1150">
+                <a:solidFill>
+                  <a:srgbClr val="222222"/>
+                </a:solidFill>
+                <a:latin typeface="Consolas"/>
+              </a:rPr>
+              <a:t># Keras (nb 02)</a:t>
+            </a:r>
+          </a:p>
+          <a:p>
+            <a:r>
+              <a:rPr sz="1150">
                 <a:solidFill>
                   <a:srgbClr val="222222"/>
                 </a:solidFill>
@@ -5324,7 +5576,7 @@
           </a:p>
           <a:p>
             <a:r>
-              <a:rPr sz="1200">
+              <a:rPr sz="1150">
                 <a:solidFill>
                   <a:srgbClr val="222222"/>
                 </a:solidFill>
@@ -5828,7 +6080,7 @@
         <p:spPr>
           <a:xfrm>
             <a:off x="7416000" y="1368000"/>
-            <a:ext cx="4356000" cy="2376000"/>
+            <a:ext cx="4356000" cy="2520000"/>
           </a:xfrm>
           <a:prstGeom prst="rect">
             <a:avLst/>
@@ -5867,7 +6119,7 @@
                 </a:solidFill>
                 <a:latin typeface="Consolas"/>
               </a:rPr>
-              <a:t># đúng các số trong bảng bên trái</a:t>
+              <a:t># sinh đúng các số trong bảng trái</a:t>
             </a:r>
           </a:p>
           <a:p>
@@ -5966,18 +6218,18 @@
                 </a:solidFill>
                 <a:latin typeface="Consolas"/>
               </a:rPr>
-              <a:t>h1 = np.tanh(W @ x1 + U @ h0)</a:t>
-            </a:r>
-          </a:p>
-          <a:p>
-            <a:r>
-              <a:rPr sz="1150">
-                <a:solidFill>
-                  <a:srgbClr val="222222"/>
-                </a:solidFill>
-                <a:latin typeface="Consolas"/>
-              </a:rPr>
-              <a:t>y1 = V @ h1</a:t>
+              <a:t>h1 = np.tanh(W @ x1 + U @ h0)  # bước 3</a:t>
+            </a:r>
+          </a:p>
+          <a:p>
+            <a:r>
+              <a:rPr sz="1150">
+                <a:solidFill>
+                  <a:srgbClr val="222222"/>
+                </a:solidFill>
+                <a:latin typeface="Consolas"/>
+              </a:rPr>
+              <a:t>y1 = V @ h1                    # bước 4</a:t>
             </a:r>
           </a:p>
         </p:txBody>
@@ -6121,7 +6373,7 @@
                 </a:solidFill>
                 <a:latin typeface="Calibri"/>
               </a:rPr>
-              <a:t>5. Huấn luyện: lan truyền ngược qua thời gian (BPTT)</a:t>
+              <a:t>5. Chuẩn bị dữ liệu: từng hàm trong pipeline</a:t>
             </a:r>
           </a:p>
         </p:txBody>
@@ -6134,8 +6386,8 @@
         </p:nvSpPr>
         <p:spPr>
           <a:xfrm>
-            <a:off x="432000" y="1188000"/>
-            <a:ext cx="6983999" cy="486000"/>
+            <a:off x="432000" y="1224000"/>
+            <a:ext cx="5400000" cy="360000"/>
           </a:xfrm>
           <a:prstGeom prst="rect">
             <a:avLst/>
@@ -6150,13 +6402,13 @@
           <a:p>
             <a:pPr algn="l"/>
             <a:r>
-              <a:rPr sz="1700" b="0">
-                <a:solidFill>
-                  <a:srgbClr val="222222"/>
+              <a:rPr sz="1500" b="1">
+                <a:solidFill>
+                  <a:srgbClr val="1E3A8A"/>
                 </a:solidFill>
                 <a:latin typeface="Calibri"/>
               </a:rPr>
-              <a:t>•  Dự đoán sai → tính loss → điều chỉnh W, U, V theo thời gian NGƯỢC từ cuối chuỗi về đầu</a:t>
+              <a:t>① Chia chronological 70/15/15</a:t>
             </a:r>
           </a:p>
         </p:txBody>
@@ -6169,8 +6421,8 @@
         </p:nvSpPr>
         <p:spPr>
           <a:xfrm>
-            <a:off x="432000" y="1674000"/>
-            <a:ext cx="6983999" cy="486000"/>
+            <a:off x="432000" y="1584000"/>
+            <a:ext cx="5400000" cy="648000"/>
           </a:xfrm>
           <a:prstGeom prst="rect">
             <a:avLst/>
@@ -6185,13 +6437,13 @@
           <a:p>
             <a:pPr algn="l"/>
             <a:r>
-              <a:rPr sz="1700" b="1">
+              <a:rPr sz="1250" b="0">
                 <a:solidFill>
                   <a:srgbClr val="222222"/>
                 </a:solidFill>
                 <a:latin typeface="Calibri"/>
               </a:rPr>
-              <a:t>Chuỗi dài → gradient suy giảm nhanh: mạng khó học quá khứ XA</a:t>
+              <a:t>train_df = df.iloc[:n_train] — cắt THEO THỜI GIAN, không xáo trộn. Xáo trộn cho mẫu tương lai lọt vào train → rò rỉ dữ liệu.</a:t>
             </a:r>
           </a:p>
         </p:txBody>
@@ -6204,8 +6456,8 @@
         </p:nvSpPr>
         <p:spPr>
           <a:xfrm>
-            <a:off x="432000" y="2160000"/>
-            <a:ext cx="6983999" cy="486000"/>
+            <a:off x="432000" y="2358000"/>
+            <a:ext cx="5400000" cy="360000"/>
           </a:xfrm>
           <a:prstGeom prst="rect">
             <a:avLst/>
@@ -6220,27 +6472,202 @@
           <a:p>
             <a:pPr algn="l"/>
             <a:r>
-              <a:rPr sz="1700" b="0">
-                <a:solidFill>
-                  <a:srgbClr val="222222"/>
+              <a:rPr sz="1500" b="1">
+                <a:solidFill>
+                  <a:srgbClr val="1E3A8A"/>
                 </a:solidFill>
                 <a:latin typeface="Calibri"/>
               </a:rPr>
-              <a:t>•  Khắc phục: cắt gradient (clipping) và dùng LSTM / GRU</a:t>
-            </a:r>
-          </a:p>
-        </p:txBody>
-      </p:sp>
-      <p:sp>
-        <p:nvSpPr>
-          <p:cNvPr id="7" name="Rectangle 6"/>
+              <a:t>② MinMaxScaler().fit(train_df)</a:t>
+            </a:r>
+          </a:p>
+        </p:txBody>
+      </p:sp>
+      <p:sp>
+        <p:nvSpPr>
+          <p:cNvPr id="7" name="TextBox 6"/>
+          <p:cNvSpPr txBox="1"/>
+          <p:nvPr/>
+        </p:nvSpPr>
+        <p:spPr>
+          <a:xfrm>
+            <a:off x="432000" y="2718000"/>
+            <a:ext cx="5400000" cy="648000"/>
+          </a:xfrm>
+          <a:prstGeom prst="rect">
+            <a:avLst/>
+          </a:prstGeom>
+          <a:noFill/>
+        </p:spPr>
+        <p:txBody>
+          <a:bodyPr wrap="square">
+            <a:spAutoFit/>
+          </a:bodyPr>
+          <a:lstStyle/>
+          <a:p>
+            <a:pPr algn="l"/>
+            <a:r>
+              <a:rPr sz="1250" b="0">
+                <a:solidFill>
+                  <a:srgbClr val="222222"/>
+                </a:solidFill>
+                <a:latin typeface="Calibri"/>
+              </a:rPr>
+              <a:t>Chuẩn hoá z = (x − min)/(max − min) ∈ [0,1]. CHỈ fit trên tập train — nếu fit cả chuỗi, min/max của tương lai bị lộ cho model.</a:t>
+            </a:r>
+          </a:p>
+        </p:txBody>
+      </p:sp>
+      <p:sp>
+        <p:nvSpPr>
+          <p:cNvPr id="8" name="TextBox 7"/>
+          <p:cNvSpPr txBox="1"/>
+          <p:nvPr/>
+        </p:nvSpPr>
+        <p:spPr>
+          <a:xfrm>
+            <a:off x="432000" y="3492000"/>
+            <a:ext cx="5400000" cy="360000"/>
+          </a:xfrm>
+          <a:prstGeom prst="rect">
+            <a:avLst/>
+          </a:prstGeom>
+          <a:noFill/>
+        </p:spPr>
+        <p:txBody>
+          <a:bodyPr wrap="square">
+            <a:spAutoFit/>
+          </a:bodyPr>
+          <a:lstStyle/>
+          <a:p>
+            <a:pPr algn="l"/>
+            <a:r>
+              <a:rPr sz="1500" b="1">
+                <a:solidFill>
+                  <a:srgbClr val="1E3A8A"/>
+                </a:solidFill>
+                <a:latin typeface="Calibri"/>
+              </a:rPr>
+              <a:t>③ make_windows(z, L=30)</a:t>
+            </a:r>
+          </a:p>
+        </p:txBody>
+      </p:sp>
+      <p:sp>
+        <p:nvSpPr>
+          <p:cNvPr id="9" name="TextBox 8"/>
+          <p:cNvSpPr txBox="1"/>
+          <p:nvPr/>
+        </p:nvSpPr>
+        <p:spPr>
+          <a:xfrm>
+            <a:off x="432000" y="3852000"/>
+            <a:ext cx="5400000" cy="648000"/>
+          </a:xfrm>
+          <a:prstGeom prst="rect">
+            <a:avLst/>
+          </a:prstGeom>
+          <a:noFill/>
+        </p:spPr>
+        <p:txBody>
+          <a:bodyPr wrap="square">
+            <a:spAutoFit/>
+          </a:bodyPr>
+          <a:lstStyle/>
+          <a:p>
+            <a:pPr algn="l"/>
+            <a:r>
+              <a:rPr sz="1250" b="0">
+                <a:solidFill>
+                  <a:srgbClr val="222222"/>
+                </a:solidFill>
+                <a:latin typeface="Calibri"/>
+              </a:rPr>
+              <a:t>Cửa sổ trượt: X_i = 30 ngày × 2 đặc trưng (vàng+bạc), nhãn y_i = Δ vàng scaled của ngày kế tiếp.</a:t>
+            </a:r>
+          </a:p>
+        </p:txBody>
+      </p:sp>
+      <p:sp>
+        <p:nvSpPr>
+          <p:cNvPr id="10" name="TextBox 9"/>
+          <p:cNvSpPr txBox="1"/>
+          <p:nvPr/>
+        </p:nvSpPr>
+        <p:spPr>
+          <a:xfrm>
+            <a:off x="432000" y="4626000"/>
+            <a:ext cx="5400000" cy="360000"/>
+          </a:xfrm>
+          <a:prstGeom prst="rect">
+            <a:avLst/>
+          </a:prstGeom>
+          <a:noFill/>
+        </p:spPr>
+        <p:txBody>
+          <a:bodyPr wrap="square">
+            <a:spAutoFit/>
+          </a:bodyPr>
+          <a:lstStyle/>
+          <a:p>
+            <a:pPr algn="l"/>
+            <a:r>
+              <a:rPr sz="1500" b="1">
+                <a:solidFill>
+                  <a:srgbClr val="1E3A8A"/>
+                </a:solidFill>
+                <a:latin typeface="Calibri"/>
+              </a:rPr>
+              <a:t>④ Guard clip ±3σ</a:t>
+            </a:r>
+          </a:p>
+        </p:txBody>
+      </p:sp>
+      <p:sp>
+        <p:nvSpPr>
+          <p:cNvPr id="11" name="TextBox 10"/>
+          <p:cNvSpPr txBox="1"/>
+          <p:nvPr/>
+        </p:nvSpPr>
+        <p:spPr>
+          <a:xfrm>
+            <a:off x="432000" y="4986000"/>
+            <a:ext cx="5400000" cy="648000"/>
+          </a:xfrm>
+          <a:prstGeom prst="rect">
+            <a:avLst/>
+          </a:prstGeom>
+          <a:noFill/>
+        </p:spPr>
+        <p:txBody>
+          <a:bodyPr wrap="square">
+            <a:spAutoFit/>
+          </a:bodyPr>
+          <a:lstStyle/>
+          <a:p>
+            <a:pPr algn="l"/>
+            <a:r>
+              <a:rPr sz="1250" b="0">
+                <a:solidFill>
+                  <a:srgbClr val="222222"/>
+                </a:solidFill>
+                <a:latin typeface="Calibri"/>
+              </a:rPr>
+              <a:t>σ = std(Δ train); nhãn |Δ|&gt;3σ bị kéo về biên — lợi suất có đuôi dày, vài ngày khủng hoảng Δ cực lớn sẽ chi phối loss.</a:t>
+            </a:r>
+          </a:p>
+        </p:txBody>
+      </p:sp>
+      <p:sp>
+        <p:nvSpPr>
+          <p:cNvPr id="12" name="Rectangle 11"/>
           <p:cNvSpPr/>
           <p:nvPr/>
         </p:nvSpPr>
         <p:spPr>
           <a:xfrm>
-            <a:off x="432000" y="3096000"/>
-            <a:ext cx="6983999" cy="2304000"/>
+            <a:off x="6048000" y="1224000"/>
+            <a:ext cx="5724000" cy="4536000"/>
           </a:xfrm>
           <a:prstGeom prst="rect">
             <a:avLst/>
@@ -6273,149 +6700,189 @@
           <a:p>
             <a:pPr algn="ctr"/>
             <a:r>
-              <a:rPr sz="1250">
-                <a:solidFill>
-                  <a:srgbClr val="222222"/>
-                </a:solidFill>
-                <a:latin typeface="Consolas"/>
-              </a:rPr>
-              <a:t># vòng lặp huấn luyện (notebook 01)</a:t>
-            </a:r>
-          </a:p>
-          <a:p>
-            <a:r>
-              <a:rPr sz="1250">
-                <a:solidFill>
-                  <a:srgbClr val="222222"/>
-                </a:solidFill>
-                <a:latin typeface="Consolas"/>
-              </a:rPr>
-              <a:t>for Xb, yb in loader:</a:t>
-            </a:r>
-          </a:p>
-          <a:p>
-            <a:r>
-              <a:rPr sz="1250">
-                <a:solidFill>
-                  <a:srgbClr val="222222"/>
-                </a:solidFill>
-                <a:latin typeface="Consolas"/>
-              </a:rPr>
-              <a:t>    loss = mse(model(Xb), yb)    # sai số dự báo</a:t>
-            </a:r>
-          </a:p>
-          <a:p>
-            <a:r>
-              <a:rPr sz="1250">
-                <a:solidFill>
-                  <a:srgbClr val="222222"/>
-                </a:solidFill>
-                <a:latin typeface="Consolas"/>
-              </a:rPr>
-              <a:t>    opt.zero_grad()</a:t>
-            </a:r>
-          </a:p>
-          <a:p>
-            <a:r>
-              <a:rPr sz="1250">
-                <a:solidFill>
-                  <a:srgbClr val="222222"/>
-                </a:solidFill>
-                <a:latin typeface="Consolas"/>
-              </a:rPr>
-              <a:t>    loss.backward()   # BPTT: gradient chảy ngược</a:t>
-            </a:r>
-          </a:p>
-          <a:p>
-            <a:r>
-              <a:rPr sz="1250">
-                <a:solidFill>
-                  <a:srgbClr val="222222"/>
-                </a:solidFill>
-                <a:latin typeface="Consolas"/>
-              </a:rPr>
-              <a:t>                      # qua từng thời điểm</a:t>
-            </a:r>
-          </a:p>
-          <a:p>
-            <a:r>
-              <a:rPr sz="1250">
-                <a:solidFill>
-                  <a:srgbClr val="222222"/>
-                </a:solidFill>
-                <a:latin typeface="Consolas"/>
-              </a:rPr>
-              <a:t>    clip_grad_norm_(model.parameters(), 1.0)</a:t>
-            </a:r>
-          </a:p>
-          <a:p>
-            <a:r>
-              <a:rPr sz="1250">
-                <a:solidFill>
-                  <a:srgbClr val="222222"/>
-                </a:solidFill>
-                <a:latin typeface="Consolas"/>
-              </a:rPr>
-              <a:t>    opt.step()        # cập nhật W, U, V</a:t>
-            </a:r>
-          </a:p>
-        </p:txBody>
-      </p:sp>
-      <p:pic>
-        <p:nvPicPr>
-          <p:cNvPr id="8" name="Picture 7" descr="slide-09-vanish.png"/>
-          <p:cNvPicPr>
-            <a:picLocks noChangeAspect="1"/>
-          </p:cNvPicPr>
-          <p:nvPr/>
-        </p:nvPicPr>
-        <p:blipFill>
-          <a:blip r:embed="rId3"/>
-          <a:stretch>
-            <a:fillRect/>
-          </a:stretch>
-        </p:blipFill>
-        <p:spPr>
-          <a:xfrm>
-            <a:off x="7632000" y="1260000"/>
-            <a:ext cx="4248000" cy="2304794"/>
-          </a:xfrm>
-          <a:prstGeom prst="rect">
-            <a:avLst/>
-          </a:prstGeom>
-        </p:spPr>
-      </p:pic>
-      <p:sp>
-        <p:nvSpPr>
-          <p:cNvPr id="9" name="TextBox 8"/>
-          <p:cNvSpPr txBox="1"/>
-          <p:nvPr/>
-        </p:nvSpPr>
-        <p:spPr>
-          <a:xfrm>
-            <a:off x="7632000" y="3671999"/>
-            <a:ext cx="4248000" cy="288000"/>
-          </a:xfrm>
-          <a:prstGeom prst="rect">
-            <a:avLst/>
-          </a:prstGeom>
-          <a:noFill/>
-        </p:spPr>
-        <p:txBody>
-          <a:bodyPr wrap="square">
-            <a:spAutoFit/>
-          </a:bodyPr>
-          <a:lstStyle/>
-          <a:p>
-            <a:pPr algn="l"/>
-            <a:r>
-              <a:rPr sz="1200" b="0">
-                <a:solidFill>
-                  <a:srgbClr val="1E3A8A"/>
-                </a:solidFill>
-                <a:latin typeface="Calibri"/>
-              </a:rPr>
-              <a:t>Gradient suy giảm theo cấp số nhân</a:t>
+              <a:rPr sz="1150">
+                <a:solidFill>
+                  <a:srgbClr val="222222"/>
+                </a:solidFill>
+                <a:latin typeface="Consolas"/>
+              </a:rPr>
+              <a:t># (notebook 01 — code thật)</a:t>
+            </a:r>
+          </a:p>
+          <a:p>
+            <a:r>
+              <a:rPr sz="1150">
+                <a:solidFill>
+                  <a:srgbClr val="222222"/>
+                </a:solidFill>
+                <a:latin typeface="Consolas"/>
+              </a:rPr>
+              <a:t>n = len(df)</a:t>
+            </a:r>
+          </a:p>
+          <a:p>
+            <a:r>
+              <a:rPr sz="1150">
+                <a:solidFill>
+                  <a:srgbClr val="222222"/>
+                </a:solidFill>
+                <a:latin typeface="Consolas"/>
+              </a:rPr>
+              <a:t>n_tr, n_va = int(n*0.70), int(n*0.85)   # ① chrono</a:t>
+            </a:r>
+          </a:p>
+          <a:p>
+            <a:r>
+              <a:rPr sz="1150">
+                <a:solidFill>
+                  <a:srgbClr val="222222"/>
+                </a:solidFill>
+                <a:latin typeface="Consolas"/>
+              </a:rPr>
+              <a:t>scaler = MinMaxScaler().fit(df[:n_tr])  # ② fit TRAIN</a:t>
+            </a:r>
+          </a:p>
+          <a:p>
+            <a:r>
+              <a:rPr sz="1150">
+                <a:solidFill>
+                  <a:srgbClr val="222222"/>
+                </a:solidFill>
+                <a:latin typeface="Consolas"/>
+              </a:rPr>
+              <a:t>z = scaler.transform(df)                #    → [0,1]</a:t>
+            </a:r>
+          </a:p>
+          <a:p>
+            <a:r>
+              <a:rPr sz="1150">
+                <a:solidFill>
+                  <a:srgbClr val="222222"/>
+                </a:solidFill>
+                <a:latin typeface="Consolas"/>
+              </a:rPr>
+              <a:t/>
+            </a:r>
+          </a:p>
+          <a:p>
+            <a:r>
+              <a:rPr sz="1150">
+                <a:solidFill>
+                  <a:srgbClr val="222222"/>
+                </a:solidFill>
+                <a:latin typeface="Consolas"/>
+              </a:rPr>
+              <a:t>def make_windows(f, L):                  # ③ cửa sổ</a:t>
+            </a:r>
+          </a:p>
+          <a:p>
+            <a:r>
+              <a:rPr sz="1150">
+                <a:solidFill>
+                  <a:srgbClr val="222222"/>
+                </a:solidFill>
+                <a:latin typeface="Consolas"/>
+              </a:rPr>
+              <a:t>    X, y = [], []</a:t>
+            </a:r>
+          </a:p>
+          <a:p>
+            <a:r>
+              <a:rPr sz="1150">
+                <a:solidFill>
+                  <a:srgbClr val="222222"/>
+                </a:solidFill>
+                <a:latin typeface="Consolas"/>
+              </a:rPr>
+              <a:t>    for i in range(len(f) - L):</a:t>
+            </a:r>
+          </a:p>
+          <a:p>
+            <a:r>
+              <a:rPr sz="1150">
+                <a:solidFill>
+                  <a:srgbClr val="222222"/>
+                </a:solidFill>
+                <a:latin typeface="Consolas"/>
+              </a:rPr>
+              <a:t>        X.append(f[i:i+L])    # 30 ngày</a:t>
+            </a:r>
+          </a:p>
+          <a:p>
+            <a:r>
+              <a:rPr sz="1150">
+                <a:solidFill>
+                  <a:srgbClr val="222222"/>
+                </a:solidFill>
+                <a:latin typeface="Consolas"/>
+              </a:rPr>
+              <a:t>        y.append(f[i+L, 0] - f[i+L-1, 0])</a:t>
+            </a:r>
+          </a:p>
+          <a:p>
+            <a:r>
+              <a:rPr sz="1150">
+                <a:solidFill>
+                  <a:srgbClr val="222222"/>
+                </a:solidFill>
+                <a:latin typeface="Consolas"/>
+              </a:rPr>
+              <a:t>        #            Δ = giá mai − giá nay</a:t>
+            </a:r>
+          </a:p>
+          <a:p>
+            <a:r>
+              <a:rPr sz="1150">
+                <a:solidFill>
+                  <a:srgbClr val="222222"/>
+                </a:solidFill>
+                <a:latin typeface="Consolas"/>
+              </a:rPr>
+              <a:t>    return np.asarray(X), np.asarray(y)</a:t>
+            </a:r>
+          </a:p>
+          <a:p>
+            <a:r>
+              <a:rPr sz="1150">
+                <a:solidFill>
+                  <a:srgbClr val="222222"/>
+                </a:solidFill>
+                <a:latin typeface="Consolas"/>
+              </a:rPr>
+              <a:t/>
+            </a:r>
+          </a:p>
+          <a:p>
+            <a:r>
+              <a:rPr sz="1150">
+                <a:solidFill>
+                  <a:srgbClr val="222222"/>
+                </a:solidFill>
+                <a:latin typeface="Consolas"/>
+              </a:rPr>
+              <a:t>SIGMA = np.std(y_train_raw)              # ④ σ Δ train</a:t>
+            </a:r>
+          </a:p>
+          <a:p>
+            <a:r>
+              <a:rPr sz="1150">
+                <a:solidFill>
+                  <a:srgbClr val="222222"/>
+                </a:solidFill>
+                <a:latin typeface="Consolas"/>
+              </a:rPr>
+              <a:t>BOUND  = 3.0 * SIGMA                     # biên ±3σ</a:t>
+            </a:r>
+          </a:p>
+          <a:p>
+            <a:r>
+              <a:rPr sz="1150">
+                <a:solidFill>
+                  <a:srgbClr val="222222"/>
+                </a:solidFill>
+                <a:latin typeface="Consolas"/>
+              </a:rPr>
+              <a:t>y_train = np.clip(y_train_raw, -BOUND, BOUND)</a:t>
             </a:r>
           </a:p>
         </p:txBody>
@@ -6512,7 +6979,7 @@
                 </a:solidFill>
                 <a:latin typeface="Calibri"/>
               </a:rPr>
-              <a:t>6. Áp dụng: dự đoán giá ngày mai trên 2 tập dữ liệu thật</a:t>
+              <a:t>6. Huấn luyện — BPTT: gradient chảy ngược qua thời gian</a:t>
             </a:r>
           </a:p>
         </p:txBody>
@@ -6525,8 +6992,8 @@
         </p:nvSpPr>
         <p:spPr>
           <a:xfrm>
-            <a:off x="432000" y="1152000"/>
-            <a:ext cx="6048000" cy="3096000"/>
+            <a:off x="432000" y="1188000"/>
+            <a:ext cx="6408000" cy="3456000"/>
           </a:xfrm>
           <a:prstGeom prst="rect">
             <a:avLst/>
@@ -6565,7 +7032,7 @@
                 </a:solidFill>
                 <a:latin typeface="Consolas"/>
               </a:rPr>
-              <a:t># pipeline (notebook 01 &amp; 03)</a:t>
+              <a:t>L = mean(ŷ − y)²                  # loss cuối chuỗi</a:t>
             </a:r>
           </a:p>
           <a:p>
@@ -6576,7 +7043,7 @@
                 </a:solidFill>
                 <a:latin typeface="Consolas"/>
               </a:rPr>
-              <a:t>scaler = MinMaxScaler().fit(train)   # chỉ fit train</a:t>
+              <a:t/>
             </a:r>
           </a:p>
           <a:p>
@@ -6587,7 +7054,7 @@
                 </a:solidFill>
                 <a:latin typeface="Consolas"/>
               </a:rPr>
-              <a:t>z = scaler.transform(prices)         # chuẩn hoá</a:t>
+              <a:t>∂L/∂V = (ŷ − y) · h_T             # tầng output</a:t>
             </a:r>
           </a:p>
           <a:p>
@@ -6598,7 +7065,7 @@
                 </a:solidFill>
                 <a:latin typeface="Consolas"/>
               </a:rPr>
-              <a:t>X, y = make_windows(z, L=30)         # cửa sổ 30 ngày</a:t>
+              <a:t/>
             </a:r>
           </a:p>
           <a:p>
@@ -6609,6 +7076,28 @@
                 </a:solidFill>
                 <a:latin typeface="Consolas"/>
               </a:rPr>
+              <a:t>∂h_i/∂h_(i−1) = U^T · diag(1 − tanh²(a_i))</a:t>
+            </a:r>
+          </a:p>
+          <a:p>
+            <a:r>
+              <a:rPr sz="1250">
+                <a:solidFill>
+                  <a:srgbClr val="222222"/>
+                </a:solidFill>
+                <a:latin typeface="Consolas"/>
+              </a:rPr>
+              <a:t>        # nhân tử JACOBIAN lặp lại mỗi bước ngược</a:t>
+            </a:r>
+          </a:p>
+          <a:p>
+            <a:r>
+              <a:rPr sz="1250">
+                <a:solidFill>
+                  <a:srgbClr val="222222"/>
+                </a:solidFill>
+                <a:latin typeface="Consolas"/>
+              </a:rPr>
               <a:t/>
             </a:r>
           </a:p>
@@ -6620,7 +7109,7 @@
                 </a:solidFill>
                 <a:latin typeface="Consolas"/>
               </a:rPr>
-              <a:t>model = MetalsRNN(2, 128)            # nn.RNN + Linear</a:t>
+              <a:t>∂L/∂W = Σ_t Σ_(k≤t) (∂L/∂h_t) ·</a:t>
             </a:r>
           </a:p>
           <a:p>
@@ -6631,7 +7120,7 @@
                 </a:solidFill>
                 <a:latin typeface="Consolas"/>
               </a:rPr>
-              <a:t>opt = torch.optim.Adam(</a:t>
+              <a:t>        [ ∏_(i=k+1)^t ∂h_i/∂h_(i−1) ] · (∂h_k/∂W)</a:t>
             </a:r>
           </a:p>
           <a:p>
@@ -6642,7 +7131,7 @@
                 </a:solidFill>
                 <a:latin typeface="Consolas"/>
               </a:rPr>
-              <a:t>    model.parameters(), lr=1e-3)</a:t>
+              <a:t>        # mỗi thời điểm k CỘNG DỒN mọi đường ngược về nó</a:t>
             </a:r>
           </a:p>
           <a:p>
@@ -6653,7 +7142,7 @@
                 </a:solidFill>
                 <a:latin typeface="Consolas"/>
               </a:rPr>
-              <a:t># Keras: SimpleRNN(128) + Dense(1)</a:t>
+              <a:t/>
             </a:r>
           </a:p>
           <a:p>
@@ -6664,7 +7153,636 @@
                 </a:solidFill>
                 <a:latin typeface="Consolas"/>
               </a:rPr>
-              <a:t># + EarlyStopping(patience=4)</a:t>
+              <a:t>‖∂h_t/∂h_k‖ ≤ ‖U‖^(t−k)</a:t>
+            </a:r>
+          </a:p>
+          <a:p>
+            <a:r>
+              <a:rPr sz="1250">
+                <a:solidFill>
+                  <a:srgbClr val="222222"/>
+                </a:solidFill>
+                <a:latin typeface="Consolas"/>
+              </a:rPr>
+              <a:t>  ‖U‖ &lt; 1 → cấp số nhân → 0  (BIẾN MẤT)</a:t>
+            </a:r>
+          </a:p>
+          <a:p>
+            <a:r>
+              <a:rPr sz="1250">
+                <a:solidFill>
+                  <a:srgbClr val="222222"/>
+                </a:solidFill>
+                <a:latin typeface="Consolas"/>
+              </a:rPr>
+              <a:t>  ‖U‖ &gt; 1 → cấp số nhân → ∞  (BÙNG NỔ)</a:t>
+            </a:r>
+          </a:p>
+        </p:txBody>
+      </p:sp>
+      <p:sp>
+        <p:nvSpPr>
+          <p:cNvPr id="5" name="TextBox 4"/>
+          <p:cNvSpPr txBox="1"/>
+          <p:nvPr/>
+        </p:nvSpPr>
+        <p:spPr>
+          <a:xfrm>
+            <a:off x="432000" y="4896000"/>
+            <a:ext cx="6408000" cy="468000"/>
+          </a:xfrm>
+          <a:prstGeom prst="rect">
+            <a:avLst/>
+          </a:prstGeom>
+          <a:noFill/>
+        </p:spPr>
+        <p:txBody>
+          <a:bodyPr wrap="square">
+            <a:spAutoFit/>
+          </a:bodyPr>
+          <a:lstStyle/>
+          <a:p>
+            <a:pPr algn="l"/>
+            <a:r>
+              <a:rPr sz="1400" b="0">
+                <a:solidFill>
+                  <a:srgbClr val="222222"/>
+                </a:solidFill>
+                <a:latin typeface="Calibri"/>
+              </a:rPr>
+              <a:t>•  diag(1 − tanh²) ≤ 1 nên chỉ U quyết định tăng/giảm gradient</a:t>
+            </a:r>
+          </a:p>
+        </p:txBody>
+      </p:sp>
+      <p:sp>
+        <p:nvSpPr>
+          <p:cNvPr id="6" name="TextBox 5"/>
+          <p:cNvSpPr txBox="1"/>
+          <p:nvPr/>
+        </p:nvSpPr>
+        <p:spPr>
+          <a:xfrm>
+            <a:off x="432000" y="5364000"/>
+            <a:ext cx="6408000" cy="468000"/>
+          </a:xfrm>
+          <a:prstGeom prst="rect">
+            <a:avLst/>
+          </a:prstGeom>
+          <a:noFill/>
+        </p:spPr>
+        <p:txBody>
+          <a:bodyPr wrap="square">
+            <a:spAutoFit/>
+          </a:bodyPr>
+          <a:lstStyle/>
+          <a:p>
+            <a:pPr algn="l"/>
+            <a:r>
+              <a:rPr sz="1400" b="1">
+                <a:solidFill>
+                  <a:srgbClr val="222222"/>
+                </a:solidFill>
+                <a:latin typeface="Calibri"/>
+              </a:rPr>
+              <a:t>Chuỗi dài → mạng khó học quá khứ XA; khắc phục: LSTM / GRU (slide 9)</a:t>
+            </a:r>
+          </a:p>
+        </p:txBody>
+      </p:sp>
+      <p:pic>
+        <p:nvPicPr>
+          <p:cNvPr id="7" name="Picture 6" descr="slide-09-vanish.png"/>
+          <p:cNvPicPr>
+            <a:picLocks noChangeAspect="1"/>
+          </p:cNvPicPr>
+          <p:nvPr/>
+        </p:nvPicPr>
+        <p:blipFill>
+          <a:blip r:embed="rId3"/>
+          <a:stretch>
+            <a:fillRect/>
+          </a:stretch>
+        </p:blipFill>
+        <p:spPr>
+          <a:xfrm>
+            <a:off x="7200000" y="1224000"/>
+            <a:ext cx="4572000" cy="2480583"/>
+          </a:xfrm>
+          <a:prstGeom prst="rect">
+            <a:avLst/>
+          </a:prstGeom>
+        </p:spPr>
+      </p:pic>
+      <p:sp>
+        <p:nvSpPr>
+          <p:cNvPr id="8" name="TextBox 7"/>
+          <p:cNvSpPr txBox="1"/>
+          <p:nvPr/>
+        </p:nvSpPr>
+        <p:spPr>
+          <a:xfrm>
+            <a:off x="7200000" y="3816000"/>
+            <a:ext cx="4572000" cy="288000"/>
+          </a:xfrm>
+          <a:prstGeom prst="rect">
+            <a:avLst/>
+          </a:prstGeom>
+          <a:noFill/>
+        </p:spPr>
+        <p:txBody>
+          <a:bodyPr wrap="square">
+            <a:spAutoFit/>
+          </a:bodyPr>
+          <a:lstStyle/>
+          <a:p>
+            <a:pPr algn="l"/>
+            <a:r>
+              <a:rPr sz="1200" b="0">
+                <a:solidFill>
+                  <a:srgbClr val="1E3A8A"/>
+                </a:solidFill>
+                <a:latin typeface="Calibri"/>
+              </a:rPr>
+              <a:t>Gradient suy giảm theo cấp số nhân (nb 00)</a:t>
+            </a:r>
+          </a:p>
+        </p:txBody>
+      </p:sp>
+      <p:sp>
+        <p:nvSpPr>
+          <p:cNvPr id="9" name="Rectangle 8"/>
+          <p:cNvSpPr/>
+          <p:nvPr/>
+        </p:nvSpPr>
+        <p:spPr>
+          <a:xfrm>
+            <a:off x="7200000" y="4248000"/>
+            <a:ext cx="4572000" cy="1655999"/>
+          </a:xfrm>
+          <a:prstGeom prst="rect">
+            <a:avLst/>
+          </a:prstGeom>
+          <a:solidFill>
+            <a:srgbClr val="F2F2F2"/>
+          </a:solidFill>
+          <a:ln>
+            <a:noFill/>
+          </a:ln>
+          <a:effectLst/>
+        </p:spPr>
+        <p:style>
+          <a:lnRef idx="1">
+            <a:schemeClr val="accent1"/>
+          </a:lnRef>
+          <a:fillRef idx="3">
+            <a:schemeClr val="accent1"/>
+          </a:fillRef>
+          <a:effectRef idx="2">
+            <a:schemeClr val="accent1"/>
+          </a:effectRef>
+          <a:fontRef idx="minor">
+            <a:schemeClr val="lt1"/>
+          </a:fontRef>
+        </p:style>
+        <p:txBody>
+          <a:bodyPr rtlCol="0" anchor="ctr" wrap="square"/>
+          <a:lstStyle/>
+          <a:p>
+            <a:pPr algn="ctr"/>
+            <a:r>
+              <a:rPr sz="1150">
+                <a:solidFill>
+                  <a:srgbClr val="222222"/>
+                </a:solidFill>
+                <a:latin typeface="Consolas"/>
+              </a:rPr>
+              <a:t># chữa BÙNG NỔ — cắt gradient (nb 00)</a:t>
+            </a:r>
+          </a:p>
+          <a:p>
+            <a:r>
+              <a:rPr sz="1150">
+                <a:solidFill>
+                  <a:srgbClr val="222222"/>
+                </a:solidFill>
+                <a:latin typeface="Consolas"/>
+              </a:rPr>
+              <a:t>g ← g · min( 1, c/‖g‖ )    # giữ hướng,</a:t>
+            </a:r>
+          </a:p>
+          <a:p>
+            <a:r>
+              <a:rPr sz="1150">
+                <a:solidFill>
+                  <a:srgbClr val="222222"/>
+                </a:solidFill>
+                <a:latin typeface="Consolas"/>
+              </a:rPr>
+              <a:t>                           # chặn độ lớn</a:t>
+            </a:r>
+          </a:p>
+          <a:p>
+            <a:r>
+              <a:rPr sz="1150">
+                <a:solidFill>
+                  <a:srgbClr val="222222"/>
+                </a:solidFill>
+                <a:latin typeface="Consolas"/>
+              </a:rPr>
+              <a:t>def clip_grad_norm(g, c=5.0):</a:t>
+            </a:r>
+          </a:p>
+          <a:p>
+            <a:r>
+              <a:rPr sz="1150">
+                <a:solidFill>
+                  <a:srgbClr val="222222"/>
+                </a:solidFill>
+                <a:latin typeface="Consolas"/>
+              </a:rPr>
+              <a:t>    s = min(1, c/‖g‖)</a:t>
+            </a:r>
+          </a:p>
+          <a:p>
+            <a:r>
+              <a:rPr sz="1150">
+                <a:solidFill>
+                  <a:srgbClr val="222222"/>
+                </a:solidFill>
+                <a:latin typeface="Consolas"/>
+              </a:rPr>
+              <a:t>    return {k: v*s for k, v in g.items()}</a:t>
+            </a:r>
+          </a:p>
+        </p:txBody>
+      </p:sp>
+    </p:spTree>
+  </p:cSld>
+  <p:clrMapOvr>
+    <a:masterClrMapping/>
+  </p:clrMapOvr>
+</p:sld>
+</file>
+
+<file path=ppt/slides/slide7.xml><?xml version="1.0" encoding="utf-8"?>
+<p:sld xmlns:a="http://schemas.openxmlformats.org/drawingml/2006/main" xmlns:p="http://schemas.openxmlformats.org/presentationml/2006/main" xmlns:r="http://schemas.openxmlformats.org/officeDocument/2006/relationships">
+  <p:cSld>
+    <p:spTree>
+      <p:nvGrpSpPr>
+        <p:cNvPr id="1" name=""/>
+        <p:cNvGrpSpPr/>
+        <p:nvPr/>
+      </p:nvGrpSpPr>
+      <p:grpSpPr/>
+      <p:sp>
+        <p:nvSpPr>
+          <p:cNvPr id="2" name="Rectangle 1"/>
+          <p:cNvSpPr/>
+          <p:nvPr/>
+        </p:nvSpPr>
+        <p:spPr>
+          <a:xfrm>
+            <a:off x="0" y="0"/>
+            <a:ext cx="12193200" cy="792000"/>
+          </a:xfrm>
+          <a:prstGeom prst="rect">
+            <a:avLst/>
+          </a:prstGeom>
+          <a:solidFill>
+            <a:srgbClr val="1E3A8A"/>
+          </a:solidFill>
+          <a:ln>
+            <a:noFill/>
+          </a:ln>
+          <a:effectLst/>
+        </p:spPr>
+        <p:style>
+          <a:lnRef idx="1">
+            <a:schemeClr val="accent1"/>
+          </a:lnRef>
+          <a:fillRef idx="3">
+            <a:schemeClr val="accent1"/>
+          </a:fillRef>
+          <a:effectRef idx="2">
+            <a:schemeClr val="accent1"/>
+          </a:effectRef>
+          <a:fontRef idx="minor">
+            <a:schemeClr val="lt1"/>
+          </a:fontRef>
+        </p:style>
+        <p:txBody>
+          <a:bodyPr rtlCol="0" anchor="ctr"/>
+          <a:lstStyle/>
+          <a:p>
+            <a:pPr algn="ctr"/>
+          </a:p>
+        </p:txBody>
+      </p:sp>
+      <p:sp>
+        <p:nvSpPr>
+          <p:cNvPr id="3" name="TextBox 2"/>
+          <p:cNvSpPr txBox="1"/>
+          <p:nvPr/>
+        </p:nvSpPr>
+        <p:spPr>
+          <a:xfrm>
+            <a:off x="288000" y="125999"/>
+            <a:ext cx="11617200" cy="540000"/>
+          </a:xfrm>
+          <a:prstGeom prst="rect">
+            <a:avLst/>
+          </a:prstGeom>
+          <a:noFill/>
+        </p:spPr>
+        <p:txBody>
+          <a:bodyPr wrap="square">
+            <a:spAutoFit/>
+          </a:bodyPr>
+          <a:lstStyle/>
+          <a:p>
+            <a:pPr algn="l"/>
+            <a:r>
+              <a:rPr sz="2600" b="1">
+                <a:solidFill>
+                  <a:srgbClr val="FFFFFF"/>
+                </a:solidFill>
+                <a:latin typeface="Calibri"/>
+              </a:rPr>
+              <a:t>7. Vòng lặp huấn luyện — từng dòng (code thật notebook 01)</a:t>
+            </a:r>
+          </a:p>
+        </p:txBody>
+      </p:sp>
+      <p:sp>
+        <p:nvSpPr>
+          <p:cNvPr id="4" name="Rectangle 3"/>
+          <p:cNvSpPr/>
+          <p:nvPr/>
+        </p:nvSpPr>
+        <p:spPr>
+          <a:xfrm>
+            <a:off x="432000" y="1188000"/>
+            <a:ext cx="6336000" cy="4752000"/>
+          </a:xfrm>
+          <a:prstGeom prst="rect">
+            <a:avLst/>
+          </a:prstGeom>
+          <a:solidFill>
+            <a:srgbClr val="F2F2F2"/>
+          </a:solidFill>
+          <a:ln>
+            <a:noFill/>
+          </a:ln>
+          <a:effectLst/>
+        </p:spPr>
+        <p:style>
+          <a:lnRef idx="1">
+            <a:schemeClr val="accent1"/>
+          </a:lnRef>
+          <a:fillRef idx="3">
+            <a:schemeClr val="accent1"/>
+          </a:fillRef>
+          <a:effectRef idx="2">
+            <a:schemeClr val="accent1"/>
+          </a:effectRef>
+          <a:fontRef idx="minor">
+            <a:schemeClr val="lt1"/>
+          </a:fontRef>
+        </p:style>
+        <p:txBody>
+          <a:bodyPr rtlCol="0" anchor="ctr" wrap="square"/>
+          <a:lstStyle/>
+          <a:p>
+            <a:pPr algn="ctr"/>
+            <a:r>
+              <a:rPr sz="1150">
+                <a:solidFill>
+                  <a:srgbClr val="222222"/>
+                </a:solidFill>
+                <a:latin typeface="Consolas"/>
+              </a:rPr>
+              <a:t>opt = torch.optim.Adam(model.parameters(), lr=1e-3)</a:t>
+            </a:r>
+          </a:p>
+          <a:p>
+            <a:r>
+              <a:rPr sz="1150">
+                <a:solidFill>
+                  <a:srgbClr val="222222"/>
+                </a:solidFill>
+                <a:latin typeface="Consolas"/>
+              </a:rPr>
+              <a:t>criterion = nn.MSELoss()</a:t>
+            </a:r>
+          </a:p>
+          <a:p>
+            <a:r>
+              <a:rPr sz="1150">
+                <a:solidFill>
+                  <a:srgbClr val="222222"/>
+                </a:solidFill>
+                <a:latin typeface="Consolas"/>
+              </a:rPr>
+              <a:t/>
+            </a:r>
+          </a:p>
+          <a:p>
+            <a:r>
+              <a:rPr sz="1150">
+                <a:solidFill>
+                  <a:srgbClr val="222222"/>
+                </a:solidFill>
+                <a:latin typeface="Consolas"/>
+              </a:rPr>
+              <a:t>for epoch in range(30):                # ≤ 30 epoch</a:t>
+            </a:r>
+          </a:p>
+          <a:p>
+            <a:r>
+              <a:rPr sz="1150">
+                <a:solidFill>
+                  <a:srgbClr val="222222"/>
+                </a:solidFill>
+                <a:latin typeface="Consolas"/>
+              </a:rPr>
+              <a:t>    for xb, yb in train_loader:        # (1) batch 64 cửa sổ</a:t>
+            </a:r>
+          </a:p>
+          <a:p>
+            <a:r>
+              <a:rPr sz="1150">
+                <a:solidFill>
+                  <a:srgbClr val="222222"/>
+                </a:solidFill>
+                <a:latin typeface="Consolas"/>
+              </a:rPr>
+              <a:t>        opt.zero_grad()                # (2) xoá gradient cũ</a:t>
+            </a:r>
+          </a:p>
+          <a:p>
+            <a:r>
+              <a:rPr sz="1150">
+                <a:solidFill>
+                  <a:srgbClr val="222222"/>
+                </a:solidFill>
+                <a:latin typeface="Consolas"/>
+              </a:rPr>
+              <a:t>        loss = criterion(</a:t>
+            </a:r>
+          </a:p>
+          <a:p>
+            <a:r>
+              <a:rPr sz="1150">
+                <a:solidFill>
+                  <a:srgbClr val="222222"/>
+                </a:solidFill>
+                <a:latin typeface="Consolas"/>
+              </a:rPr>
+              <a:t>            model(xb).squeeze(-1), yb) # (3) forward 30 bước → Δ̂</a:t>
+            </a:r>
+          </a:p>
+          <a:p>
+            <a:r>
+              <a:rPr sz="1150">
+                <a:solidFill>
+                  <a:srgbClr val="222222"/>
+                </a:solidFill>
+                <a:latin typeface="Consolas"/>
+              </a:rPr>
+              <a:t>        loss.backward()                # (4) BPTT: ∂L/∂W,U,V</a:t>
+            </a:r>
+          </a:p>
+          <a:p>
+            <a:r>
+              <a:rPr sz="1150">
+                <a:solidFill>
+                  <a:srgbClr val="222222"/>
+                </a:solidFill>
+                <a:latin typeface="Consolas"/>
+              </a:rPr>
+              <a:t>        opt.step()                     # (5) Adam cập nhật</a:t>
+            </a:r>
+          </a:p>
+          <a:p>
+            <a:r>
+              <a:rPr sz="1150">
+                <a:solidFill>
+                  <a:srgbClr val="222222"/>
+                </a:solidFill>
+                <a:latin typeface="Consolas"/>
+              </a:rPr>
+              <a:t>    with torch.no_grad():</a:t>
+            </a:r>
+          </a:p>
+          <a:p>
+            <a:r>
+              <a:rPr sz="1150">
+                <a:solidFill>
+                  <a:srgbClr val="222222"/>
+                </a:solidFill>
+                <a:latin typeface="Consolas"/>
+              </a:rPr>
+              <a:t>        val = criterion(</a:t>
+            </a:r>
+          </a:p>
+          <a:p>
+            <a:r>
+              <a:rPr sz="1150">
+                <a:solidFill>
+                  <a:srgbClr val="222222"/>
+                </a:solidFill>
+                <a:latin typeface="Consolas"/>
+              </a:rPr>
+              <a:t>            model(X_val), y_val)       # (6) loss trên tập val</a:t>
+            </a:r>
+          </a:p>
+          <a:p>
+            <a:r>
+              <a:rPr sz="1150">
+                <a:solidFill>
+                  <a:srgbClr val="222222"/>
+                </a:solidFill>
+                <a:latin typeface="Consolas"/>
+              </a:rPr>
+              <a:t>    if val &lt; best_val:</a:t>
+            </a:r>
+          </a:p>
+          <a:p>
+            <a:r>
+              <a:rPr sz="1150">
+                <a:solidFill>
+                  <a:srgbClr val="222222"/>
+                </a:solidFill>
+                <a:latin typeface="Consolas"/>
+              </a:rPr>
+              <a:t>        best_val = val</a:t>
+            </a:r>
+          </a:p>
+          <a:p>
+            <a:r>
+              <a:rPr sz="1150">
+                <a:solidFill>
+                  <a:srgbClr val="222222"/>
+                </a:solidFill>
+                <a:latin typeface="Consolas"/>
+              </a:rPr>
+              <a:t>        best = deepcopy(</a:t>
+            </a:r>
+          </a:p>
+          <a:p>
+            <a:r>
+              <a:rPr sz="1150">
+                <a:solidFill>
+                  <a:srgbClr val="222222"/>
+                </a:solidFill>
+                <a:latin typeface="Consolas"/>
+              </a:rPr>
+              <a:t>            model.state_dict())        #     lưu bản tốt nhất</a:t>
+            </a:r>
+          </a:p>
+          <a:p>
+            <a:r>
+              <a:rPr sz="1150">
+                <a:solidFill>
+                  <a:srgbClr val="222222"/>
+                </a:solidFill>
+                <a:latin typeface="Consolas"/>
+              </a:rPr>
+              <a:t>    else:</a:t>
+            </a:r>
+          </a:p>
+          <a:p>
+            <a:r>
+              <a:rPr sz="1150">
+                <a:solidFill>
+                  <a:srgbClr val="222222"/>
+                </a:solidFill>
+                <a:latin typeface="Consolas"/>
+              </a:rPr>
+              <a:t>        bad += 1                       # (7) không giảm lần thứ bad</a:t>
+            </a:r>
+          </a:p>
+          <a:p>
+            <a:r>
+              <a:rPr sz="1150">
+                <a:solidFill>
+                  <a:srgbClr val="222222"/>
+                </a:solidFill>
+                <a:latin typeface="Consolas"/>
+              </a:rPr>
+              <a:t>    if bad &gt;= 4: break                 #     EarlyStopping (patience 4)</a:t>
+            </a:r>
+          </a:p>
+          <a:p>
+            <a:r>
+              <a:rPr sz="1150">
+                <a:solidFill>
+                  <a:srgbClr val="222222"/>
+                </a:solidFill>
+                <a:latin typeface="Consolas"/>
+              </a:rPr>
+              <a:t>model.load_state_dict(best)            # (8) phục hồi bản tốt nhất</a:t>
             </a:r>
           </a:p>
         </p:txBody>
@@ -6678,8 +7796,8 @@
           <p:nvPr/>
         </p:nvGraphicFramePr>
         <p:xfrm>
-          <a:off x="6696000" y="1224000"/>
-          <a:ext cx="5039999" cy="1800000"/>
+          <a:off x="6983999" y="1224000"/>
+          <a:ext cx="4787999" cy="4680000"/>
         </p:xfrm>
         <a:graphic>
           <a:graphicData uri="http://schemas.openxmlformats.org/drawingml/2006/table">
@@ -6688,10 +7806,736 @@
                 <a:tableStyleId>{5C22544A-7EE6-4342-B048-85BDC9FD1C3A}</a:tableStyleId>
               </a:tblPr>
               <a:tblGrid>
-                <a:gridCol w="1938461"/>
-                <a:gridCol w="1033846"/>
-                <a:gridCol w="1033846"/>
-                <a:gridCol w="1033846"/>
+                <a:gridCol w="1546892"/>
+                <a:gridCol w="3241107"/>
+              </a:tblGrid>
+              <a:tr h="520000">
+                <a:tc>
+                  <a:txBody>
+                    <a:bodyPr/>
+                    <a:lstStyle/>
+                    <a:p>
+                      <a:r>
+                        <a:rPr sz="1150" b="1">
+                          <a:solidFill>
+                            <a:srgbClr val="FFFFFF"/>
+                          </a:solidFill>
+                        </a:rPr>
+                        <a:t>Lệnh</a:t>
+                      </a:r>
+                    </a:p>
+                  </a:txBody>
+                  <a:tcPr>
+                    <a:solidFill>
+                      <a:srgbClr val="1E3A8A"/>
+                    </a:solidFill>
+                  </a:tcPr>
+                </a:tc>
+                <a:tc>
+                  <a:txBody>
+                    <a:bodyPr/>
+                    <a:lstStyle/>
+                    <a:p>
+                      <a:r>
+                        <a:rPr sz="1150" b="1">
+                          <a:solidFill>
+                            <a:srgbClr val="FFFFFF"/>
+                          </a:solidFill>
+                        </a:rPr>
+                        <a:t>Vai trò</a:t>
+                      </a:r>
+                    </a:p>
+                  </a:txBody>
+                  <a:tcPr>
+                    <a:solidFill>
+                      <a:srgbClr val="1E3A8A"/>
+                    </a:solidFill>
+                  </a:tcPr>
+                </a:tc>
+              </a:tr>
+              <a:tr h="520000">
+                <a:tc>
+                  <a:txBody>
+                    <a:bodyPr/>
+                    <a:lstStyle/>
+                    <a:p>
+                      <a:r>
+                        <a:rPr sz="1150" b="0">
+                          <a:solidFill>
+                            <a:srgbClr val="222222"/>
+                          </a:solidFill>
+                        </a:rPr>
+                        <a:t>zero_grad()</a:t>
+                      </a:r>
+                    </a:p>
+                  </a:txBody>
+                  <a:tcPr>
+                    <a:solidFill>
+                      <a:srgbClr val="EEF2FA"/>
+                    </a:solidFill>
+                  </a:tcPr>
+                </a:tc>
+                <a:tc>
+                  <a:txBody>
+                    <a:bodyPr/>
+                    <a:lstStyle/>
+                    <a:p>
+                      <a:r>
+                        <a:rPr sz="1150" b="0">
+                          <a:solidFill>
+                            <a:srgbClr val="222222"/>
+                          </a:solidFill>
+                        </a:rPr>
+                        <a:t>Xoá gradient vòng trước — không cộng dồn</a:t>
+                      </a:r>
+                    </a:p>
+                  </a:txBody>
+                  <a:tcPr>
+                    <a:solidFill>
+                      <a:srgbClr val="EEF2FA"/>
+                    </a:solidFill>
+                  </a:tcPr>
+                </a:tc>
+              </a:tr>
+              <a:tr h="520000">
+                <a:tc>
+                  <a:txBody>
+                    <a:bodyPr/>
+                    <a:lstStyle/>
+                    <a:p>
+                      <a:r>
+                        <a:rPr sz="1150" b="0">
+                          <a:solidFill>
+                            <a:srgbClr val="222222"/>
+                          </a:solidFill>
+                        </a:rPr>
+                        <a:t>model(xb)</a:t>
+                      </a:r>
+                    </a:p>
+                  </a:txBody>
+                  <a:tcPr>
+                    <a:solidFill>
+                      <a:srgbClr val="FFFFFF"/>
+                    </a:solidFill>
+                  </a:tcPr>
+                </a:tc>
+                <a:tc>
+                  <a:txBody>
+                    <a:bodyPr/>
+                    <a:lstStyle/>
+                    <a:p>
+                      <a:r>
+                        <a:rPr sz="1150" b="0">
+                          <a:solidFill>
+                            <a:srgbClr val="222222"/>
+                          </a:solidFill>
+                        </a:rPr>
+                        <a:t>Forward: rnn_cell lặp 30 bước, đọc h ngày cuối</a:t>
+                      </a:r>
+                    </a:p>
+                  </a:txBody>
+                  <a:tcPr>
+                    <a:solidFill>
+                      <a:srgbClr val="FFFFFF"/>
+                    </a:solidFill>
+                  </a:tcPr>
+                </a:tc>
+              </a:tr>
+              <a:tr h="520000">
+                <a:tc>
+                  <a:txBody>
+                    <a:bodyPr/>
+                    <a:lstStyle/>
+                    <a:p>
+                      <a:r>
+                        <a:rPr sz="1150" b="0">
+                          <a:solidFill>
+                            <a:srgbClr val="222222"/>
+                          </a:solidFill>
+                        </a:rPr>
+                        <a:t>loss.backward()</a:t>
+                      </a:r>
+                    </a:p>
+                  </a:txBody>
+                  <a:tcPr>
+                    <a:solidFill>
+                      <a:srgbClr val="EEF2FA"/>
+                    </a:solidFill>
+                  </a:tcPr>
+                </a:tc>
+                <a:tc>
+                  <a:txBody>
+                    <a:bodyPr/>
+                    <a:lstStyle/>
+                    <a:p>
+                      <a:r>
+                        <a:rPr sz="1150" b="0">
+                          <a:solidFill>
+                            <a:srgbClr val="222222"/>
+                          </a:solidFill>
+                        </a:rPr>
+                        <a:t>BPTT — tự động tính ∂L/∂W, ∂L/∂U, ∂L/∂V</a:t>
+                      </a:r>
+                    </a:p>
+                  </a:txBody>
+                  <a:tcPr>
+                    <a:solidFill>
+                      <a:srgbClr val="EEF2FA"/>
+                    </a:solidFill>
+                  </a:tcPr>
+                </a:tc>
+              </a:tr>
+              <a:tr h="520000">
+                <a:tc>
+                  <a:txBody>
+                    <a:bodyPr/>
+                    <a:lstStyle/>
+                    <a:p>
+                      <a:r>
+                        <a:rPr sz="1150" b="0">
+                          <a:solidFill>
+                            <a:srgbClr val="222222"/>
+                          </a:solidFill>
+                        </a:rPr>
+                        <a:t>opt.step()</a:t>
+                      </a:r>
+                    </a:p>
+                  </a:txBody>
+                  <a:tcPr>
+                    <a:solidFill>
+                      <a:srgbClr val="FFFFFF"/>
+                    </a:solidFill>
+                  </a:tcPr>
+                </a:tc>
+                <a:tc>
+                  <a:txBody>
+                    <a:bodyPr/>
+                    <a:lstStyle/>
+                    <a:p>
+                      <a:r>
+                        <a:rPr sz="1150" b="0">
+                          <a:solidFill>
+                            <a:srgbClr val="222222"/>
+                          </a:solidFill>
+                        </a:rPr>
+                        <a:t>Adam: θ ← θ − lr·m/√v (lr tự thích ứng từng tham số)</a:t>
+                      </a:r>
+                    </a:p>
+                  </a:txBody>
+                  <a:tcPr>
+                    <a:solidFill>
+                      <a:srgbClr val="FFFFFF"/>
+                    </a:solidFill>
+                  </a:tcPr>
+                </a:tc>
+              </a:tr>
+              <a:tr h="520000">
+                <a:tc>
+                  <a:txBody>
+                    <a:bodyPr/>
+                    <a:lstStyle/>
+                    <a:p>
+                      <a:r>
+                        <a:rPr sz="1150" b="0">
+                          <a:solidFill>
+                            <a:srgbClr val="222222"/>
+                          </a:solidFill>
+                        </a:rPr>
+                        <a:t>torch.no_grad()</a:t>
+                      </a:r>
+                    </a:p>
+                  </a:txBody>
+                  <a:tcPr>
+                    <a:solidFill>
+                      <a:srgbClr val="EEF2FA"/>
+                    </a:solidFill>
+                  </a:tcPr>
+                </a:tc>
+                <a:tc>
+                  <a:txBody>
+                    <a:bodyPr/>
+                    <a:lstStyle/>
+                    <a:p>
+                      <a:r>
+                        <a:rPr sz="1150" b="0">
+                          <a:solidFill>
+                            <a:srgbClr val="222222"/>
+                          </a:solidFill>
+                        </a:rPr>
+                        <a:t>Tắt đồ thị tính toán — đo val cho nhanh</a:t>
+                      </a:r>
+                    </a:p>
+                  </a:txBody>
+                  <a:tcPr>
+                    <a:solidFill>
+                      <a:srgbClr val="EEF2FA"/>
+                    </a:solidFill>
+                  </a:tcPr>
+                </a:tc>
+              </a:tr>
+              <a:tr h="520000">
+                <a:tc>
+                  <a:txBody>
+                    <a:bodyPr/>
+                    <a:lstStyle/>
+                    <a:p>
+                      <a:r>
+                        <a:rPr sz="1150" b="0">
+                          <a:solidFill>
+                            <a:srgbClr val="222222"/>
+                          </a:solidFill>
+                        </a:rPr>
+                        <a:t>state_dict()</a:t>
+                      </a:r>
+                    </a:p>
+                  </a:txBody>
+                  <a:tcPr>
+                    <a:solidFill>
+                      <a:srgbClr val="FFFFFF"/>
+                    </a:solidFill>
+                  </a:tcPr>
+                </a:tc>
+                <a:tc>
+                  <a:txBody>
+                    <a:bodyPr/>
+                    <a:lstStyle/>
+                    <a:p>
+                      <a:r>
+                        <a:rPr sz="1150" b="0">
+                          <a:solidFill>
+                            <a:srgbClr val="222222"/>
+                          </a:solidFill>
+                        </a:rPr>
+                        <a:t>Chụp toàn bộ trọng số W,U,V hiện tại</a:t>
+                      </a:r>
+                    </a:p>
+                  </a:txBody>
+                  <a:tcPr>
+                    <a:solidFill>
+                      <a:srgbClr val="FFFFFF"/>
+                    </a:solidFill>
+                  </a:tcPr>
+                </a:tc>
+              </a:tr>
+              <a:tr h="520000">
+                <a:tc>
+                  <a:txBody>
+                    <a:bodyPr/>
+                    <a:lstStyle/>
+                    <a:p>
+                      <a:r>
+                        <a:rPr sz="1150" b="0">
+                          <a:solidFill>
+                            <a:srgbClr val="222222"/>
+                          </a:solidFill>
+                        </a:rPr>
+                        <a:t>EarlyStopping</a:t>
+                      </a:r>
+                    </a:p>
+                  </a:txBody>
+                  <a:tcPr>
+                    <a:solidFill>
+                      <a:srgbClr val="EEF2FA"/>
+                    </a:solidFill>
+                  </a:tcPr>
+                </a:tc>
+                <a:tc>
+                  <a:txBody>
+                    <a:bodyPr/>
+                    <a:lstStyle/>
+                    <a:p>
+                      <a:r>
+                        <a:rPr sz="1150" b="0">
+                          <a:solidFill>
+                            <a:srgbClr val="222222"/>
+                          </a:solidFill>
+                        </a:rPr>
+                        <a:t>Val loss không giảm 4 epoch → dừng, chống quá khớp</a:t>
+                      </a:r>
+                    </a:p>
+                  </a:txBody>
+                  <a:tcPr>
+                    <a:solidFill>
+                      <a:srgbClr val="EEF2FA"/>
+                    </a:solidFill>
+                  </a:tcPr>
+                </a:tc>
+              </a:tr>
+              <a:tr h="520000">
+                <a:tc>
+                  <a:txBody>
+                    <a:bodyPr/>
+                    <a:lstStyle/>
+                    <a:p>
+                      <a:r>
+                        <a:rPr sz="1150" b="0">
+                          <a:solidFill>
+                            <a:srgbClr val="222222"/>
+                          </a:solidFill>
+                        </a:rPr>
+                        <a:t>restore best</a:t>
+                      </a:r>
+                    </a:p>
+                  </a:txBody>
+                  <a:tcPr>
+                    <a:solidFill>
+                      <a:srgbClr val="FFFFFF"/>
+                    </a:solidFill>
+                  </a:tcPr>
+                </a:tc>
+                <a:tc>
+                  <a:txBody>
+                    <a:bodyPr/>
+                    <a:lstStyle/>
+                    <a:p>
+                      <a:r>
+                        <a:rPr sz="1150" b="0">
+                          <a:solidFill>
+                            <a:srgbClr val="222222"/>
+                          </a:solidFill>
+                        </a:rPr>
+                        <a:t>Nạp lại bản val tốt nhất (không phải bản cuối)</a:t>
+                      </a:r>
+                    </a:p>
+                  </a:txBody>
+                  <a:tcPr>
+                    <a:solidFill>
+                      <a:srgbClr val="FFFFFF"/>
+                    </a:solidFill>
+                  </a:tcPr>
+                </a:tc>
+              </a:tr>
+            </a:tbl>
+          </a:graphicData>
+        </a:graphic>
+      </p:graphicFrame>
+    </p:spTree>
+  </p:cSld>
+  <p:clrMapOvr>
+    <a:masterClrMapping/>
+  </p:clrMapOvr>
+</p:sld>
+</file>
+
+<file path=ppt/slides/slide8.xml><?xml version="1.0" encoding="utf-8"?>
+<p:sld xmlns:a="http://schemas.openxmlformats.org/drawingml/2006/main" xmlns:p="http://schemas.openxmlformats.org/presentationml/2006/main" xmlns:r="http://schemas.openxmlformats.org/officeDocument/2006/relationships">
+  <p:cSld>
+    <p:spTree>
+      <p:nvGrpSpPr>
+        <p:cNvPr id="1" name=""/>
+        <p:cNvGrpSpPr/>
+        <p:nvPr/>
+      </p:nvGrpSpPr>
+      <p:grpSpPr/>
+      <p:sp>
+        <p:nvSpPr>
+          <p:cNvPr id="2" name="Rectangle 1"/>
+          <p:cNvSpPr/>
+          <p:nvPr/>
+        </p:nvSpPr>
+        <p:spPr>
+          <a:xfrm>
+            <a:off x="0" y="0"/>
+            <a:ext cx="12193200" cy="792000"/>
+          </a:xfrm>
+          <a:prstGeom prst="rect">
+            <a:avLst/>
+          </a:prstGeom>
+          <a:solidFill>
+            <a:srgbClr val="1E3A8A"/>
+          </a:solidFill>
+          <a:ln>
+            <a:noFill/>
+          </a:ln>
+          <a:effectLst/>
+        </p:spPr>
+        <p:style>
+          <a:lnRef idx="1">
+            <a:schemeClr val="accent1"/>
+          </a:lnRef>
+          <a:fillRef idx="3">
+            <a:schemeClr val="accent1"/>
+          </a:fillRef>
+          <a:effectRef idx="2">
+            <a:schemeClr val="accent1"/>
+          </a:effectRef>
+          <a:fontRef idx="minor">
+            <a:schemeClr val="lt1"/>
+          </a:fontRef>
+        </p:style>
+        <p:txBody>
+          <a:bodyPr rtlCol="0" anchor="ctr"/>
+          <a:lstStyle/>
+          <a:p>
+            <a:pPr algn="ctr"/>
+          </a:p>
+        </p:txBody>
+      </p:sp>
+      <p:sp>
+        <p:nvSpPr>
+          <p:cNvPr id="3" name="TextBox 2"/>
+          <p:cNvSpPr txBox="1"/>
+          <p:nvPr/>
+        </p:nvSpPr>
+        <p:spPr>
+          <a:xfrm>
+            <a:off x="288000" y="125999"/>
+            <a:ext cx="11617200" cy="540000"/>
+          </a:xfrm>
+          <a:prstGeom prst="rect">
+            <a:avLst/>
+          </a:prstGeom>
+          <a:noFill/>
+        </p:spPr>
+        <p:txBody>
+          <a:bodyPr wrap="square">
+            <a:spAutoFit/>
+          </a:bodyPr>
+          <a:lstStyle/>
+          <a:p>
+            <a:pPr algn="l"/>
+            <a:r>
+              <a:rPr sz="2600" b="1">
+                <a:solidFill>
+                  <a:srgbClr val="FFFFFF"/>
+                </a:solidFill>
+                <a:latin typeface="Calibri"/>
+              </a:rPr>
+              <a:t>8. Áp dụng: dự đoán giá ngày mai trên 2 tập dữ liệu thật</a:t>
+            </a:r>
+          </a:p>
+        </p:txBody>
+      </p:sp>
+      <p:sp>
+        <p:nvSpPr>
+          <p:cNvPr id="4" name="Rectangle 3"/>
+          <p:cNvSpPr/>
+          <p:nvPr/>
+        </p:nvSpPr>
+        <p:spPr>
+          <a:xfrm>
+            <a:off x="432000" y="1188000"/>
+            <a:ext cx="5832000" cy="4320000"/>
+          </a:xfrm>
+          <a:prstGeom prst="rect">
+            <a:avLst/>
+          </a:prstGeom>
+          <a:solidFill>
+            <a:srgbClr val="F2F2F2"/>
+          </a:solidFill>
+          <a:ln>
+            <a:noFill/>
+          </a:ln>
+          <a:effectLst/>
+        </p:spPr>
+        <p:style>
+          <a:lnRef idx="1">
+            <a:schemeClr val="accent1"/>
+          </a:lnRef>
+          <a:fillRef idx="3">
+            <a:schemeClr val="accent1"/>
+          </a:fillRef>
+          <a:effectRef idx="2">
+            <a:schemeClr val="accent1"/>
+          </a:effectRef>
+          <a:fontRef idx="minor">
+            <a:schemeClr val="lt1"/>
+          </a:fontRef>
+        </p:style>
+        <p:txBody>
+          <a:bodyPr rtlCol="0" anchor="ctr" wrap="square"/>
+          <a:lstStyle/>
+          <a:p>
+            <a:pPr algn="ctr"/>
+            <a:r>
+              <a:rPr sz="1150">
+                <a:solidFill>
+                  <a:srgbClr val="222222"/>
+                </a:solidFill>
+                <a:latin typeface="Consolas"/>
+              </a:rPr>
+              <a:t># MẸO THEN CHỐT: dự báo Δ, không dự báo mức giá</a:t>
+            </a:r>
+          </a:p>
+          <a:p>
+            <a:r>
+              <a:rPr sz="1150">
+                <a:solidFill>
+                  <a:srgbClr val="222222"/>
+                </a:solidFill>
+                <a:latin typeface="Consolas"/>
+              </a:rPr>
+              <a:t># mức giá thua naive 2–5× (train giá thấp, test giá cao)</a:t>
+            </a:r>
+          </a:p>
+          <a:p>
+            <a:r>
+              <a:rPr sz="1150">
+                <a:solidFill>
+                  <a:srgbClr val="222222"/>
+                </a:solidFill>
+                <a:latin typeface="Consolas"/>
+              </a:rPr>
+              <a:t/>
+            </a:r>
+          </a:p>
+          <a:p>
+            <a:r>
+              <a:rPr sz="1150">
+                <a:solidFill>
+                  <a:srgbClr val="222222"/>
+                </a:solidFill>
+                <a:latin typeface="Consolas"/>
+              </a:rPr>
+              <a:t>d_hat = model(X_test)              # Δ̂ scaled (nb 01)</a:t>
+            </a:r>
+          </a:p>
+          <a:p>
+            <a:r>
+              <a:rPr sz="1150">
+                <a:solidFill>
+                  <a:srgbClr val="222222"/>
+                </a:solidFill>
+                <a:latin typeface="Consolas"/>
+              </a:rPr>
+              <a:t>d_hat = np.clip(d_hat, -BOUND, BOUND)</a:t>
+            </a:r>
+          </a:p>
+          <a:p>
+            <a:r>
+              <a:rPr sz="1150">
+                <a:solidFill>
+                  <a:srgbClr val="222222"/>
+                </a:solidFill>
+                <a:latin typeface="Consolas"/>
+              </a:rPr>
+              <a:t>        # chặn dự báo trong cùng biên ±3σ</a:t>
+            </a:r>
+          </a:p>
+          <a:p>
+            <a:r>
+              <a:rPr sz="1150">
+                <a:solidFill>
+                  <a:srgbClr val="222222"/>
+                </a:solidFill>
+                <a:latin typeface="Consolas"/>
+              </a:rPr>
+              <a:t/>
+            </a:r>
+          </a:p>
+          <a:p>
+            <a:r>
+              <a:rPr sz="1150">
+                <a:solidFill>
+                  <a:srgbClr val="222222"/>
+                </a:solidFill>
+                <a:latin typeface="Consolas"/>
+              </a:rPr>
+              <a:t>z_prev = z[cuối_cửa_sổ, 0]         # giá "hôm nay"</a:t>
+            </a:r>
+          </a:p>
+          <a:p>
+            <a:r>
+              <a:rPr sz="1150">
+                <a:solidFill>
+                  <a:srgbClr val="222222"/>
+                </a:solidFill>
+                <a:latin typeface="Consolas"/>
+              </a:rPr>
+              <a:t>p_hat  = inverse_gold(z_prev + d_hat)</a:t>
+            </a:r>
+          </a:p>
+          <a:p>
+            <a:r>
+              <a:rPr sz="1150">
+                <a:solidFill>
+                  <a:srgbClr val="222222"/>
+                </a:solidFill>
+                <a:latin typeface="Consolas"/>
+              </a:rPr>
+              <a:t>        # giá mai = giá nay + Δ̂ → inverse → USD</a:t>
+            </a:r>
+          </a:p>
+          <a:p>
+            <a:r>
+              <a:rPr sz="1150">
+                <a:solidFill>
+                  <a:srgbClr val="222222"/>
+                </a:solidFill>
+                <a:latin typeface="Consolas"/>
+              </a:rPr>
+              <a:t/>
+            </a:r>
+          </a:p>
+          <a:p>
+            <a:r>
+              <a:rPr sz="1150">
+                <a:solidFill>
+                  <a:srgbClr val="222222"/>
+                </a:solidFill>
+                <a:latin typeface="Consolas"/>
+              </a:rPr>
+              <a:t>def inverse_gold(y_s, scaler):     # đệm cột bạc = 0</a:t>
+            </a:r>
+          </a:p>
+          <a:p>
+            <a:r>
+              <a:rPr sz="1150">
+                <a:solidFill>
+                  <a:srgbClr val="222222"/>
+                </a:solidFill>
+                <a:latin typeface="Consolas"/>
+              </a:rPr>
+              <a:t>    d = np.zeros((len(y_s), 2))    # rồi inverse_transform</a:t>
+            </a:r>
+          </a:p>
+          <a:p>
+            <a:r>
+              <a:rPr sz="1150">
+                <a:solidFill>
+                  <a:srgbClr val="222222"/>
+                </a:solidFill>
+                <a:latin typeface="Consolas"/>
+              </a:rPr>
+              <a:t>    d[:, 0] = y_s                  # lấy cột vàng</a:t>
+            </a:r>
+          </a:p>
+          <a:p>
+            <a:r>
+              <a:rPr sz="1150">
+                <a:solidFill>
+                  <a:srgbClr val="222222"/>
+                </a:solidFill>
+                <a:latin typeface="Consolas"/>
+              </a:rPr>
+              <a:t>    return scaler.inverse_transform(d)[:, 0]</a:t>
+            </a:r>
+          </a:p>
+        </p:txBody>
+      </p:sp>
+      <p:graphicFrame>
+        <p:nvGraphicFramePr>
+          <p:cNvPr id="5" name="Table 4"/>
+          <p:cNvGraphicFramePr>
+            <a:graphicFrameLocks noGrp="1"/>
+          </p:cNvGraphicFramePr>
+          <p:nvPr/>
+        </p:nvGraphicFramePr>
+        <p:xfrm>
+          <a:off x="6552000" y="1224000"/>
+          <a:ext cx="5183998" cy="1800000"/>
+        </p:xfrm>
+        <a:graphic>
+          <a:graphicData uri="http://schemas.openxmlformats.org/drawingml/2006/table">
+            <a:tbl>
+              <a:tblPr firstRow="1" bandRow="1">
+                <a:tableStyleId>{5C22544A-7EE6-4342-B048-85BDC9FD1C3A}</a:tableStyleId>
+              </a:tblPr>
+              <a:tblGrid>
+                <a:gridCol w="1993846"/>
+                <a:gridCol w="1063384"/>
+                <a:gridCol w="1063384"/>
+                <a:gridCol w="1063384"/>
               </a:tblGrid>
               <a:tr h="600000">
                 <a:tc>
@@ -6963,8 +8807,8 @@
         </p:nvSpPr>
         <p:spPr>
           <a:xfrm>
-            <a:off x="6696000" y="3311999"/>
-            <a:ext cx="5040000" cy="1152000"/>
+            <a:off x="6552000" y="3240000"/>
+            <a:ext cx="5184000" cy="2160000"/>
           </a:xfrm>
           <a:prstGeom prst="rect">
             <a:avLst/>
@@ -6997,7 +8841,7 @@
                 </a:solidFill>
                 <a:latin typeface="Calibri"/>
               </a:rPr>
-              <a:t>RNN đạt nhỉnh hơn baseline này trên cả 2 tập</a:t>
+              <a:t>RNN thắng baseline này trên cả 2 tập (R² ≥ 0.99,</a:t>
             </a:r>
           </a:p>
           <a:p>
@@ -7009,7 +8853,55 @@
                 </a:solidFill>
                 <a:latin typeface="Calibri"/>
               </a:rPr>
-              <a:t>(R² ≥ 0.99, MAPE 0.6–1.8%).</a:t>
+              <a:t>MAPE 0.6–1.8%) — chỉ khi dự báo Δ residual.</a:t>
+            </a:r>
+          </a:p>
+          <a:p>
+            <a:pPr algn="l"/>
+            <a:r>
+              <a:rPr sz="1400" b="1">
+                <a:solidFill>
+                  <a:srgbClr val="1E3A8A"/>
+                </a:solidFill>
+                <a:latin typeface="Calibri"/>
+              </a:rPr>
+              <a:t/>
+            </a:r>
+          </a:p>
+          <a:p>
+            <a:pPr algn="l"/>
+            <a:r>
+              <a:rPr sz="1400" b="1">
+                <a:solidFill>
+                  <a:srgbClr val="1E3A8A"/>
+                </a:solidFill>
+                <a:latin typeface="Calibri"/>
+              </a:rPr>
+              <a:t>Dự báo thẳng MỨC GIÁ: RMSE thua naive 2–5×</a:t>
+            </a:r>
+          </a:p>
+          <a:p>
+            <a:pPr algn="l"/>
+            <a:r>
+              <a:rPr sz="1400" b="1">
+                <a:solidFill>
+                  <a:srgbClr val="1E3A8A"/>
+                </a:solidFill>
+                <a:latin typeface="Calibri"/>
+              </a:rPr>
+              <a:t>vì network bị kéo về trung bình giá train.</a:t>
+            </a:r>
+          </a:p>
+          <a:p>
+            <a:pPr algn="l"/>
+            <a:r>
+              <a:rPr sz="1400" b="1">
+                <a:solidFill>
+                  <a:srgbClr val="1E3A8A"/>
+                </a:solidFill>
+                <a:latin typeface="Calibri"/>
+              </a:rPr>
+              <a:t>Kỹ thuật Δ nhất quán ở cả 4 notebook.</a:t>
             </a:r>
           </a:p>
         </p:txBody>
@@ -7022,7 +8914,7 @@
 </p:sld>
 </file>
 
-<file path=ppt/slides/slide7.xml><?xml version="1.0" encoding="utf-8"?>
+<file path=ppt/slides/slide9.xml><?xml version="1.0" encoding="utf-8"?>
 <p:sld xmlns:a="http://schemas.openxmlformats.org/drawingml/2006/main" xmlns:p="http://schemas.openxmlformats.org/presentationml/2006/main" xmlns:r="http://schemas.openxmlformats.org/officeDocument/2006/relationships">
   <p:cSld>
     <p:spTree>
@@ -7106,7 +8998,7 @@
                 </a:solidFill>
                 <a:latin typeface="Calibri"/>
               </a:rPr>
-              <a:t>7. Hạn chế của RNN &amp; mô hình phát triển</a:t>
+              <a:t>9. Hạn chế của RNN &amp; mô hình phát triển: LSTM, GRU</a:t>
             </a:r>
           </a:p>
         </p:txBody>
@@ -7119,8 +9011,8 @@
         </p:nvSpPr>
         <p:spPr>
           <a:xfrm>
-            <a:off x="432000" y="1188000"/>
-            <a:ext cx="11304000" cy="468000"/>
+            <a:off x="432000" y="1080000"/>
+            <a:ext cx="11304000" cy="432000"/>
           </a:xfrm>
           <a:prstGeom prst="rect">
             <a:avLst/>
@@ -7135,13 +9027,13 @@
           <a:p>
             <a:pPr algn="l"/>
             <a:r>
-              <a:rPr sz="1700" b="1">
+              <a:rPr sz="1500" b="1">
                 <a:solidFill>
                   <a:srgbClr val="222222"/>
                 </a:solidFill>
                 <a:latin typeface="Calibri"/>
               </a:rPr>
-              <a:t>RNN đơn giản hay QUÊN quá khứ xa (gradient biến mất)</a:t>
+              <a:t>RNN đơn giản QUÊN quá khứ xa: gradient chỉ đi qua phép NHÂN U lặp lại → biến mất</a:t>
             </a:r>
           </a:p>
         </p:txBody>
@@ -7154,8 +9046,8 @@
         </p:nvSpPr>
         <p:spPr>
           <a:xfrm>
-            <a:off x="432000" y="1656000"/>
-            <a:ext cx="11304000" cy="468000"/>
+            <a:off x="432000" y="1512000"/>
+            <a:ext cx="11304000" cy="432000"/>
           </a:xfrm>
           <a:prstGeom prst="rect">
             <a:avLst/>
@@ -7170,97 +9062,27 @@
           <a:p>
             <a:pPr algn="l"/>
             <a:r>
-              <a:rPr sz="1700" b="0">
+              <a:rPr sz="1500" b="0">
                 <a:solidFill>
                   <a:srgbClr val="222222"/>
                 </a:solidFill>
                 <a:latin typeface="Calibri"/>
               </a:rPr>
-              <a:t>•  LSTM: thêm các cổng (quên f, ghi i, xuất o) — tự chọn điều gì đáng nhớ, đáng quên</a:t>
-            </a:r>
-          </a:p>
-        </p:txBody>
-      </p:sp>
-      <p:sp>
-        <p:nvSpPr>
-          <p:cNvPr id="6" name="TextBox 5"/>
-          <p:cNvSpPr txBox="1"/>
+              <a:t>•  LSTM thêm băng chuyền trí nhớ c_t: gradient đi qua phép CỘNG và cổng quên → gần như nguyên vẹn</a:t>
+            </a:r>
+          </a:p>
+        </p:txBody>
+      </p:sp>
+      <p:sp>
+        <p:nvSpPr>
+          <p:cNvPr id="6" name="Rectangle 5"/>
+          <p:cNvSpPr/>
           <p:nvPr/>
         </p:nvSpPr>
         <p:spPr>
           <a:xfrm>
-            <a:off x="432000" y="2124000"/>
-            <a:ext cx="11304000" cy="468000"/>
-          </a:xfrm>
-          <a:prstGeom prst="rect">
-            <a:avLst/>
-          </a:prstGeom>
-          <a:noFill/>
-        </p:spPr>
-        <p:txBody>
-          <a:bodyPr wrap="square">
-            <a:spAutoFit/>
-          </a:bodyPr>
-          <a:lstStyle/>
-          <a:p>
-            <a:pPr algn="l"/>
-            <a:r>
-              <a:rPr sz="1700" b="0">
-                <a:solidFill>
-                  <a:srgbClr val="222222"/>
-                </a:solidFill>
-                <a:latin typeface="Calibri"/>
-              </a:rPr>
-              <a:t>•  GRU: bản gọn của LSTM (2 cổng z, r) — nhanh hơn, hiệu quả tương đương</a:t>
-            </a:r>
-          </a:p>
-        </p:txBody>
-      </p:sp>
-      <p:sp>
-        <p:nvSpPr>
-          <p:cNvPr id="7" name="TextBox 6"/>
-          <p:cNvSpPr txBox="1"/>
-          <p:nvPr/>
-        </p:nvSpPr>
-        <p:spPr>
-          <a:xfrm>
-            <a:off x="432000" y="2592000"/>
-            <a:ext cx="11304000" cy="468000"/>
-          </a:xfrm>
-          <a:prstGeom prst="rect">
-            <a:avLst/>
-          </a:prstGeom>
-          <a:noFill/>
-        </p:spPr>
-        <p:txBody>
-          <a:bodyPr wrap="square">
-            <a:spAutoFit/>
-          </a:bodyPr>
-          <a:lstStyle/>
-          <a:p>
-            <a:pPr algn="l"/>
-            <a:r>
-              <a:rPr sz="1700" b="0">
-                <a:solidFill>
-                  <a:srgbClr val="222222"/>
-                </a:solidFill>
-                <a:latin typeface="Calibri"/>
-              </a:rPr>
-              <a:t>•  Ứng dụng chuỗi: dự báo tài chính, dịch máy, nhận dạng giọng nói, phân tích hành vi</a:t>
-            </a:r>
-          </a:p>
-        </p:txBody>
-      </p:sp>
-      <p:sp>
-        <p:nvSpPr>
-          <p:cNvPr id="8" name="Rectangle 7"/>
-          <p:cNvSpPr/>
-          <p:nvPr/>
-        </p:nvSpPr>
-        <p:spPr>
-          <a:xfrm>
-            <a:off x="432000" y="3384000"/>
-            <a:ext cx="5472000" cy="2015999"/>
+            <a:off x="432000" y="2015999"/>
+            <a:ext cx="5688000" cy="4104000"/>
           </a:xfrm>
           <a:prstGeom prst="rect">
             <a:avLst/>
@@ -7293,85 +9115,365 @@
           <a:p>
             <a:pPr algn="ctr"/>
             <a:r>
-              <a:rPr sz="1250">
-                <a:solidFill>
-                  <a:srgbClr val="222222"/>
-                </a:solidFill>
-                <a:latin typeface="Consolas"/>
-              </a:rPr>
-              <a:t># chỉ cần đổi 1 dòng (notebook 00)</a:t>
-            </a:r>
-          </a:p>
-          <a:p>
-            <a:r>
-              <a:rPr sz="1250">
-                <a:solidFill>
-                  <a:srgbClr val="222222"/>
-                </a:solidFill>
-                <a:latin typeface="Consolas"/>
-              </a:rPr>
-              <a:t>nn.RNN (2, 64)   # RNN thường</a:t>
-            </a:r>
-          </a:p>
-          <a:p>
-            <a:r>
-              <a:rPr sz="1250">
-                <a:solidFill>
-                  <a:srgbClr val="222222"/>
-                </a:solidFill>
-                <a:latin typeface="Consolas"/>
-              </a:rPr>
-              <a:t>nn.LSTM(2, 64)   # thêm cổng nhớ dài hạn</a:t>
-            </a:r>
-          </a:p>
-          <a:p>
-            <a:r>
-              <a:rPr sz="1250">
-                <a:solidFill>
-                  <a:srgbClr val="222222"/>
-                </a:solidFill>
-                <a:latin typeface="Consolas"/>
-              </a:rPr>
-              <a:t>nn.GRU (2, 64)   # bản gọn 2 cổng, nhanh hơn</a:t>
-            </a:r>
-          </a:p>
-          <a:p>
-            <a:r>
-              <a:rPr sz="1250">
-                <a:solidFill>
-                  <a:srgbClr val="222222"/>
-                </a:solidFill>
-                <a:latin typeface="Consolas"/>
-              </a:rPr>
-              <a:t># dùng y hệt: out, h = layer(x)</a:t>
-            </a:r>
-          </a:p>
-        </p:txBody>
-      </p:sp>
-      <p:pic>
-        <p:nvPicPr>
-          <p:cNvPr id="9" name="Picture 8" descr="slide-10-lstm.png"/>
-          <p:cNvPicPr>
-            <a:picLocks noChangeAspect="1"/>
-          </p:cNvPicPr>
+              <a:rPr sz="1150">
+                <a:solidFill>
+                  <a:srgbClr val="222222"/>
+                </a:solidFill>
+                <a:latin typeface="Consolas"/>
+              </a:rPr>
+              <a:t># LSTM — 5 cổng, σ(s)=1/(1+e^(−s)) ∈ (0,1)</a:t>
+            </a:r>
+          </a:p>
+          <a:p>
+            <a:r>
+              <a:rPr sz="1150">
+                <a:solidFill>
+                  <a:srgbClr val="222222"/>
+                </a:solidFill>
+                <a:latin typeface="Consolas"/>
+              </a:rPr>
+              <a:t>f_t = σ(W_f·[h_(t−1),x_t] + b_f)</a:t>
+            </a:r>
+          </a:p>
+          <a:p>
+            <a:r>
+              <a:rPr sz="1150">
+                <a:solidFill>
+                  <a:srgbClr val="222222"/>
+                </a:solidFill>
+                <a:latin typeface="Consolas"/>
+              </a:rPr>
+              <a:t>     # cổng QUÊN: giữ lại bao nhiêu c_(t−1)</a:t>
+            </a:r>
+          </a:p>
+          <a:p>
+            <a:r>
+              <a:rPr sz="1150">
+                <a:solidFill>
+                  <a:srgbClr val="222222"/>
+                </a:solidFill>
+                <a:latin typeface="Consolas"/>
+              </a:rPr>
+              <a:t>i_t = σ(W_i·[h_(t−1),x_t] + b_i)</a:t>
+            </a:r>
+          </a:p>
+          <a:p>
+            <a:r>
+              <a:rPr sz="1150">
+                <a:solidFill>
+                  <a:srgbClr val="222222"/>
+                </a:solidFill>
+                <a:latin typeface="Consolas"/>
+              </a:rPr>
+              <a:t>     # cổng GHI: nhận bao nhiêu tin mới</a:t>
+            </a:r>
+          </a:p>
+          <a:p>
+            <a:r>
+              <a:rPr sz="1150">
+                <a:solidFill>
+                  <a:srgbClr val="222222"/>
+                </a:solidFill>
+                <a:latin typeface="Consolas"/>
+              </a:rPr>
+              <a:t>c̃_t = tanh(W_c·[h_(t−1),x_t] + b_c)</a:t>
+            </a:r>
+          </a:p>
+          <a:p>
+            <a:r>
+              <a:rPr sz="1150">
+                <a:solidFill>
+                  <a:srgbClr val="222222"/>
+                </a:solidFill>
+                <a:latin typeface="Consolas"/>
+              </a:rPr>
+              <a:t>     # nội dung mới đề xuất</a:t>
+            </a:r>
+          </a:p>
+          <a:p>
+            <a:r>
+              <a:rPr sz="1150">
+                <a:solidFill>
+                  <a:srgbClr val="222222"/>
+                </a:solidFill>
+                <a:latin typeface="Consolas"/>
+              </a:rPr>
+              <a:t>c_t = f_t ⊙ c_(t−1) + i_t ⊙ c̃_t</a:t>
+            </a:r>
+          </a:p>
+          <a:p>
+            <a:r>
+              <a:rPr sz="1150">
+                <a:solidFill>
+                  <a:srgbClr val="222222"/>
+                </a:solidFill>
+                <a:latin typeface="Consolas"/>
+              </a:rPr>
+              <a:t>     # BĂNG CHUYỀN trí nhớ dài hạn</a:t>
+            </a:r>
+          </a:p>
+          <a:p>
+            <a:r>
+              <a:rPr sz="1150">
+                <a:solidFill>
+                  <a:srgbClr val="222222"/>
+                </a:solidFill>
+                <a:latin typeface="Consolas"/>
+              </a:rPr>
+              <a:t>o_t = σ(W_o·[h_(t−1),x_t] + b_o)</a:t>
+            </a:r>
+          </a:p>
+          <a:p>
+            <a:r>
+              <a:rPr sz="1150">
+                <a:solidFill>
+                  <a:srgbClr val="222222"/>
+                </a:solidFill>
+                <a:latin typeface="Consolas"/>
+              </a:rPr>
+              <a:t>     # cổng XUẤT: lộ bao nhiêu ra ngoài</a:t>
+            </a:r>
+          </a:p>
+          <a:p>
+            <a:r>
+              <a:rPr sz="1150">
+                <a:solidFill>
+                  <a:srgbClr val="222222"/>
+                </a:solidFill>
+                <a:latin typeface="Consolas"/>
+              </a:rPr>
+              <a:t>h_t = o_t ⊙ tanh(c_t)</a:t>
+            </a:r>
+          </a:p>
+          <a:p>
+            <a:r>
+              <a:rPr sz="1150">
+                <a:solidFill>
+                  <a:srgbClr val="222222"/>
+                </a:solidFill>
+                <a:latin typeface="Consolas"/>
+              </a:rPr>
+              <a:t>     # trí nhớ ngắn hạn đưa ra ngoài</a:t>
+            </a:r>
+          </a:p>
+          <a:p>
+            <a:r>
+              <a:rPr sz="1150">
+                <a:solidFill>
+                  <a:srgbClr val="222222"/>
+                </a:solidFill>
+                <a:latin typeface="Consolas"/>
+              </a:rPr>
+              <a:t># ⊙ = nhân từng phần tử (element-wise)</a:t>
+            </a:r>
+          </a:p>
+        </p:txBody>
+      </p:sp>
+      <p:sp>
+        <p:nvSpPr>
+          <p:cNvPr id="7" name="Rectangle 6"/>
+          <p:cNvSpPr/>
           <p:nvPr/>
-        </p:nvPicPr>
-        <p:blipFill>
-          <a:blip r:embed="rId3"/>
-          <a:stretch>
-            <a:fillRect/>
-          </a:stretch>
-        </p:blipFill>
+        </p:nvSpPr>
         <p:spPr>
           <a:xfrm>
-            <a:off x="6263999" y="3384000"/>
-            <a:ext cx="5472000" cy="2837231"/>
+            <a:off x="6372000" y="2015999"/>
+            <a:ext cx="5400000" cy="2736000"/>
           </a:xfrm>
           <a:prstGeom prst="rect">
             <a:avLst/>
           </a:prstGeom>
+          <a:solidFill>
+            <a:srgbClr val="F2F2F2"/>
+          </a:solidFill>
+          <a:ln>
+            <a:noFill/>
+          </a:ln>
+          <a:effectLst/>
         </p:spPr>
-      </p:pic>
+        <p:style>
+          <a:lnRef idx="1">
+            <a:schemeClr val="accent1"/>
+          </a:lnRef>
+          <a:fillRef idx="3">
+            <a:schemeClr val="accent1"/>
+          </a:fillRef>
+          <a:effectRef idx="2">
+            <a:schemeClr val="accent1"/>
+          </a:effectRef>
+          <a:fontRef idx="minor">
+            <a:schemeClr val="lt1"/>
+          </a:fontRef>
+        </p:style>
+        <p:txBody>
+          <a:bodyPr rtlCol="0" anchor="ctr" wrap="square"/>
+          <a:lstStyle/>
+          <a:p>
+            <a:pPr algn="ctr"/>
+            <a:r>
+              <a:rPr sz="1150">
+                <a:solidFill>
+                  <a:srgbClr val="222222"/>
+                </a:solidFill>
+                <a:latin typeface="Consolas"/>
+              </a:rPr>
+              <a:t># GRU — bản gọn: gộp quên+ghi thành 2 cổng</a:t>
+            </a:r>
+          </a:p>
+          <a:p>
+            <a:r>
+              <a:rPr sz="1150">
+                <a:solidFill>
+                  <a:srgbClr val="222222"/>
+                </a:solidFill>
+                <a:latin typeface="Consolas"/>
+              </a:rPr>
+              <a:t>z_t = σ(W_z·[h_(t−1),x_t])   # cổng CẬP NHẬT</a:t>
+            </a:r>
+          </a:p>
+          <a:p>
+            <a:r>
+              <a:rPr sz="1150">
+                <a:solidFill>
+                  <a:srgbClr val="222222"/>
+                </a:solidFill>
+                <a:latin typeface="Consolas"/>
+              </a:rPr>
+              <a:t>r_t = σ(W_r·[h_(t−1),x_t])   # cổng ĐẶT LẠI</a:t>
+            </a:r>
+          </a:p>
+          <a:p>
+            <a:r>
+              <a:rPr sz="1150">
+                <a:solidFill>
+                  <a:srgbClr val="222222"/>
+                </a:solidFill>
+                <a:latin typeface="Consolas"/>
+              </a:rPr>
+              <a:t>h̃_t = tanh(W_h·[r_t ⊙ h_(t−1), x_t])</a:t>
+            </a:r>
+          </a:p>
+          <a:p>
+            <a:r>
+              <a:rPr sz="1150">
+                <a:solidFill>
+                  <a:srgbClr val="222222"/>
+                </a:solidFill>
+                <a:latin typeface="Consolas"/>
+              </a:rPr>
+              <a:t>h_t = (1−z_t) ⊙ h_(t−1) + z_t ⊙ h̃_t</a:t>
+            </a:r>
+          </a:p>
+          <a:p>
+            <a:r>
+              <a:rPr sz="1150">
+                <a:solidFill>
+                  <a:srgbClr val="222222"/>
+                </a:solidFill>
+                <a:latin typeface="Consolas"/>
+              </a:rPr>
+              <a:t># không có c_t riêng — ít tham số ~25%</a:t>
+            </a:r>
+          </a:p>
+          <a:p>
+            <a:r>
+              <a:rPr sz="1150">
+                <a:solidFill>
+                  <a:srgbClr val="222222"/>
+                </a:solidFill>
+                <a:latin typeface="Consolas"/>
+              </a:rPr>
+              <a:t># → nhanh hơn, hiệu quả tương đương</a:t>
+            </a:r>
+          </a:p>
+        </p:txBody>
+      </p:sp>
+      <p:sp>
+        <p:nvSpPr>
+          <p:cNvPr id="8" name="Rectangle 7"/>
+          <p:cNvSpPr/>
+          <p:nvPr/>
+        </p:nvSpPr>
+        <p:spPr>
+          <a:xfrm>
+            <a:off x="6372000" y="4968000"/>
+            <a:ext cx="5400000" cy="1152000"/>
+          </a:xfrm>
+          <a:prstGeom prst="rect">
+            <a:avLst/>
+          </a:prstGeom>
+          <a:solidFill>
+            <a:srgbClr val="F2F2F2"/>
+          </a:solidFill>
+          <a:ln>
+            <a:noFill/>
+          </a:ln>
+          <a:effectLst/>
+        </p:spPr>
+        <p:style>
+          <a:lnRef idx="1">
+            <a:schemeClr val="accent1"/>
+          </a:lnRef>
+          <a:fillRef idx="3">
+            <a:schemeClr val="accent1"/>
+          </a:fillRef>
+          <a:effectRef idx="2">
+            <a:schemeClr val="accent1"/>
+          </a:effectRef>
+          <a:fontRef idx="minor">
+            <a:schemeClr val="lt1"/>
+          </a:fontRef>
+        </p:style>
+        <p:txBody>
+          <a:bodyPr rtlCol="0" anchor="ctr" wrap="square"/>
+          <a:lstStyle/>
+          <a:p>
+            <a:pPr algn="ctr"/>
+            <a:r>
+              <a:rPr sz="1150">
+                <a:solidFill>
+                  <a:srgbClr val="222222"/>
+                </a:solidFill>
+                <a:latin typeface="Consolas"/>
+              </a:rPr>
+              <a:t># chỉ cần đổi 1 DÒNG (nb 00 so sánh cả 3)</a:t>
+            </a:r>
+          </a:p>
+          <a:p>
+            <a:r>
+              <a:rPr sz="1150">
+                <a:solidFill>
+                  <a:srgbClr val="222222"/>
+                </a:solidFill>
+                <a:latin typeface="Consolas"/>
+              </a:rPr>
+              <a:t>nn.RNN (2, 64)   # thường — quên dài hạn</a:t>
+            </a:r>
+          </a:p>
+          <a:p>
+            <a:r>
+              <a:rPr sz="1150">
+                <a:solidFill>
+                  <a:srgbClr val="222222"/>
+                </a:solidFill>
+                <a:latin typeface="Consolas"/>
+              </a:rPr>
+              <a:t>nn.LSTM(2, 64)   # nhớ dài hạn (5 cổng)</a:t>
+            </a:r>
+          </a:p>
+          <a:p>
+            <a:r>
+              <a:rPr sz="1150">
+                <a:solidFill>
+                  <a:srgbClr val="222222"/>
+                </a:solidFill>
+                <a:latin typeface="Consolas"/>
+              </a:rPr>
+              <a:t>nn.GRU (2, 64)   # gọn, nhanh (2 cổng)</a:t>
+            </a:r>
+          </a:p>
+        </p:txBody>
+      </p:sp>
     </p:spTree>
   </p:cSld>
   <p:clrMapOvr>

</xml_diff>

<commit_message>
feat: add math intro slides (tanh/sigmoid/derivative rules), now 11 slides with updated script
</commit_message>
<xml_diff>
--- a/asm06/slides/rnn.pptx
+++ b/asm06/slides/rnn.pptx
@@ -14,6 +14,8 @@
     <p:sldId id="262" r:id="rId14"/>
     <p:sldId id="263" r:id="rId15"/>
     <p:sldId id="264" r:id="rId16"/>
+    <p:sldId id="265" r:id="rId17"/>
+    <p:sldId id="266" r:id="rId18"/>
   </p:sldIdLst>
   <p:sldSz cx="12193200" cy="6858000" type="screen4x3"/>
   <p:notesSz cx="6858000" cy="9144000"/>
@@ -510,7 +512,147 @@
           <a:lstStyle/>
           <a:p>
             <a:r>
-              <a:t>Slide 1/9 — Dữ liệu chuỗi có thứ tự; mạng thường không nhớ → cần RNN. Hàm make_windows cắt cửa sổ 30 ngày</a:t>
+              <a:t>Slide 1/11 — Dữ liệu chuỗi có thứ tự; mạng thường không nhớ → cần RNN. Hàm make_windows cắt cửa sổ 30 ngày</a:t>
+            </a:r>
+          </a:p>
+        </p:txBody>
+      </p:sp>
+      <p:sp>
+        <p:nvSpPr>
+          <p:cNvPr id="4" name="Slide Number Placeholder 3"/>
+          <p:cNvSpPr>
+            <a:spLocks noGrp="1"/>
+          </p:cNvSpPr>
+          <p:nvPr>
+            <p:ph type="sldNum" idx="5" sz="quarter"/>
+          </p:nvPr>
+        </p:nvSpPr>
+        <p:spPr/>
+      </p:sp>
+    </p:spTree>
+  </p:cSld>
+  <p:clrMapOvr>
+    <a:masterClrMapping/>
+  </p:clrMapOvr>
+</p:notes>
+</file>
+
+<file path=ppt/notesSlides/notesSlide10.xml><?xml version="1.0" encoding="utf-8"?>
+<p:notes xmlns:a="http://schemas.openxmlformats.org/drawingml/2006/main" xmlns:p="http://schemas.openxmlformats.org/presentationml/2006/main" xmlns:r="http://schemas.openxmlformats.org/officeDocument/2006/relationships">
+  <p:cSld>
+    <p:spTree>
+      <p:nvGrpSpPr>
+        <p:cNvPr id="1" name=""/>
+        <p:cNvGrpSpPr/>
+        <p:nvPr/>
+      </p:nvGrpSpPr>
+      <p:grpSpPr>
+        <a:xfrm>
+          <a:off x="0" y="0"/>
+          <a:ext cx="0" cy="0"/>
+          <a:chOff x="0" y="0"/>
+          <a:chExt cx="0" cy="0"/>
+        </a:xfrm>
+      </p:grpSpPr>
+      <p:sp>
+        <p:nvSpPr>
+          <p:cNvPr id="2" name="Slide Image Placeholder 1"/>
+          <p:cNvSpPr>
+            <a:spLocks noGrp="1"/>
+          </p:cNvSpPr>
+          <p:nvPr>
+            <p:ph type="sldImg" idx="2"/>
+          </p:nvPr>
+        </p:nvSpPr>
+        <p:spPr/>
+      </p:sp>
+      <p:sp>
+        <p:nvSpPr>
+          <p:cNvPr id="3" name="Notes Placeholder 2"/>
+          <p:cNvSpPr>
+            <a:spLocks noGrp="1"/>
+          </p:cNvSpPr>
+          <p:nvPr>
+            <p:ph type="body" idx="3" sz="quarter"/>
+          </p:nvPr>
+        </p:nvSpPr>
+        <p:spPr/>
+        <p:txBody>
+          <a:bodyPr/>
+          <a:lstStyle/>
+          <a:p>
+            <a:r>
+              <a:t>Slide 10/11 — Dự báo Δ residual (giá mai = giá nay + Δ̂, guard ±3σ) thắng naive trên cả 2 tập</a:t>
+            </a:r>
+          </a:p>
+        </p:txBody>
+      </p:sp>
+      <p:sp>
+        <p:nvSpPr>
+          <p:cNvPr id="4" name="Slide Number Placeholder 3"/>
+          <p:cNvSpPr>
+            <a:spLocks noGrp="1"/>
+          </p:cNvSpPr>
+          <p:nvPr>
+            <p:ph type="sldNum" idx="5" sz="quarter"/>
+          </p:nvPr>
+        </p:nvSpPr>
+        <p:spPr/>
+      </p:sp>
+    </p:spTree>
+  </p:cSld>
+  <p:clrMapOvr>
+    <a:masterClrMapping/>
+  </p:clrMapOvr>
+</p:notes>
+</file>
+
+<file path=ppt/notesSlides/notesSlide11.xml><?xml version="1.0" encoding="utf-8"?>
+<p:notes xmlns:a="http://schemas.openxmlformats.org/drawingml/2006/main" xmlns:p="http://schemas.openxmlformats.org/presentationml/2006/main" xmlns:r="http://schemas.openxmlformats.org/officeDocument/2006/relationships">
+  <p:cSld>
+    <p:spTree>
+      <p:nvGrpSpPr>
+        <p:cNvPr id="1" name=""/>
+        <p:cNvGrpSpPr/>
+        <p:nvPr/>
+      </p:nvGrpSpPr>
+      <p:grpSpPr>
+        <a:xfrm>
+          <a:off x="0" y="0"/>
+          <a:ext cx="0" cy="0"/>
+          <a:chOff x="0" y="0"/>
+          <a:chExt cx="0" cy="0"/>
+        </a:xfrm>
+      </p:grpSpPr>
+      <p:sp>
+        <p:nvSpPr>
+          <p:cNvPr id="2" name="Slide Image Placeholder 1"/>
+          <p:cNvSpPr>
+            <a:spLocks noGrp="1"/>
+          </p:cNvSpPr>
+          <p:nvPr>
+            <p:ph type="sldImg" idx="2"/>
+          </p:nvPr>
+        </p:nvSpPr>
+        <p:spPr/>
+      </p:sp>
+      <p:sp>
+        <p:nvSpPr>
+          <p:cNvPr id="3" name="Notes Placeholder 2"/>
+          <p:cNvSpPr>
+            <a:spLocks noGrp="1"/>
+          </p:cNvSpPr>
+          <p:nvPr>
+            <p:ph type="body" idx="3" sz="quarter"/>
+          </p:nvPr>
+        </p:nvSpPr>
+        <p:spPr/>
+        <p:txBody>
+          <a:bodyPr/>
+          <a:lstStyle/>
+          <a:p>
+            <a:r>
+              <a:t>Slide 11/11 — LSTM 5 cổng + băng chuyền c_t (gradient qua phép CỘNG); GRU bản gọn 2 cổng; đổi 1 dòng code</a:t>
             </a:r>
           </a:p>
         </p:txBody>
@@ -580,7 +722,7 @@
           <a:lstStyle/>
           <a:p>
             <a:r>
-              <a:t>Slide 2/9 — h_t là trí nhớ; lặp CÙNG trọng số qua từng thời điểm. Hàm rnn_cell = 1 bước, comment từng dòng</a:t>
+              <a:t>Slide 2/11 — h_t là trí nhớ; lặp CÙNG trọng số qua từng thời điểm. Hàm rnn_cell = 1 bước, comment từng dòng</a:t>
             </a:r>
           </a:p>
         </p:txBody>
@@ -650,7 +792,7 @@
           <a:lstStyle/>
           <a:p>
             <a:r>
-              <a:t>Slide 3/9 — Công thức trung tâm + vai trò 3 ma trận + tên gọi tương ứng trong PyTorch/Keras</a:t>
+              <a:t>Slide 3/11 — Toán của các hàm: tanh (e^z), sigmoid, ⊙ — công thức, miền giá trị, đạo hàm, bão hòa; vì sao RNN chọn tanh</a:t>
             </a:r>
           </a:p>
         </p:txBody>
@@ -720,7 +862,7 @@
           <a:lstStyle/>
           <a:p>
             <a:r>
-              <a:t>Slide 4/9 — Ví dụ số nhỏ chạy tay 1 bước — 4 dòng trong bảng = 4 phép tính, code sinh đúng số đó</a:t>
+              <a:t>Slide 4/11 — 3 công cụ đạo hàm — chain rule, affine, tanh — BPTT (slide 8) chỉ là lắp chúng theo thời gian</a:t>
             </a:r>
           </a:p>
         </p:txBody>
@@ -790,7 +932,7 @@
           <a:lstStyle/>
           <a:p>
             <a:r>
-              <a:t>Slide 5/9 — 4 hàm tiền xử lý: load+sort → chia chrono → MinMax fit train → make_windows + guard ±3σ</a:t>
+              <a:t>Slide 5/11 — Công thức trung tâm + vai trò 3 ma trận + tên gọi tương ứng trong PyTorch/Keras</a:t>
             </a:r>
           </a:p>
         </p:txBody>
@@ -860,7 +1002,7 @@
           <a:lstStyle/>
           <a:p>
             <a:r>
-              <a:t>Slide 6/9 — BPTT: gradient chảy ngược thời gian, mỗi bước nhân thêm U^T·diag(1−tanh²) → ‖U‖&lt;1 biến mất, &gt;1 bùng nổ</a:t>
+              <a:t>Slide 6/11 — Ví dụ số nhỏ chạy tay 1 bước — 4 dòng trong bảng = 4 phép tính, code sinh đúng số đó</a:t>
             </a:r>
           </a:p>
         </p:txBody>
@@ -930,7 +1072,7 @@
           <a:lstStyle/>
           <a:p>
             <a:r>
-              <a:t>Slide 7/9 — Vòng lặp huấn luyện notebook 01 — từng lệnh đánh số ①→⑧; phải: bảng vai trò từng lệnh</a:t>
+              <a:t>Slide 7/11 — 4 hàm tiền xử lý: load+sort → chia chrono → MinMax fit train → make_windows + guard ±3σ</a:t>
             </a:r>
           </a:p>
         </p:txBody>
@@ -1000,7 +1142,7 @@
           <a:lstStyle/>
           <a:p>
             <a:r>
-              <a:t>Slide 8/9 — Dự báo Δ residual (giá mai = giá nay + Δ̂, guard ±3σ) thắng naive trên cả 2 tập</a:t>
+              <a:t>Slide 8/11 — BPTT: gradient chảy ngược thời gian, mỗi bước nhân thêm U^T·diag(1−tanh²) → ‖U‖&lt;1 biến mất, &gt;1 bùng nổ</a:t>
             </a:r>
           </a:p>
         </p:txBody>
@@ -1070,7 +1212,7 @@
           <a:lstStyle/>
           <a:p>
             <a:r>
-              <a:t>Slide 9/9 — LSTM 5 cổng + băng chuyền c_t (gradient qua phép CỘNG); GRU bản gọn 2 cổng; đổi 1 dòng code</a:t>
+              <a:t>Slide 9/11 — Vòng lặp huấn luyện notebook 01 — từng lệnh đánh số ①→⑧; phải: bảng vai trò từng lệnh</a:t>
             </a:r>
           </a:p>
         </p:txBody>
@@ -4512,7 +4654,7 @@
 </p:sld>
 </file>
 
-<file path=ppt/slides/slide2.xml><?xml version="1.0" encoding="utf-8"?>
+<file path=ppt/slides/slide10.xml><?xml version="1.0" encoding="utf-8"?>
 <p:sld xmlns:a="http://schemas.openxmlformats.org/drawingml/2006/main" xmlns:p="http://schemas.openxmlformats.org/presentationml/2006/main" xmlns:r="http://schemas.openxmlformats.org/officeDocument/2006/relationships">
   <p:cSld>
     <p:spTree>
@@ -4596,6 +4738,1271 @@
                 </a:solidFill>
                 <a:latin typeface="Calibri"/>
               </a:rPr>
+              <a:t>10. Áp dụng: dự đoán giá ngày mai trên 2 tập dữ liệu thật</a:t>
+            </a:r>
+          </a:p>
+        </p:txBody>
+      </p:sp>
+      <p:sp>
+        <p:nvSpPr>
+          <p:cNvPr id="4" name="Rectangle 3"/>
+          <p:cNvSpPr/>
+          <p:nvPr/>
+        </p:nvSpPr>
+        <p:spPr>
+          <a:xfrm>
+            <a:off x="432000" y="1188000"/>
+            <a:ext cx="5832000" cy="4320000"/>
+          </a:xfrm>
+          <a:prstGeom prst="rect">
+            <a:avLst/>
+          </a:prstGeom>
+          <a:solidFill>
+            <a:srgbClr val="F2F2F2"/>
+          </a:solidFill>
+          <a:ln>
+            <a:noFill/>
+          </a:ln>
+          <a:effectLst/>
+        </p:spPr>
+        <p:style>
+          <a:lnRef idx="1">
+            <a:schemeClr val="accent1"/>
+          </a:lnRef>
+          <a:fillRef idx="3">
+            <a:schemeClr val="accent1"/>
+          </a:fillRef>
+          <a:effectRef idx="2">
+            <a:schemeClr val="accent1"/>
+          </a:effectRef>
+          <a:fontRef idx="minor">
+            <a:schemeClr val="lt1"/>
+          </a:fontRef>
+        </p:style>
+        <p:txBody>
+          <a:bodyPr rtlCol="0" anchor="ctr" wrap="square"/>
+          <a:lstStyle/>
+          <a:p>
+            <a:pPr algn="ctr"/>
+            <a:r>
+              <a:rPr sz="1150">
+                <a:solidFill>
+                  <a:srgbClr val="222222"/>
+                </a:solidFill>
+                <a:latin typeface="Consolas"/>
+              </a:rPr>
+              <a:t># MẸO THEN CHỐT: dự báo Δ, không dự báo mức giá</a:t>
+            </a:r>
+          </a:p>
+          <a:p>
+            <a:r>
+              <a:rPr sz="1150">
+                <a:solidFill>
+                  <a:srgbClr val="222222"/>
+                </a:solidFill>
+                <a:latin typeface="Consolas"/>
+              </a:rPr>
+              <a:t># mức giá thua naive 2–5× (train giá thấp, test giá cao)</a:t>
+            </a:r>
+          </a:p>
+          <a:p>
+            <a:r>
+              <a:rPr sz="1150">
+                <a:solidFill>
+                  <a:srgbClr val="222222"/>
+                </a:solidFill>
+                <a:latin typeface="Consolas"/>
+              </a:rPr>
+              <a:t/>
+            </a:r>
+          </a:p>
+          <a:p>
+            <a:r>
+              <a:rPr sz="1150">
+                <a:solidFill>
+                  <a:srgbClr val="222222"/>
+                </a:solidFill>
+                <a:latin typeface="Consolas"/>
+              </a:rPr>
+              <a:t>d_hat = model(X_test)              # Δ̂ scaled (nb 01)</a:t>
+            </a:r>
+          </a:p>
+          <a:p>
+            <a:r>
+              <a:rPr sz="1150">
+                <a:solidFill>
+                  <a:srgbClr val="222222"/>
+                </a:solidFill>
+                <a:latin typeface="Consolas"/>
+              </a:rPr>
+              <a:t>d_hat = np.clip(d_hat, -BOUND, BOUND)</a:t>
+            </a:r>
+          </a:p>
+          <a:p>
+            <a:r>
+              <a:rPr sz="1150">
+                <a:solidFill>
+                  <a:srgbClr val="222222"/>
+                </a:solidFill>
+                <a:latin typeface="Consolas"/>
+              </a:rPr>
+              <a:t>        # chặn dự báo trong cùng biên ±3σ</a:t>
+            </a:r>
+          </a:p>
+          <a:p>
+            <a:r>
+              <a:rPr sz="1150">
+                <a:solidFill>
+                  <a:srgbClr val="222222"/>
+                </a:solidFill>
+                <a:latin typeface="Consolas"/>
+              </a:rPr>
+              <a:t/>
+            </a:r>
+          </a:p>
+          <a:p>
+            <a:r>
+              <a:rPr sz="1150">
+                <a:solidFill>
+                  <a:srgbClr val="222222"/>
+                </a:solidFill>
+                <a:latin typeface="Consolas"/>
+              </a:rPr>
+              <a:t>z_prev = z[cuối_cửa_sổ, 0]         # giá "hôm nay"</a:t>
+            </a:r>
+          </a:p>
+          <a:p>
+            <a:r>
+              <a:rPr sz="1150">
+                <a:solidFill>
+                  <a:srgbClr val="222222"/>
+                </a:solidFill>
+                <a:latin typeface="Consolas"/>
+              </a:rPr>
+              <a:t>p_hat  = inverse_gold(z_prev + d_hat)</a:t>
+            </a:r>
+          </a:p>
+          <a:p>
+            <a:r>
+              <a:rPr sz="1150">
+                <a:solidFill>
+                  <a:srgbClr val="222222"/>
+                </a:solidFill>
+                <a:latin typeface="Consolas"/>
+              </a:rPr>
+              <a:t>        # giá mai = giá nay + Δ̂ → inverse → USD</a:t>
+            </a:r>
+          </a:p>
+          <a:p>
+            <a:r>
+              <a:rPr sz="1150">
+                <a:solidFill>
+                  <a:srgbClr val="222222"/>
+                </a:solidFill>
+                <a:latin typeface="Consolas"/>
+              </a:rPr>
+              <a:t/>
+            </a:r>
+          </a:p>
+          <a:p>
+            <a:r>
+              <a:rPr sz="1150">
+                <a:solidFill>
+                  <a:srgbClr val="222222"/>
+                </a:solidFill>
+                <a:latin typeface="Consolas"/>
+              </a:rPr>
+              <a:t>def inverse_gold(y_s, scaler):     # đệm cột bạc = 0</a:t>
+            </a:r>
+          </a:p>
+          <a:p>
+            <a:r>
+              <a:rPr sz="1150">
+                <a:solidFill>
+                  <a:srgbClr val="222222"/>
+                </a:solidFill>
+                <a:latin typeface="Consolas"/>
+              </a:rPr>
+              <a:t>    d = np.zeros((len(y_s), 2))    # rồi inverse_transform</a:t>
+            </a:r>
+          </a:p>
+          <a:p>
+            <a:r>
+              <a:rPr sz="1150">
+                <a:solidFill>
+                  <a:srgbClr val="222222"/>
+                </a:solidFill>
+                <a:latin typeface="Consolas"/>
+              </a:rPr>
+              <a:t>    d[:, 0] = y_s                  # lấy cột vàng</a:t>
+            </a:r>
+          </a:p>
+          <a:p>
+            <a:r>
+              <a:rPr sz="1150">
+                <a:solidFill>
+                  <a:srgbClr val="222222"/>
+                </a:solidFill>
+                <a:latin typeface="Consolas"/>
+              </a:rPr>
+              <a:t>    return scaler.inverse_transform(d)[:, 0]</a:t>
+            </a:r>
+          </a:p>
+        </p:txBody>
+      </p:sp>
+      <p:graphicFrame>
+        <p:nvGraphicFramePr>
+          <p:cNvPr id="5" name="Table 4"/>
+          <p:cNvGraphicFramePr>
+            <a:graphicFrameLocks noGrp="1"/>
+          </p:cNvGraphicFramePr>
+          <p:nvPr/>
+        </p:nvGraphicFramePr>
+        <p:xfrm>
+          <a:off x="6552000" y="1224000"/>
+          <a:ext cx="5183998" cy="1800000"/>
+        </p:xfrm>
+        <a:graphic>
+          <a:graphicData uri="http://schemas.openxmlformats.org/drawingml/2006/table">
+            <a:tbl>
+              <a:tblPr firstRow="1" bandRow="1">
+                <a:tableStyleId>{5C22544A-7EE6-4342-B048-85BDC9FD1C3A}</a:tableStyleId>
+              </a:tblPr>
+              <a:tblGrid>
+                <a:gridCol w="1993846"/>
+                <a:gridCol w="1063384"/>
+                <a:gridCol w="1063384"/>
+                <a:gridCol w="1063384"/>
+              </a:tblGrid>
+              <a:tr h="600000">
+                <a:tc>
+                  <a:txBody>
+                    <a:bodyPr/>
+                    <a:lstStyle/>
+                    <a:p>
+                      <a:r>
+                        <a:rPr sz="1300" b="1">
+                          <a:solidFill>
+                            <a:srgbClr val="FFFFFF"/>
+                          </a:solidFill>
+                        </a:rPr>
+                        <a:t>Tập dữ liệu (RMSE test)</a:t>
+                      </a:r>
+                    </a:p>
+                  </a:txBody>
+                  <a:tcPr>
+                    <a:solidFill>
+                      <a:srgbClr val="1E3A8A"/>
+                    </a:solidFill>
+                  </a:tcPr>
+                </a:tc>
+                <a:tc>
+                  <a:txBody>
+                    <a:bodyPr/>
+                    <a:lstStyle/>
+                    <a:p>
+                      <a:r>
+                        <a:rPr sz="1300" b="1">
+                          <a:solidFill>
+                            <a:srgbClr val="FFFFFF"/>
+                          </a:solidFill>
+                        </a:rPr>
+                        <a:t>PyTorch</a:t>
+                      </a:r>
+                    </a:p>
+                  </a:txBody>
+                  <a:tcPr>
+                    <a:solidFill>
+                      <a:srgbClr val="1E3A8A"/>
+                    </a:solidFill>
+                  </a:tcPr>
+                </a:tc>
+                <a:tc>
+                  <a:txBody>
+                    <a:bodyPr/>
+                    <a:lstStyle/>
+                    <a:p>
+                      <a:r>
+                        <a:rPr sz="1300" b="1">
+                          <a:solidFill>
+                            <a:srgbClr val="FFFFFF"/>
+                          </a:solidFill>
+                        </a:rPr>
+                        <a:t>Keras</a:t>
+                      </a:r>
+                    </a:p>
+                  </a:txBody>
+                  <a:tcPr>
+                    <a:solidFill>
+                      <a:srgbClr val="1E3A8A"/>
+                    </a:solidFill>
+                  </a:tcPr>
+                </a:tc>
+                <a:tc>
+                  <a:txBody>
+                    <a:bodyPr/>
+                    <a:lstStyle/>
+                    <a:p>
+                      <a:r>
+                        <a:rPr sz="1300" b="1">
+                          <a:solidFill>
+                            <a:srgbClr val="FFFFFF"/>
+                          </a:solidFill>
+                        </a:rPr>
+                        <a:t>Naive</a:t>
+                      </a:r>
+                    </a:p>
+                  </a:txBody>
+                  <a:tcPr>
+                    <a:solidFill>
+                      <a:srgbClr val="1E3A8A"/>
+                    </a:solidFill>
+                  </a:tcPr>
+                </a:tc>
+              </a:tr>
+              <a:tr h="600000">
+                <a:tc>
+                  <a:txBody>
+                    <a:bodyPr/>
+                    <a:lstStyle/>
+                    <a:p>
+                      <a:r>
+                        <a:rPr sz="1300" b="0">
+                          <a:solidFill>
+                            <a:srgbClr val="222222"/>
+                          </a:solidFill>
+                        </a:rPr>
+                        <a:t>Giá vàng (Gold &amp; Silver)</a:t>
+                      </a:r>
+                    </a:p>
+                  </a:txBody>
+                  <a:tcPr>
+                    <a:solidFill>
+                      <a:srgbClr val="EEF2FA"/>
+                    </a:solidFill>
+                  </a:tcPr>
+                </a:tc>
+                <a:tc>
+                  <a:txBody>
+                    <a:bodyPr/>
+                    <a:lstStyle/>
+                    <a:p>
+                      <a:r>
+                        <a:rPr sz="1300" b="0">
+                          <a:solidFill>
+                            <a:srgbClr val="222222"/>
+                          </a:solidFill>
+                        </a:rPr>
+                        <a:t>15.45</a:t>
+                      </a:r>
+                    </a:p>
+                  </a:txBody>
+                  <a:tcPr>
+                    <a:solidFill>
+                      <a:srgbClr val="EEF2FA"/>
+                    </a:solidFill>
+                  </a:tcPr>
+                </a:tc>
+                <a:tc>
+                  <a:txBody>
+                    <a:bodyPr/>
+                    <a:lstStyle/>
+                    <a:p>
+                      <a:r>
+                        <a:rPr sz="1300" b="0">
+                          <a:solidFill>
+                            <a:srgbClr val="222222"/>
+                          </a:solidFill>
+                        </a:rPr>
+                        <a:t>16.42</a:t>
+                      </a:r>
+                    </a:p>
+                  </a:txBody>
+                  <a:tcPr>
+                    <a:solidFill>
+                      <a:srgbClr val="EEF2FA"/>
+                    </a:solidFill>
+                  </a:tcPr>
+                </a:tc>
+                <a:tc>
+                  <a:txBody>
+                    <a:bodyPr/>
+                    <a:lstStyle/>
+                    <a:p>
+                      <a:r>
+                        <a:rPr sz="1300" b="0">
+                          <a:solidFill>
+                            <a:srgbClr val="222222"/>
+                          </a:solidFill>
+                        </a:rPr>
+                        <a:t>15.48</a:t>
+                      </a:r>
+                    </a:p>
+                  </a:txBody>
+                  <a:tcPr>
+                    <a:solidFill>
+                      <a:srgbClr val="EEF2FA"/>
+                    </a:solidFill>
+                  </a:tcPr>
+                </a:tc>
+              </a:tr>
+              <a:tr h="600000">
+                <a:tc>
+                  <a:txBody>
+                    <a:bodyPr/>
+                    <a:lstStyle/>
+                    <a:p>
+                      <a:r>
+                        <a:rPr sz="1300" b="0">
+                          <a:solidFill>
+                            <a:srgbClr val="222222"/>
+                          </a:solidFill>
+                        </a:rPr>
+                        <a:t>Cổ phiếu AMZN</a:t>
+                      </a:r>
+                    </a:p>
+                  </a:txBody>
+                  <a:tcPr>
+                    <a:solidFill>
+                      <a:srgbClr val="FFFFFF"/>
+                    </a:solidFill>
+                  </a:tcPr>
+                </a:tc>
+                <a:tc>
+                  <a:txBody>
+                    <a:bodyPr/>
+                    <a:lstStyle/>
+                    <a:p>
+                      <a:r>
+                        <a:rPr sz="1300" b="0">
+                          <a:solidFill>
+                            <a:srgbClr val="222222"/>
+                          </a:solidFill>
+                        </a:rPr>
+                        <a:t>3.13</a:t>
+                      </a:r>
+                    </a:p>
+                  </a:txBody>
+                  <a:tcPr>
+                    <a:solidFill>
+                      <a:srgbClr val="FFFFFF"/>
+                    </a:solidFill>
+                  </a:tcPr>
+                </a:tc>
+                <a:tc>
+                  <a:txBody>
+                    <a:bodyPr/>
+                    <a:lstStyle/>
+                    <a:p>
+                      <a:r>
+                        <a:rPr sz="1300" b="0">
+                          <a:solidFill>
+                            <a:srgbClr val="222222"/>
+                          </a:solidFill>
+                        </a:rPr>
+                        <a:t>3.18</a:t>
+                      </a:r>
+                    </a:p>
+                  </a:txBody>
+                  <a:tcPr>
+                    <a:solidFill>
+                      <a:srgbClr val="FFFFFF"/>
+                    </a:solidFill>
+                  </a:tcPr>
+                </a:tc>
+                <a:tc>
+                  <a:txBody>
+                    <a:bodyPr/>
+                    <a:lstStyle/>
+                    <a:p>
+                      <a:r>
+                        <a:rPr sz="1300" b="0">
+                          <a:solidFill>
+                            <a:srgbClr val="222222"/>
+                          </a:solidFill>
+                        </a:rPr>
+                        <a:t>3.14</a:t>
+                      </a:r>
+                    </a:p>
+                  </a:txBody>
+                  <a:tcPr>
+                    <a:solidFill>
+                      <a:srgbClr val="FFFFFF"/>
+                    </a:solidFill>
+                  </a:tcPr>
+                </a:tc>
+              </a:tr>
+            </a:tbl>
+          </a:graphicData>
+        </a:graphic>
+      </p:graphicFrame>
+      <p:sp>
+        <p:nvSpPr>
+          <p:cNvPr id="6" name="TextBox 5"/>
+          <p:cNvSpPr txBox="1"/>
+          <p:nvPr/>
+        </p:nvSpPr>
+        <p:spPr>
+          <a:xfrm>
+            <a:off x="6552000" y="3240000"/>
+            <a:ext cx="5184000" cy="2160000"/>
+          </a:xfrm>
+          <a:prstGeom prst="rect">
+            <a:avLst/>
+          </a:prstGeom>
+          <a:noFill/>
+        </p:spPr>
+        <p:txBody>
+          <a:bodyPr wrap="square">
+            <a:spAutoFit/>
+          </a:bodyPr>
+          <a:lstStyle/>
+          <a:p>
+            <a:pPr algn="l"/>
+            <a:r>
+              <a:rPr sz="1400" b="1">
+                <a:solidFill>
+                  <a:srgbClr val="1E3A8A"/>
+                </a:solidFill>
+                <a:latin typeface="Calibri"/>
+              </a:rPr>
+              <a:t>Naive = dự báo “ngày mai giống hôm nay”.</a:t>
+            </a:r>
+          </a:p>
+          <a:p>
+            <a:pPr algn="l"/>
+            <a:r>
+              <a:rPr sz="1400" b="1">
+                <a:solidFill>
+                  <a:srgbClr val="1E3A8A"/>
+                </a:solidFill>
+                <a:latin typeface="Calibri"/>
+              </a:rPr>
+              <a:t>RNN thắng baseline này trên cả 2 tập (R² ≥ 0.99,</a:t>
+            </a:r>
+          </a:p>
+          <a:p>
+            <a:pPr algn="l"/>
+            <a:r>
+              <a:rPr sz="1400" b="1">
+                <a:solidFill>
+                  <a:srgbClr val="1E3A8A"/>
+                </a:solidFill>
+                <a:latin typeface="Calibri"/>
+              </a:rPr>
+              <a:t>MAPE 0.6–1.8%) — chỉ khi dự báo Δ residual.</a:t>
+            </a:r>
+          </a:p>
+          <a:p>
+            <a:pPr algn="l"/>
+            <a:r>
+              <a:rPr sz="1400" b="1">
+                <a:solidFill>
+                  <a:srgbClr val="1E3A8A"/>
+                </a:solidFill>
+                <a:latin typeface="Calibri"/>
+              </a:rPr>
+              <a:t/>
+            </a:r>
+          </a:p>
+          <a:p>
+            <a:pPr algn="l"/>
+            <a:r>
+              <a:rPr sz="1400" b="1">
+                <a:solidFill>
+                  <a:srgbClr val="1E3A8A"/>
+                </a:solidFill>
+                <a:latin typeface="Calibri"/>
+              </a:rPr>
+              <a:t>Dự báo thẳng MỨC GIÁ: RMSE thua naive 2–5×</a:t>
+            </a:r>
+          </a:p>
+          <a:p>
+            <a:pPr algn="l"/>
+            <a:r>
+              <a:rPr sz="1400" b="1">
+                <a:solidFill>
+                  <a:srgbClr val="1E3A8A"/>
+                </a:solidFill>
+                <a:latin typeface="Calibri"/>
+              </a:rPr>
+              <a:t>vì network bị kéo về trung bình giá train.</a:t>
+            </a:r>
+          </a:p>
+          <a:p>
+            <a:pPr algn="l"/>
+            <a:r>
+              <a:rPr sz="1400" b="1">
+                <a:solidFill>
+                  <a:srgbClr val="1E3A8A"/>
+                </a:solidFill>
+                <a:latin typeface="Calibri"/>
+              </a:rPr>
+              <a:t>Kỹ thuật Δ nhất quán ở cả 4 notebook.</a:t>
+            </a:r>
+          </a:p>
+        </p:txBody>
+      </p:sp>
+    </p:spTree>
+  </p:cSld>
+  <p:clrMapOvr>
+    <a:masterClrMapping/>
+  </p:clrMapOvr>
+</p:sld>
+</file>
+
+<file path=ppt/slides/slide11.xml><?xml version="1.0" encoding="utf-8"?>
+<p:sld xmlns:a="http://schemas.openxmlformats.org/drawingml/2006/main" xmlns:p="http://schemas.openxmlformats.org/presentationml/2006/main" xmlns:r="http://schemas.openxmlformats.org/officeDocument/2006/relationships">
+  <p:cSld>
+    <p:spTree>
+      <p:nvGrpSpPr>
+        <p:cNvPr id="1" name=""/>
+        <p:cNvGrpSpPr/>
+        <p:nvPr/>
+      </p:nvGrpSpPr>
+      <p:grpSpPr/>
+      <p:sp>
+        <p:nvSpPr>
+          <p:cNvPr id="2" name="Rectangle 1"/>
+          <p:cNvSpPr/>
+          <p:nvPr/>
+        </p:nvSpPr>
+        <p:spPr>
+          <a:xfrm>
+            <a:off x="0" y="0"/>
+            <a:ext cx="12193200" cy="792000"/>
+          </a:xfrm>
+          <a:prstGeom prst="rect">
+            <a:avLst/>
+          </a:prstGeom>
+          <a:solidFill>
+            <a:srgbClr val="1E3A8A"/>
+          </a:solidFill>
+          <a:ln>
+            <a:noFill/>
+          </a:ln>
+          <a:effectLst/>
+        </p:spPr>
+        <p:style>
+          <a:lnRef idx="1">
+            <a:schemeClr val="accent1"/>
+          </a:lnRef>
+          <a:fillRef idx="3">
+            <a:schemeClr val="accent1"/>
+          </a:fillRef>
+          <a:effectRef idx="2">
+            <a:schemeClr val="accent1"/>
+          </a:effectRef>
+          <a:fontRef idx="minor">
+            <a:schemeClr val="lt1"/>
+          </a:fontRef>
+        </p:style>
+        <p:txBody>
+          <a:bodyPr rtlCol="0" anchor="ctr"/>
+          <a:lstStyle/>
+          <a:p>
+            <a:pPr algn="ctr"/>
+          </a:p>
+        </p:txBody>
+      </p:sp>
+      <p:sp>
+        <p:nvSpPr>
+          <p:cNvPr id="3" name="TextBox 2"/>
+          <p:cNvSpPr txBox="1"/>
+          <p:nvPr/>
+        </p:nvSpPr>
+        <p:spPr>
+          <a:xfrm>
+            <a:off x="288000" y="125999"/>
+            <a:ext cx="11617200" cy="540000"/>
+          </a:xfrm>
+          <a:prstGeom prst="rect">
+            <a:avLst/>
+          </a:prstGeom>
+          <a:noFill/>
+        </p:spPr>
+        <p:txBody>
+          <a:bodyPr wrap="square">
+            <a:spAutoFit/>
+          </a:bodyPr>
+          <a:lstStyle/>
+          <a:p>
+            <a:pPr algn="l"/>
+            <a:r>
+              <a:rPr sz="2600" b="1">
+                <a:solidFill>
+                  <a:srgbClr val="FFFFFF"/>
+                </a:solidFill>
+                <a:latin typeface="Calibri"/>
+              </a:rPr>
+              <a:t>11. Hạn chế của RNN &amp; mô hình phát triển: LSTM, GRU</a:t>
+            </a:r>
+          </a:p>
+        </p:txBody>
+      </p:sp>
+      <p:sp>
+        <p:nvSpPr>
+          <p:cNvPr id="4" name="TextBox 3"/>
+          <p:cNvSpPr txBox="1"/>
+          <p:nvPr/>
+        </p:nvSpPr>
+        <p:spPr>
+          <a:xfrm>
+            <a:off x="432000" y="1080000"/>
+            <a:ext cx="11304000" cy="432000"/>
+          </a:xfrm>
+          <a:prstGeom prst="rect">
+            <a:avLst/>
+          </a:prstGeom>
+          <a:noFill/>
+        </p:spPr>
+        <p:txBody>
+          <a:bodyPr wrap="square">
+            <a:spAutoFit/>
+          </a:bodyPr>
+          <a:lstStyle/>
+          <a:p>
+            <a:pPr algn="l"/>
+            <a:r>
+              <a:rPr sz="1500" b="1">
+                <a:solidFill>
+                  <a:srgbClr val="222222"/>
+                </a:solidFill>
+                <a:latin typeface="Calibri"/>
+              </a:rPr>
+              <a:t>RNN đơn giản QUÊN quá khứ xa: gradient chỉ đi qua phép NHÂN U lặp lại → biến mất</a:t>
+            </a:r>
+          </a:p>
+        </p:txBody>
+      </p:sp>
+      <p:sp>
+        <p:nvSpPr>
+          <p:cNvPr id="5" name="TextBox 4"/>
+          <p:cNvSpPr txBox="1"/>
+          <p:nvPr/>
+        </p:nvSpPr>
+        <p:spPr>
+          <a:xfrm>
+            <a:off x="432000" y="1512000"/>
+            <a:ext cx="11304000" cy="432000"/>
+          </a:xfrm>
+          <a:prstGeom prst="rect">
+            <a:avLst/>
+          </a:prstGeom>
+          <a:noFill/>
+        </p:spPr>
+        <p:txBody>
+          <a:bodyPr wrap="square">
+            <a:spAutoFit/>
+          </a:bodyPr>
+          <a:lstStyle/>
+          <a:p>
+            <a:pPr algn="l"/>
+            <a:r>
+              <a:rPr sz="1500" b="0">
+                <a:solidFill>
+                  <a:srgbClr val="222222"/>
+                </a:solidFill>
+                <a:latin typeface="Calibri"/>
+              </a:rPr>
+              <a:t>•  LSTM thêm băng chuyền trí nhớ c_t: gradient đi qua phép CỘNG và cổng quên → gần như nguyên vẹn</a:t>
+            </a:r>
+          </a:p>
+        </p:txBody>
+      </p:sp>
+      <p:sp>
+        <p:nvSpPr>
+          <p:cNvPr id="6" name="Rectangle 5"/>
+          <p:cNvSpPr/>
+          <p:nvPr/>
+        </p:nvSpPr>
+        <p:spPr>
+          <a:xfrm>
+            <a:off x="432000" y="2015999"/>
+            <a:ext cx="5688000" cy="4104000"/>
+          </a:xfrm>
+          <a:prstGeom prst="rect">
+            <a:avLst/>
+          </a:prstGeom>
+          <a:solidFill>
+            <a:srgbClr val="F2F2F2"/>
+          </a:solidFill>
+          <a:ln>
+            <a:noFill/>
+          </a:ln>
+          <a:effectLst/>
+        </p:spPr>
+        <p:style>
+          <a:lnRef idx="1">
+            <a:schemeClr val="accent1"/>
+          </a:lnRef>
+          <a:fillRef idx="3">
+            <a:schemeClr val="accent1"/>
+          </a:fillRef>
+          <a:effectRef idx="2">
+            <a:schemeClr val="accent1"/>
+          </a:effectRef>
+          <a:fontRef idx="minor">
+            <a:schemeClr val="lt1"/>
+          </a:fontRef>
+        </p:style>
+        <p:txBody>
+          <a:bodyPr rtlCol="0" anchor="ctr" wrap="square"/>
+          <a:lstStyle/>
+          <a:p>
+            <a:pPr algn="ctr"/>
+            <a:r>
+              <a:rPr sz="1150">
+                <a:solidFill>
+                  <a:srgbClr val="222222"/>
+                </a:solidFill>
+                <a:latin typeface="Consolas"/>
+              </a:rPr>
+              <a:t># LSTM — 5 cổng, σ(s)=1/(1+e^(−s)) ∈ (0,1)</a:t>
+            </a:r>
+          </a:p>
+          <a:p>
+            <a:r>
+              <a:rPr sz="1150">
+                <a:solidFill>
+                  <a:srgbClr val="222222"/>
+                </a:solidFill>
+                <a:latin typeface="Consolas"/>
+              </a:rPr>
+              <a:t>f_t = σ(W_f·[h_(t−1),x_t] + b_f)</a:t>
+            </a:r>
+          </a:p>
+          <a:p>
+            <a:r>
+              <a:rPr sz="1150">
+                <a:solidFill>
+                  <a:srgbClr val="222222"/>
+                </a:solidFill>
+                <a:latin typeface="Consolas"/>
+              </a:rPr>
+              <a:t>     # cổng QUÊN: giữ lại bao nhiêu c_(t−1)</a:t>
+            </a:r>
+          </a:p>
+          <a:p>
+            <a:r>
+              <a:rPr sz="1150">
+                <a:solidFill>
+                  <a:srgbClr val="222222"/>
+                </a:solidFill>
+                <a:latin typeface="Consolas"/>
+              </a:rPr>
+              <a:t>i_t = σ(W_i·[h_(t−1),x_t] + b_i)</a:t>
+            </a:r>
+          </a:p>
+          <a:p>
+            <a:r>
+              <a:rPr sz="1150">
+                <a:solidFill>
+                  <a:srgbClr val="222222"/>
+                </a:solidFill>
+                <a:latin typeface="Consolas"/>
+              </a:rPr>
+              <a:t>     # cổng GHI: nhận bao nhiêu tin mới</a:t>
+            </a:r>
+          </a:p>
+          <a:p>
+            <a:r>
+              <a:rPr sz="1150">
+                <a:solidFill>
+                  <a:srgbClr val="222222"/>
+                </a:solidFill>
+                <a:latin typeface="Consolas"/>
+              </a:rPr>
+              <a:t>c̃_t = tanh(W_c·[h_(t−1),x_t] + b_c)</a:t>
+            </a:r>
+          </a:p>
+          <a:p>
+            <a:r>
+              <a:rPr sz="1150">
+                <a:solidFill>
+                  <a:srgbClr val="222222"/>
+                </a:solidFill>
+                <a:latin typeface="Consolas"/>
+              </a:rPr>
+              <a:t>     # nội dung mới đề xuất</a:t>
+            </a:r>
+          </a:p>
+          <a:p>
+            <a:r>
+              <a:rPr sz="1150">
+                <a:solidFill>
+                  <a:srgbClr val="222222"/>
+                </a:solidFill>
+                <a:latin typeface="Consolas"/>
+              </a:rPr>
+              <a:t>c_t = f_t ⊙ c_(t−1) + i_t ⊙ c̃_t</a:t>
+            </a:r>
+          </a:p>
+          <a:p>
+            <a:r>
+              <a:rPr sz="1150">
+                <a:solidFill>
+                  <a:srgbClr val="222222"/>
+                </a:solidFill>
+                <a:latin typeface="Consolas"/>
+              </a:rPr>
+              <a:t>     # BĂNG CHUYỀN trí nhớ dài hạn</a:t>
+            </a:r>
+          </a:p>
+          <a:p>
+            <a:r>
+              <a:rPr sz="1150">
+                <a:solidFill>
+                  <a:srgbClr val="222222"/>
+                </a:solidFill>
+                <a:latin typeface="Consolas"/>
+              </a:rPr>
+              <a:t>o_t = σ(W_o·[h_(t−1),x_t] + b_o)</a:t>
+            </a:r>
+          </a:p>
+          <a:p>
+            <a:r>
+              <a:rPr sz="1150">
+                <a:solidFill>
+                  <a:srgbClr val="222222"/>
+                </a:solidFill>
+                <a:latin typeface="Consolas"/>
+              </a:rPr>
+              <a:t>     # cổng XUẤT: lộ bao nhiêu ra ngoài</a:t>
+            </a:r>
+          </a:p>
+          <a:p>
+            <a:r>
+              <a:rPr sz="1150">
+                <a:solidFill>
+                  <a:srgbClr val="222222"/>
+                </a:solidFill>
+                <a:latin typeface="Consolas"/>
+              </a:rPr>
+              <a:t>h_t = o_t ⊙ tanh(c_t)</a:t>
+            </a:r>
+          </a:p>
+          <a:p>
+            <a:r>
+              <a:rPr sz="1150">
+                <a:solidFill>
+                  <a:srgbClr val="222222"/>
+                </a:solidFill>
+                <a:latin typeface="Consolas"/>
+              </a:rPr>
+              <a:t>     # trí nhớ ngắn hạn đưa ra ngoài</a:t>
+            </a:r>
+          </a:p>
+          <a:p>
+            <a:r>
+              <a:rPr sz="1150">
+                <a:solidFill>
+                  <a:srgbClr val="222222"/>
+                </a:solidFill>
+                <a:latin typeface="Consolas"/>
+              </a:rPr>
+              <a:t># ⊙ = nhân từng phần tử (element-wise)</a:t>
+            </a:r>
+          </a:p>
+        </p:txBody>
+      </p:sp>
+      <p:sp>
+        <p:nvSpPr>
+          <p:cNvPr id="7" name="Rectangle 6"/>
+          <p:cNvSpPr/>
+          <p:nvPr/>
+        </p:nvSpPr>
+        <p:spPr>
+          <a:xfrm>
+            <a:off x="6372000" y="2015999"/>
+            <a:ext cx="5400000" cy="2736000"/>
+          </a:xfrm>
+          <a:prstGeom prst="rect">
+            <a:avLst/>
+          </a:prstGeom>
+          <a:solidFill>
+            <a:srgbClr val="F2F2F2"/>
+          </a:solidFill>
+          <a:ln>
+            <a:noFill/>
+          </a:ln>
+          <a:effectLst/>
+        </p:spPr>
+        <p:style>
+          <a:lnRef idx="1">
+            <a:schemeClr val="accent1"/>
+          </a:lnRef>
+          <a:fillRef idx="3">
+            <a:schemeClr val="accent1"/>
+          </a:fillRef>
+          <a:effectRef idx="2">
+            <a:schemeClr val="accent1"/>
+          </a:effectRef>
+          <a:fontRef idx="minor">
+            <a:schemeClr val="lt1"/>
+          </a:fontRef>
+        </p:style>
+        <p:txBody>
+          <a:bodyPr rtlCol="0" anchor="ctr" wrap="square"/>
+          <a:lstStyle/>
+          <a:p>
+            <a:pPr algn="ctr"/>
+            <a:r>
+              <a:rPr sz="1150">
+                <a:solidFill>
+                  <a:srgbClr val="222222"/>
+                </a:solidFill>
+                <a:latin typeface="Consolas"/>
+              </a:rPr>
+              <a:t># GRU — bản gọn: gộp quên+ghi thành 2 cổng</a:t>
+            </a:r>
+          </a:p>
+          <a:p>
+            <a:r>
+              <a:rPr sz="1150">
+                <a:solidFill>
+                  <a:srgbClr val="222222"/>
+                </a:solidFill>
+                <a:latin typeface="Consolas"/>
+              </a:rPr>
+              <a:t>z_t = σ(W_z·[h_(t−1),x_t])   # cổng CẬP NHẬT</a:t>
+            </a:r>
+          </a:p>
+          <a:p>
+            <a:r>
+              <a:rPr sz="1150">
+                <a:solidFill>
+                  <a:srgbClr val="222222"/>
+                </a:solidFill>
+                <a:latin typeface="Consolas"/>
+              </a:rPr>
+              <a:t>r_t = σ(W_r·[h_(t−1),x_t])   # cổng ĐẶT LẠI</a:t>
+            </a:r>
+          </a:p>
+          <a:p>
+            <a:r>
+              <a:rPr sz="1150">
+                <a:solidFill>
+                  <a:srgbClr val="222222"/>
+                </a:solidFill>
+                <a:latin typeface="Consolas"/>
+              </a:rPr>
+              <a:t>h̃_t = tanh(W_h·[r_t ⊙ h_(t−1), x_t])</a:t>
+            </a:r>
+          </a:p>
+          <a:p>
+            <a:r>
+              <a:rPr sz="1150">
+                <a:solidFill>
+                  <a:srgbClr val="222222"/>
+                </a:solidFill>
+                <a:latin typeface="Consolas"/>
+              </a:rPr>
+              <a:t>h_t = (1−z_t) ⊙ h_(t−1) + z_t ⊙ h̃_t</a:t>
+            </a:r>
+          </a:p>
+          <a:p>
+            <a:r>
+              <a:rPr sz="1150">
+                <a:solidFill>
+                  <a:srgbClr val="222222"/>
+                </a:solidFill>
+                <a:latin typeface="Consolas"/>
+              </a:rPr>
+              <a:t># không có c_t riêng — ít tham số ~25%</a:t>
+            </a:r>
+          </a:p>
+          <a:p>
+            <a:r>
+              <a:rPr sz="1150">
+                <a:solidFill>
+                  <a:srgbClr val="222222"/>
+                </a:solidFill>
+                <a:latin typeface="Consolas"/>
+              </a:rPr>
+              <a:t># → nhanh hơn, hiệu quả tương đương</a:t>
+            </a:r>
+          </a:p>
+        </p:txBody>
+      </p:sp>
+      <p:sp>
+        <p:nvSpPr>
+          <p:cNvPr id="8" name="Rectangle 7"/>
+          <p:cNvSpPr/>
+          <p:nvPr/>
+        </p:nvSpPr>
+        <p:spPr>
+          <a:xfrm>
+            <a:off x="6372000" y="4968000"/>
+            <a:ext cx="5400000" cy="1152000"/>
+          </a:xfrm>
+          <a:prstGeom prst="rect">
+            <a:avLst/>
+          </a:prstGeom>
+          <a:solidFill>
+            <a:srgbClr val="F2F2F2"/>
+          </a:solidFill>
+          <a:ln>
+            <a:noFill/>
+          </a:ln>
+          <a:effectLst/>
+        </p:spPr>
+        <p:style>
+          <a:lnRef idx="1">
+            <a:schemeClr val="accent1"/>
+          </a:lnRef>
+          <a:fillRef idx="3">
+            <a:schemeClr val="accent1"/>
+          </a:fillRef>
+          <a:effectRef idx="2">
+            <a:schemeClr val="accent1"/>
+          </a:effectRef>
+          <a:fontRef idx="minor">
+            <a:schemeClr val="lt1"/>
+          </a:fontRef>
+        </p:style>
+        <p:txBody>
+          <a:bodyPr rtlCol="0" anchor="ctr" wrap="square"/>
+          <a:lstStyle/>
+          <a:p>
+            <a:pPr algn="ctr"/>
+            <a:r>
+              <a:rPr sz="1150">
+                <a:solidFill>
+                  <a:srgbClr val="222222"/>
+                </a:solidFill>
+                <a:latin typeface="Consolas"/>
+              </a:rPr>
+              <a:t># chỉ cần đổi 1 DÒNG (nb 00 so sánh cả 3)</a:t>
+            </a:r>
+          </a:p>
+          <a:p>
+            <a:r>
+              <a:rPr sz="1150">
+                <a:solidFill>
+                  <a:srgbClr val="222222"/>
+                </a:solidFill>
+                <a:latin typeface="Consolas"/>
+              </a:rPr>
+              <a:t>nn.RNN (2, 64)   # thường — quên dài hạn</a:t>
+            </a:r>
+          </a:p>
+          <a:p>
+            <a:r>
+              <a:rPr sz="1150">
+                <a:solidFill>
+                  <a:srgbClr val="222222"/>
+                </a:solidFill>
+                <a:latin typeface="Consolas"/>
+              </a:rPr>
+              <a:t>nn.LSTM(2, 64)   # nhớ dài hạn (5 cổng)</a:t>
+            </a:r>
+          </a:p>
+          <a:p>
+            <a:r>
+              <a:rPr sz="1150">
+                <a:solidFill>
+                  <a:srgbClr val="222222"/>
+                </a:solidFill>
+                <a:latin typeface="Consolas"/>
+              </a:rPr>
+              <a:t>nn.GRU (2, 64)   # gọn, nhanh (2 cổng)</a:t>
+            </a:r>
+          </a:p>
+        </p:txBody>
+      </p:sp>
+    </p:spTree>
+  </p:cSld>
+  <p:clrMapOvr>
+    <a:masterClrMapping/>
+  </p:clrMapOvr>
+</p:sld>
+</file>
+
+<file path=ppt/slides/slide2.xml><?xml version="1.0" encoding="utf-8"?>
+<p:sld xmlns:a="http://schemas.openxmlformats.org/drawingml/2006/main" xmlns:p="http://schemas.openxmlformats.org/presentationml/2006/main" xmlns:r="http://schemas.openxmlformats.org/officeDocument/2006/relationships">
+  <p:cSld>
+    <p:spTree>
+      <p:nvGrpSpPr>
+        <p:cNvPr id="1" name=""/>
+        <p:cNvGrpSpPr/>
+        <p:nvPr/>
+      </p:nvGrpSpPr>
+      <p:grpSpPr/>
+      <p:sp>
+        <p:nvSpPr>
+          <p:cNvPr id="2" name="Rectangle 1"/>
+          <p:cNvSpPr/>
+          <p:nvPr/>
+        </p:nvSpPr>
+        <p:spPr>
+          <a:xfrm>
+            <a:off x="0" y="0"/>
+            <a:ext cx="12193200" cy="792000"/>
+          </a:xfrm>
+          <a:prstGeom prst="rect">
+            <a:avLst/>
+          </a:prstGeom>
+          <a:solidFill>
+            <a:srgbClr val="1E3A8A"/>
+          </a:solidFill>
+          <a:ln>
+            <a:noFill/>
+          </a:ln>
+          <a:effectLst/>
+        </p:spPr>
+        <p:style>
+          <a:lnRef idx="1">
+            <a:schemeClr val="accent1"/>
+          </a:lnRef>
+          <a:fillRef idx="3">
+            <a:schemeClr val="accent1"/>
+          </a:fillRef>
+          <a:effectRef idx="2">
+            <a:schemeClr val="accent1"/>
+          </a:effectRef>
+          <a:fontRef idx="minor">
+            <a:schemeClr val="lt1"/>
+          </a:fontRef>
+        </p:style>
+        <p:txBody>
+          <a:bodyPr rtlCol="0" anchor="ctr"/>
+          <a:lstStyle/>
+          <a:p>
+            <a:pPr algn="ctr"/>
+          </a:p>
+        </p:txBody>
+      </p:sp>
+      <p:sp>
+        <p:nvSpPr>
+          <p:cNvPr id="3" name="TextBox 2"/>
+          <p:cNvSpPr txBox="1"/>
+          <p:nvPr/>
+        </p:nvSpPr>
+        <p:spPr>
+          <a:xfrm>
+            <a:off x="288000" y="125999"/>
+            <a:ext cx="11617200" cy="540000"/>
+          </a:xfrm>
+          <a:prstGeom prst="rect">
+            <a:avLst/>
+          </a:prstGeom>
+          <a:noFill/>
+        </p:spPr>
+        <p:txBody>
+          <a:bodyPr wrap="square">
+            <a:spAutoFit/>
+          </a:bodyPr>
+          <a:lstStyle/>
+          <a:p>
+            <a:pPr algn="l"/>
+            <a:r>
+              <a:rPr sz="2600" b="1">
+                <a:solidFill>
+                  <a:srgbClr val="FFFFFF"/>
+                </a:solidFill>
+                <a:latin typeface="Calibri"/>
+              </a:rPr>
               <a:t>2. Ý tưởng RNN: trạng thái ẩn h_t chính là “trí nhớ”</a:t>
             </a:r>
           </a:p>
@@ -4972,7 +6379,1245 @@
                 </a:solidFill>
                 <a:latin typeface="Calibri"/>
               </a:rPr>
-              <a:t>3. Công thức &amp; 3 ma trận W, U, V</a:t>
+              <a:t>3. Các hàm toán trong RNN: tanh, σ, ⊙</a:t>
+            </a:r>
+          </a:p>
+        </p:txBody>
+      </p:sp>
+      <p:sp>
+        <p:nvSpPr>
+          <p:cNvPr id="4" name="Rectangle 3"/>
+          <p:cNvSpPr/>
+          <p:nvPr/>
+        </p:nvSpPr>
+        <p:spPr>
+          <a:xfrm>
+            <a:off x="432000" y="1152000"/>
+            <a:ext cx="6263999" cy="4176000"/>
+          </a:xfrm>
+          <a:prstGeom prst="rect">
+            <a:avLst/>
+          </a:prstGeom>
+          <a:solidFill>
+            <a:srgbClr val="F2F2F2"/>
+          </a:solidFill>
+          <a:ln>
+            <a:noFill/>
+          </a:ln>
+          <a:effectLst/>
+        </p:spPr>
+        <p:style>
+          <a:lnRef idx="1">
+            <a:schemeClr val="accent1"/>
+          </a:lnRef>
+          <a:fillRef idx="3">
+            <a:schemeClr val="accent1"/>
+          </a:fillRef>
+          <a:effectRef idx="2">
+            <a:schemeClr val="accent1"/>
+          </a:effectRef>
+          <a:fontRef idx="minor">
+            <a:schemeClr val="lt1"/>
+          </a:fontRef>
+        </p:style>
+        <p:txBody>
+          <a:bodyPr rtlCol="0" anchor="ctr" wrap="square"/>
+          <a:lstStyle/>
+          <a:p>
+            <a:pPr algn="ctr"/>
+            <a:r>
+              <a:rPr sz="1300">
+                <a:solidFill>
+                  <a:srgbClr val="222222"/>
+                </a:solidFill>
+                <a:latin typeface="Consolas"/>
+              </a:rPr>
+              <a:t>tanh(z) = (e^z − e^(−z)) / (e^z + e^(−z))</a:t>
+            </a:r>
+          </a:p>
+          <a:p>
+            <a:r>
+              <a:rPr sz="1300">
+                <a:solidFill>
+                  <a:srgbClr val="222222"/>
+                </a:solidFill>
+                <a:latin typeface="Consolas"/>
+              </a:rPr>
+              <a:t>  # miền (−1, 1), ĐỐI XỨNG tâm 0, tanh(0) = 0</a:t>
+            </a:r>
+          </a:p>
+          <a:p>
+            <a:r>
+              <a:rPr sz="1300">
+                <a:solidFill>
+                  <a:srgbClr val="222222"/>
+                </a:solidFill>
+                <a:latin typeface="Consolas"/>
+              </a:rPr>
+              <a:t>  # tanh(±2) ≈ ±0.96 — sát biên (vùng BÃO HÒA)</a:t>
+            </a:r>
+          </a:p>
+          <a:p>
+            <a:r>
+              <a:rPr sz="1300">
+                <a:solidFill>
+                  <a:srgbClr val="222222"/>
+                </a:solidFill>
+                <a:latin typeface="Consolas"/>
+              </a:rPr>
+              <a:t/>
+            </a:r>
+          </a:p>
+          <a:p>
+            <a:r>
+              <a:rPr sz="1300">
+                <a:solidFill>
+                  <a:srgbClr val="222222"/>
+                </a:solidFill>
+                <a:latin typeface="Consolas"/>
+              </a:rPr>
+              <a:t>d/dz tanh(z) = 1 − tanh²(z)</a:t>
+            </a:r>
+          </a:p>
+          <a:p>
+            <a:r>
+              <a:rPr sz="1300">
+                <a:solidFill>
+                  <a:srgbClr val="222222"/>
+                </a:solidFill>
+                <a:latin typeface="Consolas"/>
+              </a:rPr>
+              <a:t>  # ∈ (0, 1]; ĐỈNH = 1 tại z = 0</a:t>
+            </a:r>
+          </a:p>
+          <a:p>
+            <a:r>
+              <a:rPr sz="1300">
+                <a:solidFill>
+                  <a:srgbClr val="222222"/>
+                </a:solidFill>
+                <a:latin typeface="Consolas"/>
+              </a:rPr>
+              <a:t>  # → 0 khi |z| &gt; 2 — bão hòa làm gradient tắt</a:t>
+            </a:r>
+          </a:p>
+          <a:p>
+            <a:r>
+              <a:rPr sz="1300">
+                <a:solidFill>
+                  <a:srgbClr val="222222"/>
+                </a:solidFill>
+                <a:latin typeface="Consolas"/>
+              </a:rPr>
+              <a:t/>
+            </a:r>
+          </a:p>
+          <a:p>
+            <a:r>
+              <a:rPr sz="1300">
+                <a:solidFill>
+                  <a:srgbClr val="222222"/>
+                </a:solidFill>
+                <a:latin typeface="Consolas"/>
+              </a:rPr>
+              <a:t>σ(z) = 1 / (1 + e^(−z))</a:t>
+            </a:r>
+          </a:p>
+          <a:p>
+            <a:r>
+              <a:rPr sz="1300">
+                <a:solidFill>
+                  <a:srgbClr val="222222"/>
+                </a:solidFill>
+                <a:latin typeface="Consolas"/>
+              </a:rPr>
+              <a:t>  # miền (0, 1) — như VAN đóng/mở 0 → 1</a:t>
+            </a:r>
+          </a:p>
+          <a:p>
+            <a:r>
+              <a:rPr sz="1300">
+                <a:solidFill>
+                  <a:srgbClr val="222222"/>
+                </a:solidFill>
+                <a:latin typeface="Consolas"/>
+              </a:rPr>
+              <a:t>  # σ′ = σ·(1 − σ) ≤ 0.25 — nhỏ hơn đạo hàm tanh</a:t>
+            </a:r>
+          </a:p>
+          <a:p>
+            <a:r>
+              <a:rPr sz="1300">
+                <a:solidFill>
+                  <a:srgbClr val="222222"/>
+                </a:solidFill>
+                <a:latin typeface="Consolas"/>
+              </a:rPr>
+              <a:t/>
+            </a:r>
+          </a:p>
+          <a:p>
+            <a:r>
+              <a:rPr sz="1300">
+                <a:solidFill>
+                  <a:srgbClr val="222222"/>
+                </a:solidFill>
+                <a:latin typeface="Consolas"/>
+              </a:rPr>
+              <a:t>a ⊙ b = [a_1·b_1, …, a_n·b_n]</a:t>
+            </a:r>
+          </a:p>
+          <a:p>
+            <a:r>
+              <a:rPr sz="1300">
+                <a:solidFill>
+                  <a:srgbClr val="222222"/>
+                </a:solidFill>
+                <a:latin typeface="Consolas"/>
+              </a:rPr>
+              <a:t>  # nhân TỪNG PHẦN TỬ của 2 vector (LSTM/GRU)</a:t>
+            </a:r>
+          </a:p>
+        </p:txBody>
+      </p:sp>
+      <p:graphicFrame>
+        <p:nvGraphicFramePr>
+          <p:cNvPr id="5" name="Table 4"/>
+          <p:cNvGraphicFramePr>
+            <a:graphicFrameLocks noGrp="1"/>
+          </p:cNvGraphicFramePr>
+          <p:nvPr/>
+        </p:nvGraphicFramePr>
+        <p:xfrm>
+          <a:off x="6912000" y="1224000"/>
+          <a:ext cx="4859998" cy="2376000"/>
+        </p:xfrm>
+        <a:graphic>
+          <a:graphicData uri="http://schemas.openxmlformats.org/drawingml/2006/table">
+            <a:tbl>
+              <a:tblPr firstRow="1" bandRow="1">
+                <a:tableStyleId>{5C22544A-7EE6-4342-B048-85BDC9FD1C3A}</a:tableStyleId>
+              </a:tblPr>
+              <a:tblGrid>
+                <a:gridCol w="786176"/>
+                <a:gridCol w="929117"/>
+                <a:gridCol w="1286470"/>
+                <a:gridCol w="1858235"/>
+              </a:tblGrid>
+              <a:tr h="594000">
+                <a:tc>
+                  <a:txBody>
+                    <a:bodyPr/>
+                    <a:lstStyle/>
+                    <a:p>
+                      <a:r>
+                        <a:rPr sz="1250" b="1">
+                          <a:solidFill>
+                            <a:srgbClr val="FFFFFF"/>
+                          </a:solidFill>
+                        </a:rPr>
+                        <a:t>Hàm</a:t>
+                      </a:r>
+                    </a:p>
+                  </a:txBody>
+                  <a:tcPr>
+                    <a:solidFill>
+                      <a:srgbClr val="1E3A8A"/>
+                    </a:solidFill>
+                  </a:tcPr>
+                </a:tc>
+                <a:tc>
+                  <a:txBody>
+                    <a:bodyPr/>
+                    <a:lstStyle/>
+                    <a:p>
+                      <a:r>
+                        <a:rPr sz="1250" b="1">
+                          <a:solidFill>
+                            <a:srgbClr val="FFFFFF"/>
+                          </a:solidFill>
+                        </a:rPr>
+                        <a:t>Miền</a:t>
+                      </a:r>
+                    </a:p>
+                  </a:txBody>
+                  <a:tcPr>
+                    <a:solidFill>
+                      <a:srgbClr val="1E3A8A"/>
+                    </a:solidFill>
+                  </a:tcPr>
+                </a:tc>
+                <a:tc>
+                  <a:txBody>
+                    <a:bodyPr/>
+                    <a:lstStyle/>
+                    <a:p>
+                      <a:r>
+                        <a:rPr sz="1250" b="1">
+                          <a:solidFill>
+                            <a:srgbClr val="FFFFFF"/>
+                          </a:solidFill>
+                        </a:rPr>
+                        <a:t>Đạo hàm</a:t>
+                      </a:r>
+                    </a:p>
+                  </a:txBody>
+                  <a:tcPr>
+                    <a:solidFill>
+                      <a:srgbClr val="1E3A8A"/>
+                    </a:solidFill>
+                  </a:tcPr>
+                </a:tc>
+                <a:tc>
+                  <a:txBody>
+                    <a:bodyPr/>
+                    <a:lstStyle/>
+                    <a:p>
+                      <a:r>
+                        <a:rPr sz="1250" b="1">
+                          <a:solidFill>
+                            <a:srgbClr val="FFFFFF"/>
+                          </a:solidFill>
+                        </a:rPr>
+                        <a:t>Dùng ở đâu?</a:t>
+                      </a:r>
+                    </a:p>
+                  </a:txBody>
+                  <a:tcPr>
+                    <a:solidFill>
+                      <a:srgbClr val="1E3A8A"/>
+                    </a:solidFill>
+                  </a:tcPr>
+                </a:tc>
+              </a:tr>
+              <a:tr h="594000">
+                <a:tc>
+                  <a:txBody>
+                    <a:bodyPr/>
+                    <a:lstStyle/>
+                    <a:p>
+                      <a:r>
+                        <a:rPr sz="1250" b="0">
+                          <a:solidFill>
+                            <a:srgbClr val="222222"/>
+                          </a:solidFill>
+                        </a:rPr>
+                        <a:t>tanh</a:t>
+                      </a:r>
+                    </a:p>
+                  </a:txBody>
+                  <a:tcPr>
+                    <a:solidFill>
+                      <a:srgbClr val="EEF2FA"/>
+                    </a:solidFill>
+                  </a:tcPr>
+                </a:tc>
+                <a:tc>
+                  <a:txBody>
+                    <a:bodyPr/>
+                    <a:lstStyle/>
+                    <a:p>
+                      <a:r>
+                        <a:rPr sz="1250" b="0">
+                          <a:solidFill>
+                            <a:srgbClr val="222222"/>
+                          </a:solidFill>
+                        </a:rPr>
+                        <a:t>(−1, 1)</a:t>
+                      </a:r>
+                    </a:p>
+                  </a:txBody>
+                  <a:tcPr>
+                    <a:solidFill>
+                      <a:srgbClr val="EEF2FA"/>
+                    </a:solidFill>
+                  </a:tcPr>
+                </a:tc>
+                <a:tc>
+                  <a:txBody>
+                    <a:bodyPr/>
+                    <a:lstStyle/>
+                    <a:p>
+                      <a:r>
+                        <a:rPr sz="1250" b="0">
+                          <a:solidFill>
+                            <a:srgbClr val="222222"/>
+                          </a:solidFill>
+                        </a:rPr>
+                        <a:t>1 − tanh² ≤ 1</a:t>
+                      </a:r>
+                    </a:p>
+                  </a:txBody>
+                  <a:tcPr>
+                    <a:solidFill>
+                      <a:srgbClr val="EEF2FA"/>
+                    </a:solidFill>
+                  </a:tcPr>
+                </a:tc>
+                <a:tc>
+                  <a:txBody>
+                    <a:bodyPr/>
+                    <a:lstStyle/>
+                    <a:p>
+                      <a:r>
+                        <a:rPr sz="1250" b="0">
+                          <a:solidFill>
+                            <a:srgbClr val="222222"/>
+                          </a:solidFill>
+                        </a:rPr>
+                        <a:t>Tầng ẩn RNN (chuẩn)</a:t>
+                      </a:r>
+                    </a:p>
+                  </a:txBody>
+                  <a:tcPr>
+                    <a:solidFill>
+                      <a:srgbClr val="EEF2FA"/>
+                    </a:solidFill>
+                  </a:tcPr>
+                </a:tc>
+              </a:tr>
+              <a:tr h="594000">
+                <a:tc>
+                  <a:txBody>
+                    <a:bodyPr/>
+                    <a:lstStyle/>
+                    <a:p>
+                      <a:r>
+                        <a:rPr sz="1250" b="0">
+                          <a:solidFill>
+                            <a:srgbClr val="222222"/>
+                          </a:solidFill>
+                        </a:rPr>
+                        <a:t>σ</a:t>
+                      </a:r>
+                    </a:p>
+                  </a:txBody>
+                  <a:tcPr>
+                    <a:solidFill>
+                      <a:srgbClr val="FFFFFF"/>
+                    </a:solidFill>
+                  </a:tcPr>
+                </a:tc>
+                <a:tc>
+                  <a:txBody>
+                    <a:bodyPr/>
+                    <a:lstStyle/>
+                    <a:p>
+                      <a:r>
+                        <a:rPr sz="1250" b="0">
+                          <a:solidFill>
+                            <a:srgbClr val="222222"/>
+                          </a:solidFill>
+                        </a:rPr>
+                        <a:t>(0, 1)</a:t>
+                      </a:r>
+                    </a:p>
+                  </a:txBody>
+                  <a:tcPr>
+                    <a:solidFill>
+                      <a:srgbClr val="FFFFFF"/>
+                    </a:solidFill>
+                  </a:tcPr>
+                </a:tc>
+                <a:tc>
+                  <a:txBody>
+                    <a:bodyPr/>
+                    <a:lstStyle/>
+                    <a:p>
+                      <a:r>
+                        <a:rPr sz="1250" b="0">
+                          <a:solidFill>
+                            <a:srgbClr val="222222"/>
+                          </a:solidFill>
+                        </a:rPr>
+                        <a:t>σ(1−σ) ≤ 0.25</a:t>
+                      </a:r>
+                    </a:p>
+                  </a:txBody>
+                  <a:tcPr>
+                    <a:solidFill>
+                      <a:srgbClr val="FFFFFF"/>
+                    </a:solidFill>
+                  </a:tcPr>
+                </a:tc>
+                <a:tc>
+                  <a:txBody>
+                    <a:bodyPr/>
+                    <a:lstStyle/>
+                    <a:p>
+                      <a:r>
+                        <a:rPr sz="1250" b="0">
+                          <a:solidFill>
+                            <a:srgbClr val="222222"/>
+                          </a:solidFill>
+                        </a:rPr>
+                        <a:t>Cổng LSTM / GRU</a:t>
+                      </a:r>
+                    </a:p>
+                  </a:txBody>
+                  <a:tcPr>
+                    <a:solidFill>
+                      <a:srgbClr val="FFFFFF"/>
+                    </a:solidFill>
+                  </a:tcPr>
+                </a:tc>
+              </a:tr>
+              <a:tr h="594000">
+                <a:tc>
+                  <a:txBody>
+                    <a:bodyPr/>
+                    <a:lstStyle/>
+                    <a:p>
+                      <a:r>
+                        <a:rPr sz="1250" b="0">
+                          <a:solidFill>
+                            <a:srgbClr val="222222"/>
+                          </a:solidFill>
+                        </a:rPr>
+                        <a:t>ReLU</a:t>
+                      </a:r>
+                    </a:p>
+                  </a:txBody>
+                  <a:tcPr>
+                    <a:solidFill>
+                      <a:srgbClr val="EEF2FA"/>
+                    </a:solidFill>
+                  </a:tcPr>
+                </a:tc>
+                <a:tc>
+                  <a:txBody>
+                    <a:bodyPr/>
+                    <a:lstStyle/>
+                    <a:p>
+                      <a:r>
+                        <a:rPr sz="1250" b="0">
+                          <a:solidFill>
+                            <a:srgbClr val="222222"/>
+                          </a:solidFill>
+                        </a:rPr>
+                        <a:t>[0, +∞)</a:t>
+                      </a:r>
+                    </a:p>
+                  </a:txBody>
+                  <a:tcPr>
+                    <a:solidFill>
+                      <a:srgbClr val="EEF2FA"/>
+                    </a:solidFill>
+                  </a:tcPr>
+                </a:tc>
+                <a:tc>
+                  <a:txBody>
+                    <a:bodyPr/>
+                    <a:lstStyle/>
+                    <a:p>
+                      <a:r>
+                        <a:rPr sz="1250" b="0">
+                          <a:solidFill>
+                            <a:srgbClr val="222222"/>
+                          </a:solidFill>
+                        </a:rPr>
+                        <a:t>0 hoặc 1</a:t>
+                      </a:r>
+                    </a:p>
+                  </a:txBody>
+                  <a:tcPr>
+                    <a:solidFill>
+                      <a:srgbClr val="EEF2FA"/>
+                    </a:solidFill>
+                  </a:tcPr>
+                </a:tc>
+                <a:tc>
+                  <a:txBody>
+                    <a:bodyPr/>
+                    <a:lstStyle/>
+                    <a:p>
+                      <a:r>
+                        <a:rPr sz="1250" b="0">
+                          <a:solidFill>
+                            <a:srgbClr val="222222"/>
+                          </a:solidFill>
+                        </a:rPr>
+                        <a:t>Hiếm — h không chặn</a:t>
+                      </a:r>
+                    </a:p>
+                  </a:txBody>
+                  <a:tcPr>
+                    <a:solidFill>
+                      <a:srgbClr val="EEF2FA"/>
+                    </a:solidFill>
+                  </a:tcPr>
+                </a:tc>
+              </a:tr>
+            </a:tbl>
+          </a:graphicData>
+        </a:graphic>
+      </p:graphicFrame>
+      <p:pic>
+        <p:nvPicPr>
+          <p:cNvPr id="6" name="Picture 5" descr="slide-03-tanh.png"/>
+          <p:cNvPicPr>
+            <a:picLocks noChangeAspect="1"/>
+          </p:cNvPicPr>
+          <p:nvPr/>
+        </p:nvPicPr>
+        <p:blipFill>
+          <a:blip r:embed="rId3"/>
+          <a:stretch>
+            <a:fillRect/>
+          </a:stretch>
+        </p:blipFill>
+        <p:spPr>
+          <a:xfrm>
+            <a:off x="6912000" y="3816000"/>
+            <a:ext cx="4860000" cy="1271776"/>
+          </a:xfrm>
+          <a:prstGeom prst="rect">
+            <a:avLst/>
+          </a:prstGeom>
+        </p:spPr>
+      </p:pic>
+      <p:sp>
+        <p:nvSpPr>
+          <p:cNvPr id="7" name="TextBox 6"/>
+          <p:cNvSpPr txBox="1"/>
+          <p:nvPr/>
+        </p:nvSpPr>
+        <p:spPr>
+          <a:xfrm>
+            <a:off x="432000" y="5544000"/>
+            <a:ext cx="11304000" cy="936000"/>
+          </a:xfrm>
+          <a:prstGeom prst="rect">
+            <a:avLst/>
+          </a:prstGeom>
+          <a:noFill/>
+        </p:spPr>
+        <p:txBody>
+          <a:bodyPr wrap="square">
+            <a:spAutoFit/>
+          </a:bodyPr>
+          <a:lstStyle/>
+          <a:p>
+            <a:pPr algn="l"/>
+            <a:r>
+              <a:rPr sz="1400" b="1">
+                <a:solidFill>
+                  <a:srgbClr val="1E3A8A"/>
+                </a:solidFill>
+                <a:latin typeface="Calibri"/>
+              </a:rPr>
+              <a:t>Vì sao RNN cổ điển chọn tanh: (1) tâm 0 → trí nhớ dương/âm cân bằng; (2) chặn về (−1,1) giữ chuẩn h_t ổn định</a:t>
+            </a:r>
+          </a:p>
+          <a:p>
+            <a:pPr algn="l"/>
+            <a:r>
+              <a:rPr sz="1400" b="1">
+                <a:solidFill>
+                  <a:srgbClr val="1E3A8A"/>
+                </a:solidFill>
+                <a:latin typeface="Calibri"/>
+              </a:rPr>
+              <a:t>theo thời gian; (3) đạo hàm gọn 1 − tanh². ReLU không chặn dễ bùng nổ theo t; σ lệch dương và đạo hàm ≤ 0.25</a:t>
+            </a:r>
+          </a:p>
+          <a:p>
+            <a:pPr algn="l"/>
+            <a:r>
+              <a:rPr sz="1400" b="1">
+                <a:solidFill>
+                  <a:srgbClr val="1E3A8A"/>
+                </a:solidFill>
+                <a:latin typeface="Calibri"/>
+              </a:rPr>
+              <a:t>khiến gradient biến mất nhanh gấp đôi so với tanh.</a:t>
+            </a:r>
+          </a:p>
+        </p:txBody>
+      </p:sp>
+    </p:spTree>
+  </p:cSld>
+  <p:clrMapOvr>
+    <a:masterClrMapping/>
+  </p:clrMapOvr>
+</p:sld>
+</file>
+
+<file path=ppt/slides/slide4.xml><?xml version="1.0" encoding="utf-8"?>
+<p:sld xmlns:a="http://schemas.openxmlformats.org/drawingml/2006/main" xmlns:p="http://schemas.openxmlformats.org/presentationml/2006/main" xmlns:r="http://schemas.openxmlformats.org/officeDocument/2006/relationships">
+  <p:cSld>
+    <p:spTree>
+      <p:nvGrpSpPr>
+        <p:cNvPr id="1" name=""/>
+        <p:cNvGrpSpPr/>
+        <p:nvPr/>
+      </p:nvGrpSpPr>
+      <p:grpSpPr/>
+      <p:sp>
+        <p:nvSpPr>
+          <p:cNvPr id="2" name="Rectangle 1"/>
+          <p:cNvSpPr/>
+          <p:nvPr/>
+        </p:nvSpPr>
+        <p:spPr>
+          <a:xfrm>
+            <a:off x="0" y="0"/>
+            <a:ext cx="12193200" cy="792000"/>
+          </a:xfrm>
+          <a:prstGeom prst="rect">
+            <a:avLst/>
+          </a:prstGeom>
+          <a:solidFill>
+            <a:srgbClr val="1E3A8A"/>
+          </a:solidFill>
+          <a:ln>
+            <a:noFill/>
+          </a:ln>
+          <a:effectLst/>
+        </p:spPr>
+        <p:style>
+          <a:lnRef idx="1">
+            <a:schemeClr val="accent1"/>
+          </a:lnRef>
+          <a:fillRef idx="3">
+            <a:schemeClr val="accent1"/>
+          </a:fillRef>
+          <a:effectRef idx="2">
+            <a:schemeClr val="accent1"/>
+          </a:effectRef>
+          <a:fontRef idx="minor">
+            <a:schemeClr val="lt1"/>
+          </a:fontRef>
+        </p:style>
+        <p:txBody>
+          <a:bodyPr rtlCol="0" anchor="ctr"/>
+          <a:lstStyle/>
+          <a:p>
+            <a:pPr algn="ctr"/>
+          </a:p>
+        </p:txBody>
+      </p:sp>
+      <p:sp>
+        <p:nvSpPr>
+          <p:cNvPr id="3" name="TextBox 2"/>
+          <p:cNvSpPr txBox="1"/>
+          <p:nvPr/>
+        </p:nvSpPr>
+        <p:spPr>
+          <a:xfrm>
+            <a:off x="288000" y="125999"/>
+            <a:ext cx="11617200" cy="540000"/>
+          </a:xfrm>
+          <a:prstGeom prst="rect">
+            <a:avLst/>
+          </a:prstGeom>
+          <a:noFill/>
+        </p:spPr>
+        <p:txBody>
+          <a:bodyPr wrap="square">
+            <a:spAutoFit/>
+          </a:bodyPr>
+          <a:lstStyle/>
+          <a:p>
+            <a:pPr algn="l"/>
+            <a:r>
+              <a:rPr sz="2600" b="1">
+                <a:solidFill>
+                  <a:srgbClr val="FFFFFF"/>
+                </a:solidFill>
+                <a:latin typeface="Calibri"/>
+              </a:rPr>
+              <a:t>4. Đạo hàm sẽ dùng trong BPTT — 3 công cụ</a:t>
+            </a:r>
+          </a:p>
+        </p:txBody>
+      </p:sp>
+      <p:sp>
+        <p:nvSpPr>
+          <p:cNvPr id="4" name="Rectangle 3"/>
+          <p:cNvSpPr/>
+          <p:nvPr/>
+        </p:nvSpPr>
+        <p:spPr>
+          <a:xfrm>
+            <a:off x="432000" y="1152000"/>
+            <a:ext cx="6336000" cy="4464000"/>
+          </a:xfrm>
+          <a:prstGeom prst="rect">
+            <a:avLst/>
+          </a:prstGeom>
+          <a:solidFill>
+            <a:srgbClr val="F2F2F2"/>
+          </a:solidFill>
+          <a:ln>
+            <a:noFill/>
+          </a:ln>
+          <a:effectLst/>
+        </p:spPr>
+        <p:style>
+          <a:lnRef idx="1">
+            <a:schemeClr val="accent1"/>
+          </a:lnRef>
+          <a:fillRef idx="3">
+            <a:schemeClr val="accent1"/>
+          </a:fillRef>
+          <a:effectRef idx="2">
+            <a:schemeClr val="accent1"/>
+          </a:effectRef>
+          <a:fontRef idx="minor">
+            <a:schemeClr val="lt1"/>
+          </a:fontRef>
+        </p:style>
+        <p:txBody>
+          <a:bodyPr rtlCol="0" anchor="ctr" wrap="square"/>
+          <a:lstStyle/>
+          <a:p>
+            <a:pPr algn="ctr"/>
+            <a:r>
+              <a:rPr sz="1250">
+                <a:solidFill>
+                  <a:srgbClr val="222222"/>
+                </a:solidFill>
+                <a:latin typeface="Consolas"/>
+              </a:rPr>
+              <a:t>CÔNG CỤ 1 — Luật dây chuyền (chain rule):</a:t>
+            </a:r>
+          </a:p>
+          <a:p>
+            <a:r>
+              <a:rPr sz="1250">
+                <a:solidFill>
+                  <a:srgbClr val="222222"/>
+                </a:solidFill>
+                <a:latin typeface="Consolas"/>
+              </a:rPr>
+              <a:t>  ∂L/∂W = (∂L/∂y) · (∂y/∂W)</a:t>
+            </a:r>
+          </a:p>
+          <a:p>
+            <a:r>
+              <a:rPr sz="1250">
+                <a:solidFill>
+                  <a:srgbClr val="222222"/>
+                </a:solidFill>
+                <a:latin typeface="Consolas"/>
+              </a:rPr>
+              <a:t>  # gradient chảy QUA các phép trung gian</a:t>
+            </a:r>
+          </a:p>
+          <a:p>
+            <a:r>
+              <a:rPr sz="1250">
+                <a:solidFill>
+                  <a:srgbClr val="222222"/>
+                </a:solidFill>
+                <a:latin typeface="Consolas"/>
+              </a:rPr>
+              <a:t/>
+            </a:r>
+          </a:p>
+          <a:p>
+            <a:r>
+              <a:rPr sz="1250">
+                <a:solidFill>
+                  <a:srgbClr val="222222"/>
+                </a:solidFill>
+                <a:latin typeface="Consolas"/>
+              </a:rPr>
+              <a:t>CÔNG CỤ 2 — Phép affine y = W·x + b:</a:t>
+            </a:r>
+          </a:p>
+          <a:p>
+            <a:r>
+              <a:rPr sz="1250">
+                <a:solidFill>
+                  <a:srgbClr val="222222"/>
+                </a:solidFill>
+                <a:latin typeface="Consolas"/>
+              </a:rPr>
+              <a:t>  ∂L/∂x = Wᵀ · δ        (δ = ∂L/∂y)</a:t>
+            </a:r>
+          </a:p>
+          <a:p>
+            <a:r>
+              <a:rPr sz="1250">
+                <a:solidFill>
+                  <a:srgbClr val="222222"/>
+                </a:solidFill>
+                <a:latin typeface="Consolas"/>
+              </a:rPr>
+              <a:t>  ∂L/∂W = δ · xᵀ        (tích NGOẠI: vector × vector</a:t>
+            </a:r>
+          </a:p>
+          <a:p>
+            <a:r>
+              <a:rPr sz="1250">
+                <a:solidFill>
+                  <a:srgbClr val="222222"/>
+                </a:solidFill>
+                <a:latin typeface="Consolas"/>
+              </a:rPr>
+              <a:t>                         # → ma trận — mỗi trọng số</a:t>
+            </a:r>
+          </a:p>
+          <a:p>
+            <a:r>
+              <a:rPr sz="1250">
+                <a:solidFill>
+                  <a:srgbClr val="222222"/>
+                </a:solidFill>
+                <a:latin typeface="Consolas"/>
+              </a:rPr>
+              <a:t>                         # nhận “vệt” từ đầu vào của nó)</a:t>
+            </a:r>
+          </a:p>
+          <a:p>
+            <a:r>
+              <a:rPr sz="1250">
+                <a:solidFill>
+                  <a:srgbClr val="222222"/>
+                </a:solidFill>
+                <a:latin typeface="Consolas"/>
+              </a:rPr>
+              <a:t/>
+            </a:r>
+          </a:p>
+          <a:p>
+            <a:r>
+              <a:rPr sz="1250">
+                <a:solidFill>
+                  <a:srgbClr val="222222"/>
+                </a:solidFill>
+                <a:latin typeface="Consolas"/>
+              </a:rPr>
+              <a:t>CÔNG CỤ 3 — Nén tanh h = tanh(a):</a:t>
+            </a:r>
+          </a:p>
+          <a:p>
+            <a:r>
+              <a:rPr sz="1250">
+                <a:solidFill>
+                  <a:srgbClr val="222222"/>
+                </a:solidFill>
+                <a:latin typeface="Consolas"/>
+              </a:rPr>
+              <a:t>  ∂L/∂a = diag(1 − tanh²(a)) · (∂L/∂h)</a:t>
+            </a:r>
+          </a:p>
+          <a:p>
+            <a:r>
+              <a:rPr sz="1250">
+                <a:solidFill>
+                  <a:srgbClr val="222222"/>
+                </a:solidFill>
+                <a:latin typeface="Consolas"/>
+              </a:rPr>
+              <a:t>  # nhân TỪNG toạ độ một hệ số ≤ 1</a:t>
+            </a:r>
+          </a:p>
+          <a:p>
+            <a:r>
+              <a:rPr sz="1250">
+                <a:solidFill>
+                  <a:srgbClr val="222222"/>
+                </a:solidFill>
+                <a:latin typeface="Consolas"/>
+              </a:rPr>
+              <a:t/>
+            </a:r>
+          </a:p>
+          <a:p>
+            <a:r>
+              <a:rPr sz="1250">
+                <a:solidFill>
+                  <a:srgbClr val="222222"/>
+                </a:solidFill>
+                <a:latin typeface="Consolas"/>
+              </a:rPr>
+              <a:t>Loss MSE trung bình theo thời gian:</a:t>
+            </a:r>
+          </a:p>
+          <a:p>
+            <a:r>
+              <a:rPr sz="1250">
+                <a:solidFill>
+                  <a:srgbClr val="222222"/>
+                </a:solidFill>
+                <a:latin typeface="Consolas"/>
+              </a:rPr>
+              <a:t>  L = (1/T)·Σ_t (ŷ_t − y_t)²  →  δ_t = (2/T)(ŷ_t − y_t)</a:t>
+            </a:r>
+          </a:p>
+        </p:txBody>
+      </p:sp>
+      <p:sp>
+        <p:nvSpPr>
+          <p:cNvPr id="5" name="TextBox 4"/>
+          <p:cNvSpPr txBox="1"/>
+          <p:nvPr/>
+        </p:nvSpPr>
+        <p:spPr>
+          <a:xfrm>
+            <a:off x="6983999" y="1224000"/>
+            <a:ext cx="4788000" cy="612000"/>
+          </a:xfrm>
+          <a:prstGeom prst="rect">
+            <a:avLst/>
+          </a:prstGeom>
+          <a:noFill/>
+        </p:spPr>
+        <p:txBody>
+          <a:bodyPr wrap="square">
+            <a:spAutoFit/>
+          </a:bodyPr>
+          <a:lstStyle/>
+          <a:p>
+            <a:pPr algn="l"/>
+            <a:r>
+              <a:rPr sz="1400" b="1">
+                <a:solidFill>
+                  <a:srgbClr val="222222"/>
+                </a:solidFill>
+                <a:latin typeface="Calibri"/>
+              </a:rPr>
+              <a:t>BPTT ở slide 8 = lắp 3 công cụ này theo CHIỀU THỜI GIAN</a:t>
+            </a:r>
+          </a:p>
+        </p:txBody>
+      </p:sp>
+      <p:sp>
+        <p:nvSpPr>
+          <p:cNvPr id="6" name="TextBox 5"/>
+          <p:cNvSpPr txBox="1"/>
+          <p:nvPr/>
+        </p:nvSpPr>
+        <p:spPr>
+          <a:xfrm>
+            <a:off x="6983999" y="1836000"/>
+            <a:ext cx="4788000" cy="612000"/>
+          </a:xfrm>
+          <a:prstGeom prst="rect">
+            <a:avLst/>
+          </a:prstGeom>
+          <a:noFill/>
+        </p:spPr>
+        <p:txBody>
+          <a:bodyPr wrap="square">
+            <a:spAutoFit/>
+          </a:bodyPr>
+          <a:lstStyle/>
+          <a:p>
+            <a:pPr algn="l"/>
+            <a:r>
+              <a:rPr sz="1400" b="0">
+                <a:solidFill>
+                  <a:srgbClr val="222222"/>
+                </a:solidFill>
+                <a:latin typeface="Calibri"/>
+              </a:rPr>
+              <a:t>•  Wᵀ xuất hiện vì gradient đi ngược chiều forward</a:t>
+            </a:r>
+          </a:p>
+        </p:txBody>
+      </p:sp>
+      <p:sp>
+        <p:nvSpPr>
+          <p:cNvPr id="7" name="TextBox 6"/>
+          <p:cNvSpPr txBox="1"/>
+          <p:nvPr/>
+        </p:nvSpPr>
+        <p:spPr>
+          <a:xfrm>
+            <a:off x="6983999" y="2448000"/>
+            <a:ext cx="4788000" cy="612000"/>
+          </a:xfrm>
+          <a:prstGeom prst="rect">
+            <a:avLst/>
+          </a:prstGeom>
+          <a:noFill/>
+        </p:spPr>
+        <p:txBody>
+          <a:bodyPr wrap="square">
+            <a:spAutoFit/>
+          </a:bodyPr>
+          <a:lstStyle/>
+          <a:p>
+            <a:pPr algn="l"/>
+            <a:r>
+              <a:rPr sz="1400" b="0">
+                <a:solidFill>
+                  <a:srgbClr val="222222"/>
+                </a:solidFill>
+                <a:latin typeface="Calibri"/>
+              </a:rPr>
+              <a:t>•  δ·xᵀ (ngoại) là nguồn các công thức ∂L/∂W = Σ δz_t·x_tᵀ</a:t>
+            </a:r>
+          </a:p>
+        </p:txBody>
+      </p:sp>
+      <p:sp>
+        <p:nvSpPr>
+          <p:cNvPr id="8" name="TextBox 7"/>
+          <p:cNvSpPr txBox="1"/>
+          <p:nvPr/>
+        </p:nvSpPr>
+        <p:spPr>
+          <a:xfrm>
+            <a:off x="6983999" y="3060000"/>
+            <a:ext cx="4788000" cy="612000"/>
+          </a:xfrm>
+          <a:prstGeom prst="rect">
+            <a:avLst/>
+          </a:prstGeom>
+          <a:noFill/>
+        </p:spPr>
+        <p:txBody>
+          <a:bodyPr wrap="square">
+            <a:spAutoFit/>
+          </a:bodyPr>
+          <a:lstStyle/>
+          <a:p>
+            <a:pPr algn="l"/>
+            <a:r>
+              <a:rPr sz="1400" b="0">
+                <a:solidFill>
+                  <a:srgbClr val="222222"/>
+                </a:solidFill>
+                <a:latin typeface="Calibri"/>
+              </a:rPr>
+              <a:t>•  diag(1−tanh²) ≤ 1 chính là nhân tử làm gradient tắt dần</a:t>
+            </a:r>
+          </a:p>
+        </p:txBody>
+      </p:sp>
+      <p:sp>
+        <p:nvSpPr>
+          <p:cNvPr id="9" name="TextBox 8"/>
+          <p:cNvSpPr txBox="1"/>
+          <p:nvPr/>
+        </p:nvSpPr>
+        <p:spPr>
+          <a:xfrm>
+            <a:off x="6983999" y="3672000"/>
+            <a:ext cx="4788000" cy="612000"/>
+          </a:xfrm>
+          <a:prstGeom prst="rect">
+            <a:avLst/>
+          </a:prstGeom>
+          <a:noFill/>
+        </p:spPr>
+        <p:txBody>
+          <a:bodyPr wrap="square">
+            <a:spAutoFit/>
+          </a:bodyPr>
+          <a:lstStyle/>
+          <a:p>
+            <a:pPr algn="l"/>
+            <a:r>
+              <a:rPr sz="1400" b="0">
+                <a:solidFill>
+                  <a:srgbClr val="222222"/>
+                </a:solidFill>
+                <a:latin typeface="Calibri"/>
+              </a:rPr>
+              <a:t>•  Cùng bộ quy tắc cho Keras/PyTorch — chúng chỉ tự động hoá</a:t>
+            </a:r>
+          </a:p>
+        </p:txBody>
+      </p:sp>
+    </p:spTree>
+  </p:cSld>
+  <p:clrMapOvr>
+    <a:masterClrMapping/>
+  </p:clrMapOvr>
+</p:sld>
+</file>
+
+<file path=ppt/slides/slide5.xml><?xml version="1.0" encoding="utf-8"?>
+<p:sld xmlns:a="http://schemas.openxmlformats.org/drawingml/2006/main" xmlns:p="http://schemas.openxmlformats.org/presentationml/2006/main" xmlns:r="http://schemas.openxmlformats.org/officeDocument/2006/relationships">
+  <p:cSld>
+    <p:spTree>
+      <p:nvGrpSpPr>
+        <p:cNvPr id="1" name=""/>
+        <p:cNvGrpSpPr/>
+        <p:nvPr/>
+      </p:nvGrpSpPr>
+      <p:grpSpPr/>
+      <p:sp>
+        <p:nvSpPr>
+          <p:cNvPr id="2" name="Rectangle 1"/>
+          <p:cNvSpPr/>
+          <p:nvPr/>
+        </p:nvSpPr>
+        <p:spPr>
+          <a:xfrm>
+            <a:off x="0" y="0"/>
+            <a:ext cx="12193200" cy="792000"/>
+          </a:xfrm>
+          <a:prstGeom prst="rect">
+            <a:avLst/>
+          </a:prstGeom>
+          <a:solidFill>
+            <a:srgbClr val="1E3A8A"/>
+          </a:solidFill>
+          <a:ln>
+            <a:noFill/>
+          </a:ln>
+          <a:effectLst/>
+        </p:spPr>
+        <p:style>
+          <a:lnRef idx="1">
+            <a:schemeClr val="accent1"/>
+          </a:lnRef>
+          <a:fillRef idx="3">
+            <a:schemeClr val="accent1"/>
+          </a:fillRef>
+          <a:effectRef idx="2">
+            <a:schemeClr val="accent1"/>
+          </a:effectRef>
+          <a:fontRef idx="minor">
+            <a:schemeClr val="lt1"/>
+          </a:fontRef>
+        </p:style>
+        <p:txBody>
+          <a:bodyPr rtlCol="0" anchor="ctr"/>
+          <a:lstStyle/>
+          <a:p>
+            <a:pPr algn="ctr"/>
+          </a:p>
+        </p:txBody>
+      </p:sp>
+      <p:sp>
+        <p:nvSpPr>
+          <p:cNvPr id="3" name="TextBox 2"/>
+          <p:cNvSpPr txBox="1"/>
+          <p:nvPr/>
+        </p:nvSpPr>
+        <p:spPr>
+          <a:xfrm>
+            <a:off x="288000" y="125999"/>
+            <a:ext cx="11617200" cy="540000"/>
+          </a:xfrm>
+          <a:prstGeom prst="rect">
+            <a:avLst/>
+          </a:prstGeom>
+          <a:noFill/>
+        </p:spPr>
+        <p:txBody>
+          <a:bodyPr wrap="square">
+            <a:spAutoFit/>
+          </a:bodyPr>
+          <a:lstStyle/>
+          <a:p>
+            <a:pPr algn="l"/>
+            <a:r>
+              <a:rPr sz="2600" b="1">
+                <a:solidFill>
+                  <a:srgbClr val="FFFFFF"/>
+                </a:solidFill>
+                <a:latin typeface="Calibri"/>
+              </a:rPr>
+              <a:t>5. Công thức &amp; 3 ma trận W, U, V</a:t>
             </a:r>
           </a:p>
         </p:txBody>
@@ -5630,7 +8275,7 @@
 </p:sld>
 </file>
 
-<file path=ppt/slides/slide4.xml><?xml version="1.0" encoding="utf-8"?>
+<file path=ppt/slides/slide6.xml><?xml version="1.0" encoding="utf-8"?>
 <p:sld xmlns:a="http://schemas.openxmlformats.org/drawingml/2006/main" xmlns:p="http://schemas.openxmlformats.org/presentationml/2006/main" xmlns:r="http://schemas.openxmlformats.org/officeDocument/2006/relationships">
   <p:cSld>
     <p:spTree>
@@ -5714,7 +8359,7 @@
                 </a:solidFill>
                 <a:latin typeface="Calibri"/>
               </a:rPr>
-              <a:t>4. Tính thử một bước (ví dụ số nhỏ: d_x=2, d_h=2, d_y=1)</a:t>
+              <a:t>6. Tính thử một bước (ví dụ số nhỏ: d_x=2, d_h=2, d_y=1)</a:t>
             </a:r>
           </a:p>
         </p:txBody>
@@ -6289,7 +8934,7 @@
 </p:sld>
 </file>
 
-<file path=ppt/slides/slide5.xml><?xml version="1.0" encoding="utf-8"?>
+<file path=ppt/slides/slide7.xml><?xml version="1.0" encoding="utf-8"?>
 <p:sld xmlns:a="http://schemas.openxmlformats.org/drawingml/2006/main" xmlns:p="http://schemas.openxmlformats.org/presentationml/2006/main" xmlns:r="http://schemas.openxmlformats.org/officeDocument/2006/relationships">
   <p:cSld>
     <p:spTree>
@@ -6373,7 +9018,7 @@
                 </a:solidFill>
                 <a:latin typeface="Calibri"/>
               </a:rPr>
-              <a:t>5. Chuẩn bị dữ liệu: từng hàm trong pipeline</a:t>
+              <a:t>7. Chuẩn bị dữ liệu: từng hàm trong pipeline</a:t>
             </a:r>
           </a:p>
         </p:txBody>
@@ -6895,7 +9540,7 @@
 </p:sld>
 </file>
 
-<file path=ppt/slides/slide6.xml><?xml version="1.0" encoding="utf-8"?>
+<file path=ppt/slides/slide8.xml><?xml version="1.0" encoding="utf-8"?>
 <p:sld xmlns:a="http://schemas.openxmlformats.org/drawingml/2006/main" xmlns:p="http://schemas.openxmlformats.org/presentationml/2006/main" xmlns:r="http://schemas.openxmlformats.org/officeDocument/2006/relationships">
   <p:cSld>
     <p:spTree>
@@ -6979,7 +9624,7 @@
                 </a:solidFill>
                 <a:latin typeface="Calibri"/>
               </a:rPr>
-              <a:t>6. Huấn luyện — BPTT: gradient chảy ngược qua thời gian</a:t>
+              <a:t>8. Huấn luyện — BPTT: gradient chảy ngược qua thời gian</a:t>
             </a:r>
           </a:p>
         </p:txBody>
@@ -7245,7 +9890,7 @@
                 </a:solidFill>
                 <a:latin typeface="Calibri"/>
               </a:rPr>
-              <a:t>Chuỗi dài → mạng khó học quá khứ XA; khắc phục: LSTM / GRU (slide 9)</a:t>
+              <a:t>Chuỗi dài → mạng khó học quá khứ XA; khắc phục: LSTM / GRU (slide 11)</a:t>
             </a:r>
           </a:p>
         </p:txBody>
@@ -7425,7 +10070,7 @@
 </p:sld>
 </file>
 
-<file path=ppt/slides/slide7.xml><?xml version="1.0" encoding="utf-8"?>
+<file path=ppt/slides/slide9.xml><?xml version="1.0" encoding="utf-8"?>
 <p:sld xmlns:a="http://schemas.openxmlformats.org/drawingml/2006/main" xmlns:p="http://schemas.openxmlformats.org/presentationml/2006/main" xmlns:r="http://schemas.openxmlformats.org/officeDocument/2006/relationships">
   <p:cSld>
     <p:spTree>
@@ -7509,7 +10154,7 @@
                 </a:solidFill>
                 <a:latin typeface="Calibri"/>
               </a:rPr>
-              <a:t>7. Vòng lặp huấn luyện — từng dòng (code thật notebook 01)</a:t>
+              <a:t>9. Vòng lặp huấn luyện — từng dòng (code thật notebook 01)</a:t>
             </a:r>
           </a:p>
         </p:txBody>
@@ -8209,1271 +10854,6 @@
           </a:graphicData>
         </a:graphic>
       </p:graphicFrame>
-    </p:spTree>
-  </p:cSld>
-  <p:clrMapOvr>
-    <a:masterClrMapping/>
-  </p:clrMapOvr>
-</p:sld>
-</file>
-
-<file path=ppt/slides/slide8.xml><?xml version="1.0" encoding="utf-8"?>
-<p:sld xmlns:a="http://schemas.openxmlformats.org/drawingml/2006/main" xmlns:p="http://schemas.openxmlformats.org/presentationml/2006/main" xmlns:r="http://schemas.openxmlformats.org/officeDocument/2006/relationships">
-  <p:cSld>
-    <p:spTree>
-      <p:nvGrpSpPr>
-        <p:cNvPr id="1" name=""/>
-        <p:cNvGrpSpPr/>
-        <p:nvPr/>
-      </p:nvGrpSpPr>
-      <p:grpSpPr/>
-      <p:sp>
-        <p:nvSpPr>
-          <p:cNvPr id="2" name="Rectangle 1"/>
-          <p:cNvSpPr/>
-          <p:nvPr/>
-        </p:nvSpPr>
-        <p:spPr>
-          <a:xfrm>
-            <a:off x="0" y="0"/>
-            <a:ext cx="12193200" cy="792000"/>
-          </a:xfrm>
-          <a:prstGeom prst="rect">
-            <a:avLst/>
-          </a:prstGeom>
-          <a:solidFill>
-            <a:srgbClr val="1E3A8A"/>
-          </a:solidFill>
-          <a:ln>
-            <a:noFill/>
-          </a:ln>
-          <a:effectLst/>
-        </p:spPr>
-        <p:style>
-          <a:lnRef idx="1">
-            <a:schemeClr val="accent1"/>
-          </a:lnRef>
-          <a:fillRef idx="3">
-            <a:schemeClr val="accent1"/>
-          </a:fillRef>
-          <a:effectRef idx="2">
-            <a:schemeClr val="accent1"/>
-          </a:effectRef>
-          <a:fontRef idx="minor">
-            <a:schemeClr val="lt1"/>
-          </a:fontRef>
-        </p:style>
-        <p:txBody>
-          <a:bodyPr rtlCol="0" anchor="ctr"/>
-          <a:lstStyle/>
-          <a:p>
-            <a:pPr algn="ctr"/>
-          </a:p>
-        </p:txBody>
-      </p:sp>
-      <p:sp>
-        <p:nvSpPr>
-          <p:cNvPr id="3" name="TextBox 2"/>
-          <p:cNvSpPr txBox="1"/>
-          <p:nvPr/>
-        </p:nvSpPr>
-        <p:spPr>
-          <a:xfrm>
-            <a:off x="288000" y="125999"/>
-            <a:ext cx="11617200" cy="540000"/>
-          </a:xfrm>
-          <a:prstGeom prst="rect">
-            <a:avLst/>
-          </a:prstGeom>
-          <a:noFill/>
-        </p:spPr>
-        <p:txBody>
-          <a:bodyPr wrap="square">
-            <a:spAutoFit/>
-          </a:bodyPr>
-          <a:lstStyle/>
-          <a:p>
-            <a:pPr algn="l"/>
-            <a:r>
-              <a:rPr sz="2600" b="1">
-                <a:solidFill>
-                  <a:srgbClr val="FFFFFF"/>
-                </a:solidFill>
-                <a:latin typeface="Calibri"/>
-              </a:rPr>
-              <a:t>8. Áp dụng: dự đoán giá ngày mai trên 2 tập dữ liệu thật</a:t>
-            </a:r>
-          </a:p>
-        </p:txBody>
-      </p:sp>
-      <p:sp>
-        <p:nvSpPr>
-          <p:cNvPr id="4" name="Rectangle 3"/>
-          <p:cNvSpPr/>
-          <p:nvPr/>
-        </p:nvSpPr>
-        <p:spPr>
-          <a:xfrm>
-            <a:off x="432000" y="1188000"/>
-            <a:ext cx="5832000" cy="4320000"/>
-          </a:xfrm>
-          <a:prstGeom prst="rect">
-            <a:avLst/>
-          </a:prstGeom>
-          <a:solidFill>
-            <a:srgbClr val="F2F2F2"/>
-          </a:solidFill>
-          <a:ln>
-            <a:noFill/>
-          </a:ln>
-          <a:effectLst/>
-        </p:spPr>
-        <p:style>
-          <a:lnRef idx="1">
-            <a:schemeClr val="accent1"/>
-          </a:lnRef>
-          <a:fillRef idx="3">
-            <a:schemeClr val="accent1"/>
-          </a:fillRef>
-          <a:effectRef idx="2">
-            <a:schemeClr val="accent1"/>
-          </a:effectRef>
-          <a:fontRef idx="minor">
-            <a:schemeClr val="lt1"/>
-          </a:fontRef>
-        </p:style>
-        <p:txBody>
-          <a:bodyPr rtlCol="0" anchor="ctr" wrap="square"/>
-          <a:lstStyle/>
-          <a:p>
-            <a:pPr algn="ctr"/>
-            <a:r>
-              <a:rPr sz="1150">
-                <a:solidFill>
-                  <a:srgbClr val="222222"/>
-                </a:solidFill>
-                <a:latin typeface="Consolas"/>
-              </a:rPr>
-              <a:t># MẸO THEN CHỐT: dự báo Δ, không dự báo mức giá</a:t>
-            </a:r>
-          </a:p>
-          <a:p>
-            <a:r>
-              <a:rPr sz="1150">
-                <a:solidFill>
-                  <a:srgbClr val="222222"/>
-                </a:solidFill>
-                <a:latin typeface="Consolas"/>
-              </a:rPr>
-              <a:t># mức giá thua naive 2–5× (train giá thấp, test giá cao)</a:t>
-            </a:r>
-          </a:p>
-          <a:p>
-            <a:r>
-              <a:rPr sz="1150">
-                <a:solidFill>
-                  <a:srgbClr val="222222"/>
-                </a:solidFill>
-                <a:latin typeface="Consolas"/>
-              </a:rPr>
-              <a:t/>
-            </a:r>
-          </a:p>
-          <a:p>
-            <a:r>
-              <a:rPr sz="1150">
-                <a:solidFill>
-                  <a:srgbClr val="222222"/>
-                </a:solidFill>
-                <a:latin typeface="Consolas"/>
-              </a:rPr>
-              <a:t>d_hat = model(X_test)              # Δ̂ scaled (nb 01)</a:t>
-            </a:r>
-          </a:p>
-          <a:p>
-            <a:r>
-              <a:rPr sz="1150">
-                <a:solidFill>
-                  <a:srgbClr val="222222"/>
-                </a:solidFill>
-                <a:latin typeface="Consolas"/>
-              </a:rPr>
-              <a:t>d_hat = np.clip(d_hat, -BOUND, BOUND)</a:t>
-            </a:r>
-          </a:p>
-          <a:p>
-            <a:r>
-              <a:rPr sz="1150">
-                <a:solidFill>
-                  <a:srgbClr val="222222"/>
-                </a:solidFill>
-                <a:latin typeface="Consolas"/>
-              </a:rPr>
-              <a:t>        # chặn dự báo trong cùng biên ±3σ</a:t>
-            </a:r>
-          </a:p>
-          <a:p>
-            <a:r>
-              <a:rPr sz="1150">
-                <a:solidFill>
-                  <a:srgbClr val="222222"/>
-                </a:solidFill>
-                <a:latin typeface="Consolas"/>
-              </a:rPr>
-              <a:t/>
-            </a:r>
-          </a:p>
-          <a:p>
-            <a:r>
-              <a:rPr sz="1150">
-                <a:solidFill>
-                  <a:srgbClr val="222222"/>
-                </a:solidFill>
-                <a:latin typeface="Consolas"/>
-              </a:rPr>
-              <a:t>z_prev = z[cuối_cửa_sổ, 0]         # giá "hôm nay"</a:t>
-            </a:r>
-          </a:p>
-          <a:p>
-            <a:r>
-              <a:rPr sz="1150">
-                <a:solidFill>
-                  <a:srgbClr val="222222"/>
-                </a:solidFill>
-                <a:latin typeface="Consolas"/>
-              </a:rPr>
-              <a:t>p_hat  = inverse_gold(z_prev + d_hat)</a:t>
-            </a:r>
-          </a:p>
-          <a:p>
-            <a:r>
-              <a:rPr sz="1150">
-                <a:solidFill>
-                  <a:srgbClr val="222222"/>
-                </a:solidFill>
-                <a:latin typeface="Consolas"/>
-              </a:rPr>
-              <a:t>        # giá mai = giá nay + Δ̂ → inverse → USD</a:t>
-            </a:r>
-          </a:p>
-          <a:p>
-            <a:r>
-              <a:rPr sz="1150">
-                <a:solidFill>
-                  <a:srgbClr val="222222"/>
-                </a:solidFill>
-                <a:latin typeface="Consolas"/>
-              </a:rPr>
-              <a:t/>
-            </a:r>
-          </a:p>
-          <a:p>
-            <a:r>
-              <a:rPr sz="1150">
-                <a:solidFill>
-                  <a:srgbClr val="222222"/>
-                </a:solidFill>
-                <a:latin typeface="Consolas"/>
-              </a:rPr>
-              <a:t>def inverse_gold(y_s, scaler):     # đệm cột bạc = 0</a:t>
-            </a:r>
-          </a:p>
-          <a:p>
-            <a:r>
-              <a:rPr sz="1150">
-                <a:solidFill>
-                  <a:srgbClr val="222222"/>
-                </a:solidFill>
-                <a:latin typeface="Consolas"/>
-              </a:rPr>
-              <a:t>    d = np.zeros((len(y_s), 2))    # rồi inverse_transform</a:t>
-            </a:r>
-          </a:p>
-          <a:p>
-            <a:r>
-              <a:rPr sz="1150">
-                <a:solidFill>
-                  <a:srgbClr val="222222"/>
-                </a:solidFill>
-                <a:latin typeface="Consolas"/>
-              </a:rPr>
-              <a:t>    d[:, 0] = y_s                  # lấy cột vàng</a:t>
-            </a:r>
-          </a:p>
-          <a:p>
-            <a:r>
-              <a:rPr sz="1150">
-                <a:solidFill>
-                  <a:srgbClr val="222222"/>
-                </a:solidFill>
-                <a:latin typeface="Consolas"/>
-              </a:rPr>
-              <a:t>    return scaler.inverse_transform(d)[:, 0]</a:t>
-            </a:r>
-          </a:p>
-        </p:txBody>
-      </p:sp>
-      <p:graphicFrame>
-        <p:nvGraphicFramePr>
-          <p:cNvPr id="5" name="Table 4"/>
-          <p:cNvGraphicFramePr>
-            <a:graphicFrameLocks noGrp="1"/>
-          </p:cNvGraphicFramePr>
-          <p:nvPr/>
-        </p:nvGraphicFramePr>
-        <p:xfrm>
-          <a:off x="6552000" y="1224000"/>
-          <a:ext cx="5183998" cy="1800000"/>
-        </p:xfrm>
-        <a:graphic>
-          <a:graphicData uri="http://schemas.openxmlformats.org/drawingml/2006/table">
-            <a:tbl>
-              <a:tblPr firstRow="1" bandRow="1">
-                <a:tableStyleId>{5C22544A-7EE6-4342-B048-85BDC9FD1C3A}</a:tableStyleId>
-              </a:tblPr>
-              <a:tblGrid>
-                <a:gridCol w="1993846"/>
-                <a:gridCol w="1063384"/>
-                <a:gridCol w="1063384"/>
-                <a:gridCol w="1063384"/>
-              </a:tblGrid>
-              <a:tr h="600000">
-                <a:tc>
-                  <a:txBody>
-                    <a:bodyPr/>
-                    <a:lstStyle/>
-                    <a:p>
-                      <a:r>
-                        <a:rPr sz="1300" b="1">
-                          <a:solidFill>
-                            <a:srgbClr val="FFFFFF"/>
-                          </a:solidFill>
-                        </a:rPr>
-                        <a:t>Tập dữ liệu (RMSE test)</a:t>
-                      </a:r>
-                    </a:p>
-                  </a:txBody>
-                  <a:tcPr>
-                    <a:solidFill>
-                      <a:srgbClr val="1E3A8A"/>
-                    </a:solidFill>
-                  </a:tcPr>
-                </a:tc>
-                <a:tc>
-                  <a:txBody>
-                    <a:bodyPr/>
-                    <a:lstStyle/>
-                    <a:p>
-                      <a:r>
-                        <a:rPr sz="1300" b="1">
-                          <a:solidFill>
-                            <a:srgbClr val="FFFFFF"/>
-                          </a:solidFill>
-                        </a:rPr>
-                        <a:t>PyTorch</a:t>
-                      </a:r>
-                    </a:p>
-                  </a:txBody>
-                  <a:tcPr>
-                    <a:solidFill>
-                      <a:srgbClr val="1E3A8A"/>
-                    </a:solidFill>
-                  </a:tcPr>
-                </a:tc>
-                <a:tc>
-                  <a:txBody>
-                    <a:bodyPr/>
-                    <a:lstStyle/>
-                    <a:p>
-                      <a:r>
-                        <a:rPr sz="1300" b="1">
-                          <a:solidFill>
-                            <a:srgbClr val="FFFFFF"/>
-                          </a:solidFill>
-                        </a:rPr>
-                        <a:t>Keras</a:t>
-                      </a:r>
-                    </a:p>
-                  </a:txBody>
-                  <a:tcPr>
-                    <a:solidFill>
-                      <a:srgbClr val="1E3A8A"/>
-                    </a:solidFill>
-                  </a:tcPr>
-                </a:tc>
-                <a:tc>
-                  <a:txBody>
-                    <a:bodyPr/>
-                    <a:lstStyle/>
-                    <a:p>
-                      <a:r>
-                        <a:rPr sz="1300" b="1">
-                          <a:solidFill>
-                            <a:srgbClr val="FFFFFF"/>
-                          </a:solidFill>
-                        </a:rPr>
-                        <a:t>Naive</a:t>
-                      </a:r>
-                    </a:p>
-                  </a:txBody>
-                  <a:tcPr>
-                    <a:solidFill>
-                      <a:srgbClr val="1E3A8A"/>
-                    </a:solidFill>
-                  </a:tcPr>
-                </a:tc>
-              </a:tr>
-              <a:tr h="600000">
-                <a:tc>
-                  <a:txBody>
-                    <a:bodyPr/>
-                    <a:lstStyle/>
-                    <a:p>
-                      <a:r>
-                        <a:rPr sz="1300" b="0">
-                          <a:solidFill>
-                            <a:srgbClr val="222222"/>
-                          </a:solidFill>
-                        </a:rPr>
-                        <a:t>Giá vàng (Gold &amp; Silver)</a:t>
-                      </a:r>
-                    </a:p>
-                  </a:txBody>
-                  <a:tcPr>
-                    <a:solidFill>
-                      <a:srgbClr val="EEF2FA"/>
-                    </a:solidFill>
-                  </a:tcPr>
-                </a:tc>
-                <a:tc>
-                  <a:txBody>
-                    <a:bodyPr/>
-                    <a:lstStyle/>
-                    <a:p>
-                      <a:r>
-                        <a:rPr sz="1300" b="0">
-                          <a:solidFill>
-                            <a:srgbClr val="222222"/>
-                          </a:solidFill>
-                        </a:rPr>
-                        <a:t>15.45</a:t>
-                      </a:r>
-                    </a:p>
-                  </a:txBody>
-                  <a:tcPr>
-                    <a:solidFill>
-                      <a:srgbClr val="EEF2FA"/>
-                    </a:solidFill>
-                  </a:tcPr>
-                </a:tc>
-                <a:tc>
-                  <a:txBody>
-                    <a:bodyPr/>
-                    <a:lstStyle/>
-                    <a:p>
-                      <a:r>
-                        <a:rPr sz="1300" b="0">
-                          <a:solidFill>
-                            <a:srgbClr val="222222"/>
-                          </a:solidFill>
-                        </a:rPr>
-                        <a:t>16.42</a:t>
-                      </a:r>
-                    </a:p>
-                  </a:txBody>
-                  <a:tcPr>
-                    <a:solidFill>
-                      <a:srgbClr val="EEF2FA"/>
-                    </a:solidFill>
-                  </a:tcPr>
-                </a:tc>
-                <a:tc>
-                  <a:txBody>
-                    <a:bodyPr/>
-                    <a:lstStyle/>
-                    <a:p>
-                      <a:r>
-                        <a:rPr sz="1300" b="0">
-                          <a:solidFill>
-                            <a:srgbClr val="222222"/>
-                          </a:solidFill>
-                        </a:rPr>
-                        <a:t>15.48</a:t>
-                      </a:r>
-                    </a:p>
-                  </a:txBody>
-                  <a:tcPr>
-                    <a:solidFill>
-                      <a:srgbClr val="EEF2FA"/>
-                    </a:solidFill>
-                  </a:tcPr>
-                </a:tc>
-              </a:tr>
-              <a:tr h="600000">
-                <a:tc>
-                  <a:txBody>
-                    <a:bodyPr/>
-                    <a:lstStyle/>
-                    <a:p>
-                      <a:r>
-                        <a:rPr sz="1300" b="0">
-                          <a:solidFill>
-                            <a:srgbClr val="222222"/>
-                          </a:solidFill>
-                        </a:rPr>
-                        <a:t>Cổ phiếu AMZN</a:t>
-                      </a:r>
-                    </a:p>
-                  </a:txBody>
-                  <a:tcPr>
-                    <a:solidFill>
-                      <a:srgbClr val="FFFFFF"/>
-                    </a:solidFill>
-                  </a:tcPr>
-                </a:tc>
-                <a:tc>
-                  <a:txBody>
-                    <a:bodyPr/>
-                    <a:lstStyle/>
-                    <a:p>
-                      <a:r>
-                        <a:rPr sz="1300" b="0">
-                          <a:solidFill>
-                            <a:srgbClr val="222222"/>
-                          </a:solidFill>
-                        </a:rPr>
-                        <a:t>3.13</a:t>
-                      </a:r>
-                    </a:p>
-                  </a:txBody>
-                  <a:tcPr>
-                    <a:solidFill>
-                      <a:srgbClr val="FFFFFF"/>
-                    </a:solidFill>
-                  </a:tcPr>
-                </a:tc>
-                <a:tc>
-                  <a:txBody>
-                    <a:bodyPr/>
-                    <a:lstStyle/>
-                    <a:p>
-                      <a:r>
-                        <a:rPr sz="1300" b="0">
-                          <a:solidFill>
-                            <a:srgbClr val="222222"/>
-                          </a:solidFill>
-                        </a:rPr>
-                        <a:t>3.18</a:t>
-                      </a:r>
-                    </a:p>
-                  </a:txBody>
-                  <a:tcPr>
-                    <a:solidFill>
-                      <a:srgbClr val="FFFFFF"/>
-                    </a:solidFill>
-                  </a:tcPr>
-                </a:tc>
-                <a:tc>
-                  <a:txBody>
-                    <a:bodyPr/>
-                    <a:lstStyle/>
-                    <a:p>
-                      <a:r>
-                        <a:rPr sz="1300" b="0">
-                          <a:solidFill>
-                            <a:srgbClr val="222222"/>
-                          </a:solidFill>
-                        </a:rPr>
-                        <a:t>3.14</a:t>
-                      </a:r>
-                    </a:p>
-                  </a:txBody>
-                  <a:tcPr>
-                    <a:solidFill>
-                      <a:srgbClr val="FFFFFF"/>
-                    </a:solidFill>
-                  </a:tcPr>
-                </a:tc>
-              </a:tr>
-            </a:tbl>
-          </a:graphicData>
-        </a:graphic>
-      </p:graphicFrame>
-      <p:sp>
-        <p:nvSpPr>
-          <p:cNvPr id="6" name="TextBox 5"/>
-          <p:cNvSpPr txBox="1"/>
-          <p:nvPr/>
-        </p:nvSpPr>
-        <p:spPr>
-          <a:xfrm>
-            <a:off x="6552000" y="3240000"/>
-            <a:ext cx="5184000" cy="2160000"/>
-          </a:xfrm>
-          <a:prstGeom prst="rect">
-            <a:avLst/>
-          </a:prstGeom>
-          <a:noFill/>
-        </p:spPr>
-        <p:txBody>
-          <a:bodyPr wrap="square">
-            <a:spAutoFit/>
-          </a:bodyPr>
-          <a:lstStyle/>
-          <a:p>
-            <a:pPr algn="l"/>
-            <a:r>
-              <a:rPr sz="1400" b="1">
-                <a:solidFill>
-                  <a:srgbClr val="1E3A8A"/>
-                </a:solidFill>
-                <a:latin typeface="Calibri"/>
-              </a:rPr>
-              <a:t>Naive = dự báo “ngày mai giống hôm nay”.</a:t>
-            </a:r>
-          </a:p>
-          <a:p>
-            <a:pPr algn="l"/>
-            <a:r>
-              <a:rPr sz="1400" b="1">
-                <a:solidFill>
-                  <a:srgbClr val="1E3A8A"/>
-                </a:solidFill>
-                <a:latin typeface="Calibri"/>
-              </a:rPr>
-              <a:t>RNN thắng baseline này trên cả 2 tập (R² ≥ 0.99,</a:t>
-            </a:r>
-          </a:p>
-          <a:p>
-            <a:pPr algn="l"/>
-            <a:r>
-              <a:rPr sz="1400" b="1">
-                <a:solidFill>
-                  <a:srgbClr val="1E3A8A"/>
-                </a:solidFill>
-                <a:latin typeface="Calibri"/>
-              </a:rPr>
-              <a:t>MAPE 0.6–1.8%) — chỉ khi dự báo Δ residual.</a:t>
-            </a:r>
-          </a:p>
-          <a:p>
-            <a:pPr algn="l"/>
-            <a:r>
-              <a:rPr sz="1400" b="1">
-                <a:solidFill>
-                  <a:srgbClr val="1E3A8A"/>
-                </a:solidFill>
-                <a:latin typeface="Calibri"/>
-              </a:rPr>
-              <a:t/>
-            </a:r>
-          </a:p>
-          <a:p>
-            <a:pPr algn="l"/>
-            <a:r>
-              <a:rPr sz="1400" b="1">
-                <a:solidFill>
-                  <a:srgbClr val="1E3A8A"/>
-                </a:solidFill>
-                <a:latin typeface="Calibri"/>
-              </a:rPr>
-              <a:t>Dự báo thẳng MỨC GIÁ: RMSE thua naive 2–5×</a:t>
-            </a:r>
-          </a:p>
-          <a:p>
-            <a:pPr algn="l"/>
-            <a:r>
-              <a:rPr sz="1400" b="1">
-                <a:solidFill>
-                  <a:srgbClr val="1E3A8A"/>
-                </a:solidFill>
-                <a:latin typeface="Calibri"/>
-              </a:rPr>
-              <a:t>vì network bị kéo về trung bình giá train.</a:t>
-            </a:r>
-          </a:p>
-          <a:p>
-            <a:pPr algn="l"/>
-            <a:r>
-              <a:rPr sz="1400" b="1">
-                <a:solidFill>
-                  <a:srgbClr val="1E3A8A"/>
-                </a:solidFill>
-                <a:latin typeface="Calibri"/>
-              </a:rPr>
-              <a:t>Kỹ thuật Δ nhất quán ở cả 4 notebook.</a:t>
-            </a:r>
-          </a:p>
-        </p:txBody>
-      </p:sp>
-    </p:spTree>
-  </p:cSld>
-  <p:clrMapOvr>
-    <a:masterClrMapping/>
-  </p:clrMapOvr>
-</p:sld>
-</file>
-
-<file path=ppt/slides/slide9.xml><?xml version="1.0" encoding="utf-8"?>
-<p:sld xmlns:a="http://schemas.openxmlformats.org/drawingml/2006/main" xmlns:p="http://schemas.openxmlformats.org/presentationml/2006/main" xmlns:r="http://schemas.openxmlformats.org/officeDocument/2006/relationships">
-  <p:cSld>
-    <p:spTree>
-      <p:nvGrpSpPr>
-        <p:cNvPr id="1" name=""/>
-        <p:cNvGrpSpPr/>
-        <p:nvPr/>
-      </p:nvGrpSpPr>
-      <p:grpSpPr/>
-      <p:sp>
-        <p:nvSpPr>
-          <p:cNvPr id="2" name="Rectangle 1"/>
-          <p:cNvSpPr/>
-          <p:nvPr/>
-        </p:nvSpPr>
-        <p:spPr>
-          <a:xfrm>
-            <a:off x="0" y="0"/>
-            <a:ext cx="12193200" cy="792000"/>
-          </a:xfrm>
-          <a:prstGeom prst="rect">
-            <a:avLst/>
-          </a:prstGeom>
-          <a:solidFill>
-            <a:srgbClr val="1E3A8A"/>
-          </a:solidFill>
-          <a:ln>
-            <a:noFill/>
-          </a:ln>
-          <a:effectLst/>
-        </p:spPr>
-        <p:style>
-          <a:lnRef idx="1">
-            <a:schemeClr val="accent1"/>
-          </a:lnRef>
-          <a:fillRef idx="3">
-            <a:schemeClr val="accent1"/>
-          </a:fillRef>
-          <a:effectRef idx="2">
-            <a:schemeClr val="accent1"/>
-          </a:effectRef>
-          <a:fontRef idx="minor">
-            <a:schemeClr val="lt1"/>
-          </a:fontRef>
-        </p:style>
-        <p:txBody>
-          <a:bodyPr rtlCol="0" anchor="ctr"/>
-          <a:lstStyle/>
-          <a:p>
-            <a:pPr algn="ctr"/>
-          </a:p>
-        </p:txBody>
-      </p:sp>
-      <p:sp>
-        <p:nvSpPr>
-          <p:cNvPr id="3" name="TextBox 2"/>
-          <p:cNvSpPr txBox="1"/>
-          <p:nvPr/>
-        </p:nvSpPr>
-        <p:spPr>
-          <a:xfrm>
-            <a:off x="288000" y="125999"/>
-            <a:ext cx="11617200" cy="540000"/>
-          </a:xfrm>
-          <a:prstGeom prst="rect">
-            <a:avLst/>
-          </a:prstGeom>
-          <a:noFill/>
-        </p:spPr>
-        <p:txBody>
-          <a:bodyPr wrap="square">
-            <a:spAutoFit/>
-          </a:bodyPr>
-          <a:lstStyle/>
-          <a:p>
-            <a:pPr algn="l"/>
-            <a:r>
-              <a:rPr sz="2600" b="1">
-                <a:solidFill>
-                  <a:srgbClr val="FFFFFF"/>
-                </a:solidFill>
-                <a:latin typeface="Calibri"/>
-              </a:rPr>
-              <a:t>9. Hạn chế của RNN &amp; mô hình phát triển: LSTM, GRU</a:t>
-            </a:r>
-          </a:p>
-        </p:txBody>
-      </p:sp>
-      <p:sp>
-        <p:nvSpPr>
-          <p:cNvPr id="4" name="TextBox 3"/>
-          <p:cNvSpPr txBox="1"/>
-          <p:nvPr/>
-        </p:nvSpPr>
-        <p:spPr>
-          <a:xfrm>
-            <a:off x="432000" y="1080000"/>
-            <a:ext cx="11304000" cy="432000"/>
-          </a:xfrm>
-          <a:prstGeom prst="rect">
-            <a:avLst/>
-          </a:prstGeom>
-          <a:noFill/>
-        </p:spPr>
-        <p:txBody>
-          <a:bodyPr wrap="square">
-            <a:spAutoFit/>
-          </a:bodyPr>
-          <a:lstStyle/>
-          <a:p>
-            <a:pPr algn="l"/>
-            <a:r>
-              <a:rPr sz="1500" b="1">
-                <a:solidFill>
-                  <a:srgbClr val="222222"/>
-                </a:solidFill>
-                <a:latin typeface="Calibri"/>
-              </a:rPr>
-              <a:t>RNN đơn giản QUÊN quá khứ xa: gradient chỉ đi qua phép NHÂN U lặp lại → biến mất</a:t>
-            </a:r>
-          </a:p>
-        </p:txBody>
-      </p:sp>
-      <p:sp>
-        <p:nvSpPr>
-          <p:cNvPr id="5" name="TextBox 4"/>
-          <p:cNvSpPr txBox="1"/>
-          <p:nvPr/>
-        </p:nvSpPr>
-        <p:spPr>
-          <a:xfrm>
-            <a:off x="432000" y="1512000"/>
-            <a:ext cx="11304000" cy="432000"/>
-          </a:xfrm>
-          <a:prstGeom prst="rect">
-            <a:avLst/>
-          </a:prstGeom>
-          <a:noFill/>
-        </p:spPr>
-        <p:txBody>
-          <a:bodyPr wrap="square">
-            <a:spAutoFit/>
-          </a:bodyPr>
-          <a:lstStyle/>
-          <a:p>
-            <a:pPr algn="l"/>
-            <a:r>
-              <a:rPr sz="1500" b="0">
-                <a:solidFill>
-                  <a:srgbClr val="222222"/>
-                </a:solidFill>
-                <a:latin typeface="Calibri"/>
-              </a:rPr>
-              <a:t>•  LSTM thêm băng chuyền trí nhớ c_t: gradient đi qua phép CỘNG và cổng quên → gần như nguyên vẹn</a:t>
-            </a:r>
-          </a:p>
-        </p:txBody>
-      </p:sp>
-      <p:sp>
-        <p:nvSpPr>
-          <p:cNvPr id="6" name="Rectangle 5"/>
-          <p:cNvSpPr/>
-          <p:nvPr/>
-        </p:nvSpPr>
-        <p:spPr>
-          <a:xfrm>
-            <a:off x="432000" y="2015999"/>
-            <a:ext cx="5688000" cy="4104000"/>
-          </a:xfrm>
-          <a:prstGeom prst="rect">
-            <a:avLst/>
-          </a:prstGeom>
-          <a:solidFill>
-            <a:srgbClr val="F2F2F2"/>
-          </a:solidFill>
-          <a:ln>
-            <a:noFill/>
-          </a:ln>
-          <a:effectLst/>
-        </p:spPr>
-        <p:style>
-          <a:lnRef idx="1">
-            <a:schemeClr val="accent1"/>
-          </a:lnRef>
-          <a:fillRef idx="3">
-            <a:schemeClr val="accent1"/>
-          </a:fillRef>
-          <a:effectRef idx="2">
-            <a:schemeClr val="accent1"/>
-          </a:effectRef>
-          <a:fontRef idx="minor">
-            <a:schemeClr val="lt1"/>
-          </a:fontRef>
-        </p:style>
-        <p:txBody>
-          <a:bodyPr rtlCol="0" anchor="ctr" wrap="square"/>
-          <a:lstStyle/>
-          <a:p>
-            <a:pPr algn="ctr"/>
-            <a:r>
-              <a:rPr sz="1150">
-                <a:solidFill>
-                  <a:srgbClr val="222222"/>
-                </a:solidFill>
-                <a:latin typeface="Consolas"/>
-              </a:rPr>
-              <a:t># LSTM — 5 cổng, σ(s)=1/(1+e^(−s)) ∈ (0,1)</a:t>
-            </a:r>
-          </a:p>
-          <a:p>
-            <a:r>
-              <a:rPr sz="1150">
-                <a:solidFill>
-                  <a:srgbClr val="222222"/>
-                </a:solidFill>
-                <a:latin typeface="Consolas"/>
-              </a:rPr>
-              <a:t>f_t = σ(W_f·[h_(t−1),x_t] + b_f)</a:t>
-            </a:r>
-          </a:p>
-          <a:p>
-            <a:r>
-              <a:rPr sz="1150">
-                <a:solidFill>
-                  <a:srgbClr val="222222"/>
-                </a:solidFill>
-                <a:latin typeface="Consolas"/>
-              </a:rPr>
-              <a:t>     # cổng QUÊN: giữ lại bao nhiêu c_(t−1)</a:t>
-            </a:r>
-          </a:p>
-          <a:p>
-            <a:r>
-              <a:rPr sz="1150">
-                <a:solidFill>
-                  <a:srgbClr val="222222"/>
-                </a:solidFill>
-                <a:latin typeface="Consolas"/>
-              </a:rPr>
-              <a:t>i_t = σ(W_i·[h_(t−1),x_t] + b_i)</a:t>
-            </a:r>
-          </a:p>
-          <a:p>
-            <a:r>
-              <a:rPr sz="1150">
-                <a:solidFill>
-                  <a:srgbClr val="222222"/>
-                </a:solidFill>
-                <a:latin typeface="Consolas"/>
-              </a:rPr>
-              <a:t>     # cổng GHI: nhận bao nhiêu tin mới</a:t>
-            </a:r>
-          </a:p>
-          <a:p>
-            <a:r>
-              <a:rPr sz="1150">
-                <a:solidFill>
-                  <a:srgbClr val="222222"/>
-                </a:solidFill>
-                <a:latin typeface="Consolas"/>
-              </a:rPr>
-              <a:t>c̃_t = tanh(W_c·[h_(t−1),x_t] + b_c)</a:t>
-            </a:r>
-          </a:p>
-          <a:p>
-            <a:r>
-              <a:rPr sz="1150">
-                <a:solidFill>
-                  <a:srgbClr val="222222"/>
-                </a:solidFill>
-                <a:latin typeface="Consolas"/>
-              </a:rPr>
-              <a:t>     # nội dung mới đề xuất</a:t>
-            </a:r>
-          </a:p>
-          <a:p>
-            <a:r>
-              <a:rPr sz="1150">
-                <a:solidFill>
-                  <a:srgbClr val="222222"/>
-                </a:solidFill>
-                <a:latin typeface="Consolas"/>
-              </a:rPr>
-              <a:t>c_t = f_t ⊙ c_(t−1) + i_t ⊙ c̃_t</a:t>
-            </a:r>
-          </a:p>
-          <a:p>
-            <a:r>
-              <a:rPr sz="1150">
-                <a:solidFill>
-                  <a:srgbClr val="222222"/>
-                </a:solidFill>
-                <a:latin typeface="Consolas"/>
-              </a:rPr>
-              <a:t>     # BĂNG CHUYỀN trí nhớ dài hạn</a:t>
-            </a:r>
-          </a:p>
-          <a:p>
-            <a:r>
-              <a:rPr sz="1150">
-                <a:solidFill>
-                  <a:srgbClr val="222222"/>
-                </a:solidFill>
-                <a:latin typeface="Consolas"/>
-              </a:rPr>
-              <a:t>o_t = σ(W_o·[h_(t−1),x_t] + b_o)</a:t>
-            </a:r>
-          </a:p>
-          <a:p>
-            <a:r>
-              <a:rPr sz="1150">
-                <a:solidFill>
-                  <a:srgbClr val="222222"/>
-                </a:solidFill>
-                <a:latin typeface="Consolas"/>
-              </a:rPr>
-              <a:t>     # cổng XUẤT: lộ bao nhiêu ra ngoài</a:t>
-            </a:r>
-          </a:p>
-          <a:p>
-            <a:r>
-              <a:rPr sz="1150">
-                <a:solidFill>
-                  <a:srgbClr val="222222"/>
-                </a:solidFill>
-                <a:latin typeface="Consolas"/>
-              </a:rPr>
-              <a:t>h_t = o_t ⊙ tanh(c_t)</a:t>
-            </a:r>
-          </a:p>
-          <a:p>
-            <a:r>
-              <a:rPr sz="1150">
-                <a:solidFill>
-                  <a:srgbClr val="222222"/>
-                </a:solidFill>
-                <a:latin typeface="Consolas"/>
-              </a:rPr>
-              <a:t>     # trí nhớ ngắn hạn đưa ra ngoài</a:t>
-            </a:r>
-          </a:p>
-          <a:p>
-            <a:r>
-              <a:rPr sz="1150">
-                <a:solidFill>
-                  <a:srgbClr val="222222"/>
-                </a:solidFill>
-                <a:latin typeface="Consolas"/>
-              </a:rPr>
-              <a:t># ⊙ = nhân từng phần tử (element-wise)</a:t>
-            </a:r>
-          </a:p>
-        </p:txBody>
-      </p:sp>
-      <p:sp>
-        <p:nvSpPr>
-          <p:cNvPr id="7" name="Rectangle 6"/>
-          <p:cNvSpPr/>
-          <p:nvPr/>
-        </p:nvSpPr>
-        <p:spPr>
-          <a:xfrm>
-            <a:off x="6372000" y="2015999"/>
-            <a:ext cx="5400000" cy="2736000"/>
-          </a:xfrm>
-          <a:prstGeom prst="rect">
-            <a:avLst/>
-          </a:prstGeom>
-          <a:solidFill>
-            <a:srgbClr val="F2F2F2"/>
-          </a:solidFill>
-          <a:ln>
-            <a:noFill/>
-          </a:ln>
-          <a:effectLst/>
-        </p:spPr>
-        <p:style>
-          <a:lnRef idx="1">
-            <a:schemeClr val="accent1"/>
-          </a:lnRef>
-          <a:fillRef idx="3">
-            <a:schemeClr val="accent1"/>
-          </a:fillRef>
-          <a:effectRef idx="2">
-            <a:schemeClr val="accent1"/>
-          </a:effectRef>
-          <a:fontRef idx="minor">
-            <a:schemeClr val="lt1"/>
-          </a:fontRef>
-        </p:style>
-        <p:txBody>
-          <a:bodyPr rtlCol="0" anchor="ctr" wrap="square"/>
-          <a:lstStyle/>
-          <a:p>
-            <a:pPr algn="ctr"/>
-            <a:r>
-              <a:rPr sz="1150">
-                <a:solidFill>
-                  <a:srgbClr val="222222"/>
-                </a:solidFill>
-                <a:latin typeface="Consolas"/>
-              </a:rPr>
-              <a:t># GRU — bản gọn: gộp quên+ghi thành 2 cổng</a:t>
-            </a:r>
-          </a:p>
-          <a:p>
-            <a:r>
-              <a:rPr sz="1150">
-                <a:solidFill>
-                  <a:srgbClr val="222222"/>
-                </a:solidFill>
-                <a:latin typeface="Consolas"/>
-              </a:rPr>
-              <a:t>z_t = σ(W_z·[h_(t−1),x_t])   # cổng CẬP NHẬT</a:t>
-            </a:r>
-          </a:p>
-          <a:p>
-            <a:r>
-              <a:rPr sz="1150">
-                <a:solidFill>
-                  <a:srgbClr val="222222"/>
-                </a:solidFill>
-                <a:latin typeface="Consolas"/>
-              </a:rPr>
-              <a:t>r_t = σ(W_r·[h_(t−1),x_t])   # cổng ĐẶT LẠI</a:t>
-            </a:r>
-          </a:p>
-          <a:p>
-            <a:r>
-              <a:rPr sz="1150">
-                <a:solidFill>
-                  <a:srgbClr val="222222"/>
-                </a:solidFill>
-                <a:latin typeface="Consolas"/>
-              </a:rPr>
-              <a:t>h̃_t = tanh(W_h·[r_t ⊙ h_(t−1), x_t])</a:t>
-            </a:r>
-          </a:p>
-          <a:p>
-            <a:r>
-              <a:rPr sz="1150">
-                <a:solidFill>
-                  <a:srgbClr val="222222"/>
-                </a:solidFill>
-                <a:latin typeface="Consolas"/>
-              </a:rPr>
-              <a:t>h_t = (1−z_t) ⊙ h_(t−1) + z_t ⊙ h̃_t</a:t>
-            </a:r>
-          </a:p>
-          <a:p>
-            <a:r>
-              <a:rPr sz="1150">
-                <a:solidFill>
-                  <a:srgbClr val="222222"/>
-                </a:solidFill>
-                <a:latin typeface="Consolas"/>
-              </a:rPr>
-              <a:t># không có c_t riêng — ít tham số ~25%</a:t>
-            </a:r>
-          </a:p>
-          <a:p>
-            <a:r>
-              <a:rPr sz="1150">
-                <a:solidFill>
-                  <a:srgbClr val="222222"/>
-                </a:solidFill>
-                <a:latin typeface="Consolas"/>
-              </a:rPr>
-              <a:t># → nhanh hơn, hiệu quả tương đương</a:t>
-            </a:r>
-          </a:p>
-        </p:txBody>
-      </p:sp>
-      <p:sp>
-        <p:nvSpPr>
-          <p:cNvPr id="8" name="Rectangle 7"/>
-          <p:cNvSpPr/>
-          <p:nvPr/>
-        </p:nvSpPr>
-        <p:spPr>
-          <a:xfrm>
-            <a:off x="6372000" y="4968000"/>
-            <a:ext cx="5400000" cy="1152000"/>
-          </a:xfrm>
-          <a:prstGeom prst="rect">
-            <a:avLst/>
-          </a:prstGeom>
-          <a:solidFill>
-            <a:srgbClr val="F2F2F2"/>
-          </a:solidFill>
-          <a:ln>
-            <a:noFill/>
-          </a:ln>
-          <a:effectLst/>
-        </p:spPr>
-        <p:style>
-          <a:lnRef idx="1">
-            <a:schemeClr val="accent1"/>
-          </a:lnRef>
-          <a:fillRef idx="3">
-            <a:schemeClr val="accent1"/>
-          </a:fillRef>
-          <a:effectRef idx="2">
-            <a:schemeClr val="accent1"/>
-          </a:effectRef>
-          <a:fontRef idx="minor">
-            <a:schemeClr val="lt1"/>
-          </a:fontRef>
-        </p:style>
-        <p:txBody>
-          <a:bodyPr rtlCol="0" anchor="ctr" wrap="square"/>
-          <a:lstStyle/>
-          <a:p>
-            <a:pPr algn="ctr"/>
-            <a:r>
-              <a:rPr sz="1150">
-                <a:solidFill>
-                  <a:srgbClr val="222222"/>
-                </a:solidFill>
-                <a:latin typeface="Consolas"/>
-              </a:rPr>
-              <a:t># chỉ cần đổi 1 DÒNG (nb 00 so sánh cả 3)</a:t>
-            </a:r>
-          </a:p>
-          <a:p>
-            <a:r>
-              <a:rPr sz="1150">
-                <a:solidFill>
-                  <a:srgbClr val="222222"/>
-                </a:solidFill>
-                <a:latin typeface="Consolas"/>
-              </a:rPr>
-              <a:t>nn.RNN (2, 64)   # thường — quên dài hạn</a:t>
-            </a:r>
-          </a:p>
-          <a:p>
-            <a:r>
-              <a:rPr sz="1150">
-                <a:solidFill>
-                  <a:srgbClr val="222222"/>
-                </a:solidFill>
-                <a:latin typeface="Consolas"/>
-              </a:rPr>
-              <a:t>nn.LSTM(2, 64)   # nhớ dài hạn (5 cổng)</a:t>
-            </a:r>
-          </a:p>
-          <a:p>
-            <a:r>
-              <a:rPr sz="1150">
-                <a:solidFill>
-                  <a:srgbClr val="222222"/>
-                </a:solidFill>
-                <a:latin typeface="Consolas"/>
-              </a:rPr>
-              <a:t>nn.GRU (2, 64)   # gọn, nhanh (2 cổng)</a:t>
-            </a:r>
-          </a:p>
-        </p:txBody>
-      </p:sp>
     </p:spTree>
   </p:cSld>
   <p:clrMapOvr>

</xml_diff>

<commit_message>
feat: deepen tanh-vs-sigmoid/relu rationale on slide 3, add 8 theory Q&A to speaker script
</commit_message>
<xml_diff>
--- a/asm06/slides/rnn.pptx
+++ b/asm06/slides/rnn.pptx
@@ -6984,8 +6984,8 @@
         </p:nvSpPr>
         <p:spPr>
           <a:xfrm>
-            <a:off x="432000" y="5544000"/>
-            <a:ext cx="11304000" cy="936000"/>
+            <a:off x="432000" y="5472000"/>
+            <a:ext cx="11304000" cy="1224000"/>
           </a:xfrm>
           <a:prstGeom prst="rect">
             <a:avLst/>
@@ -7031,6 +7031,30 @@
                 <a:latin typeface="Calibri"/>
               </a:rPr>
               <a:t>khiến gradient biến mất nhanh gấp đôi so với tanh.</a:t>
+            </a:r>
+          </a:p>
+          <a:p>
+            <a:pPr algn="l"/>
+            <a:r>
+              <a:rPr sz="1400" b="1">
+                <a:solidFill>
+                  <a:srgbClr val="1E3A8A"/>
+                </a:solidFill>
+                <a:latin typeface="Calibri"/>
+              </a:rPr>
+              <a:t>Quan hệ giữa hai hàm: tanh(z) = 2σ(2z) − 1 — chính là sigmoid kéo về tâm 0. Sigmoid ra (0,1) không âm →</a:t>
+            </a:r>
+          </a:p>
+          <a:p>
+            <a:pPr algn="l"/>
+            <a:r>
+              <a:rPr sz="1400" b="1">
+                <a:solidFill>
+                  <a:srgbClr val="1E3A8A"/>
+                </a:solidFill>
+                <a:latin typeface="Calibri"/>
+              </a:rPr>
+              <a:t>gradient của W CÙNG DẤU mỗi batch → bước cập nhật ziczac, hội tụ chậm hơn.</a:t>
             </a:r>
           </a:p>
         </p:txBody>

</xml_diff>

<commit_message>
feat: add 26-slide beamer speaker script, fix tanh-vs-sigmoid factor and c3 consistency
</commit_message>
<xml_diff>
--- a/asm06/slides/rnn.pptx
+++ b/asm06/slides/rnn.pptx
@@ -7018,7 +7018,7 @@
                 </a:solidFill>
                 <a:latin typeface="Calibri"/>
               </a:rPr>
-              <a:t>theo thời gian; (3) đạo hàm gọn 1 − tanh². ReLU không chặn dễ bùng nổ theo t; σ lệch dương và đạo hàm ≤ 0.25</a:t>
+              <a:t>theo thời gian; (3) đạo hàm gọn 1 − tanh². ReLU không chặn dễ bùng nổ theo t; σ lệch dương và đạo hàm tối đa</a:t>
             </a:r>
           </a:p>
           <a:p>
@@ -7030,7 +7030,7 @@
                 </a:solidFill>
                 <a:latin typeface="Calibri"/>
               </a:rPr>
-              <a:t>khiến gradient biến mất nhanh gấp đôi so với tanh.</a:t>
+              <a:t>0.25 — chỉ bằng 1/4 của tanh — khiến gradient biến mất nhanh gấp bốn so với tanh.</a:t>
             </a:r>
           </a:p>
           <a:p>

</xml_diff>